<commit_message>
Rebuild SNT summary slide keeping ANR base content, adding imprensa, interna and cost containment
Co-Authored-By: Claude Sonnet 5.5 <noreply@anthropic.com>
Claude-Session: https://claude.ai/code/session_01Y8xeok1NgQ689Ht8iSN8YH
</commit_message>
<xml_diff>
--- a/ANR_SNT_executivo.pptx
+++ b/ANR_SNT_executivo.pptx
@@ -108,186 +108,6 @@
     </a:lvl9pPr>
   </p:defaultTextStyle>
 </p:presentation>
-</file>
-
-<file path=ppt/charts/chart1.xml><?xml version="1.0" encoding="utf-8"?>
-<c:chartSpace xmlns:c="http://schemas.openxmlformats.org/drawingml/2006/chart" xmlns:a="http://schemas.openxmlformats.org/drawingml/2006/main" xmlns:r="http://schemas.openxmlformats.org/officeDocument/2006/relationships">
-  <c:date1904 val="0"/>
-  <c:chart>
-    <c:autoTitleDeleted val="1"/>
-    <c:plotArea>
-      <c:barChart>
-        <c:barDir val="bar"/>
-        <c:grouping val="clustered"/>
-        <c:ser>
-          <c:idx val="0"/>
-          <c:order val="0"/>
-          <c:tx>
-            <c:strRef>
-              <c:f>Sheet1!$B$1</c:f>
-              <c:strCache>
-                <c:ptCount val="1"/>
-                <c:pt idx="0">
-                  <c:v>Interações</c:v>
-                </c:pt>
-              </c:strCache>
-            </c:strRef>
-          </c:tx>
-          <c:dPt>
-            <c:idx val="0"/>
-            <c:spPr>
-              <a:solidFill>
-                <a:srgbClr val="7AAAD4"/>
-              </a:solidFill>
-            </c:spPr>
-          </c:dPt>
-          <c:dPt>
-            <c:idx val="1"/>
-            <c:spPr>
-              <a:solidFill>
-                <a:srgbClr val="7AAAD4"/>
-              </a:solidFill>
-            </c:spPr>
-          </c:dPt>
-          <c:dPt>
-            <c:idx val="2"/>
-            <c:spPr>
-              <a:solidFill>
-                <a:srgbClr val="F37919"/>
-              </a:solidFill>
-            </c:spPr>
-          </c:dPt>
-          <c:cat>
-            <c:strRef>
-              <c:f>Sheet1!$A$2:$A$4</c:f>
-              <c:strCache>
-                <c:ptCount val="3"/>
-                <c:pt idx="0">
-                  <c:v>Virada MFA</c:v>
-                </c:pt>
-                <c:pt idx="1">
-                  <c:v>Semana do Cliente</c:v>
-                </c:pt>
-                <c:pt idx="2">
-                  <c:v>Semana do Trânsito</c:v>
-                </c:pt>
-              </c:strCache>
-            </c:strRef>
-          </c:cat>
-          <c:val>
-            <c:numRef>
-              <c:f>Sheet1!$B$2:$B$4</c:f>
-              <c:numCache>
-                <c:formatCode>General</c:formatCode>
-                <c:ptCount val="3"/>
-                <c:pt idx="0">
-                  <c:v>0.246</c:v>
-                </c:pt>
-                <c:pt idx="1">
-                  <c:v>0.164</c:v>
-                </c:pt>
-                <c:pt idx="2">
-                  <c:v>0.091</c:v>
-                </c:pt>
-              </c:numCache>
-            </c:numRef>
-          </c:val>
-        </c:ser>
-        <c:dLbls>
-          <c:numFmt formatCode="0.0%" sourceLinked="0"/>
-          <c:txPr>
-            <a:bodyPr/>
-            <a:lstStyle/>
-            <a:p>
-              <a:pPr>
-                <a:defRPr sz="900" b="1">
-                  <a:solidFill>
-                    <a:srgbClr val="142B52"/>
-                  </a:solidFill>
-                </a:defRPr>
-              </a:pPr>
-            </a:p>
-          </c:txPr>
-          <c:dLblPos val="outEnd"/>
-          <c:showLegendKey val="0"/>
-          <c:showVal val="1"/>
-          <c:showCatName val="0"/>
-          <c:showSerName val="0"/>
-          <c:showPercent val="0"/>
-          <c:showBubbleSize val="0"/>
-          <c:showLeaderLines val="1"/>
-        </c:dLbls>
-        <c:gapWidth val="45"/>
-        <c:axId val="-2068027336"/>
-        <c:axId val="-2113994440"/>
-      </c:barChart>
-      <c:catAx>
-        <c:axId val="-2068027336"/>
-        <c:scaling>
-          <c:orientation val="maxMin"/>
-        </c:scaling>
-        <c:delete val="0"/>
-        <c:axPos val="l"/>
-        <c:majorTickMark val="out"/>
-        <c:minorTickMark val="none"/>
-        <c:tickLblPos val="nextTo"/>
-        <c:spPr>
-          <a:ln>
-            <a:noFill/>
-          </a:ln>
-        </c:spPr>
-        <c:txPr>
-          <a:bodyPr/>
-          <a:lstStyle/>
-          <a:p>
-            <a:pPr>
-              <a:defRPr sz="900"/>
-            </a:pPr>
-          </a:p>
-        </c:txPr>
-        <c:crossAx val="-2113994440"/>
-        <c:crosses val="autoZero"/>
-        <c:auto val="1"/>
-        <c:lblAlgn val="ctr"/>
-        <c:lblOffset val="100"/>
-        <c:noMultiLvlLbl val="0"/>
-      </c:catAx>
-      <c:valAx>
-        <c:axId val="-2113994440"/>
-        <c:scaling>
-          <c:max val="0.34"/>
-          <c:min val="0.0"/>
-        </c:scaling>
-        <c:delete/>
-        <c:axPos val="b"/>
-        <c:majorTickMark val="out"/>
-        <c:minorTickMark val="none"/>
-        <c:tickLblPos val="nextTo"/>
-        <c:crossAx val="-2068027336"/>
-        <c:crosses val="autoZero"/>
-      </c:valAx>
-    </c:plotArea>
-    <c:dispBlanksAs val="gap"/>
-  </c:chart>
-  <c:txPr>
-    <a:bodyPr/>
-    <a:lstStyle/>
-    <a:p>
-      <a:pPr>
-        <a:defRPr sz="900">
-          <a:solidFill>
-            <a:srgbClr val="43597E"/>
-          </a:solidFill>
-          <a:latin typeface="Manrope"/>
-        </a:defRPr>
-      </a:pPr>
-      <a:endParaRPr lang="en-US"/>
-    </a:p>
-  </c:txPr>
-  <c:externalData r:id="rId1">
-    <c:autoUpdate val="0"/>
-  </c:externalData>
-</c:chartSpace>
 </file>
 
 <file path=ppt/notesMasters/notesMaster1.xml><?xml version="1.0" encoding="utf-8"?>
@@ -737,7 +557,7 @@
           <a:lstStyle/>
           <a:p>
             <a:r>
-              <a:t>One page SNT: Mídia on/off (ANR), Imprensa (69 inserções, 6,3 mi de alcance, recorde) e Comunicação Interna (relatório de setembro).</a:t>
+              <a:t>Quadro resumo SNT: Digital (mídia on/off), Imprensa (69 inserções, 6,3 mi de alcance, recorde), Comunicação Interna e contenção de custo (R$ 60 mil orçados, ~R$ 35 mil realizados).</a:t>
             </a:r>
           </a:p>
         </p:txBody>
@@ -4318,25 +4138,27 @@
       </p:pic>
       <p:sp>
         <p:nvSpPr>
-          <p:cNvPr id="1129" name="Headline"/>
+          <p:cNvPr id="1129" name="Tile alcance na imprensa"/>
           <p:cNvSpPr/>
           <p:nvPr/>
         </p:nvSpPr>
         <p:spPr>
           <a:xfrm>
-            <a:off x="411480" y="1097280"/>
-            <a:ext cx="11521440" cy="502920"/>
+            <a:off x="301752" y="1051560"/>
+            <a:ext cx="1819656" cy="749808"/>
           </a:xfrm>
           <a:prstGeom prst="roundRect">
             <a:avLst>
-              <a:gd name="adj" fmla="val 6000"/>
+              <a:gd name="adj" fmla="val 5000"/>
             </a:avLst>
           </a:prstGeom>
           <a:solidFill>
-            <a:srgbClr val="E6EBF3"/>
+            <a:srgbClr val="FFFFFF"/>
           </a:solidFill>
-          <a:ln>
-            <a:noFill/>
+          <a:ln w="9525">
+            <a:solidFill>
+              <a:srgbClr val="DDE2ED"/>
+            </a:solidFill>
           </a:ln>
           <a:effectLst/>
         </p:spPr>
@@ -4364,14 +4186,14 @@
       </p:sp>
       <p:sp>
         <p:nvSpPr>
-          <p:cNvPr id="1130" name="Headline texto"/>
+          <p:cNvPr id="1130" name="Big alcance na imprensa"/>
           <p:cNvSpPr txBox="1"/>
           <p:nvPr/>
         </p:nvSpPr>
         <p:spPr>
           <a:xfrm>
-            <a:off x="594360" y="1097280"/>
-            <a:ext cx="11155680" cy="502920"/>
+            <a:off x="411480" y="1088136"/>
+            <a:ext cx="1636776" cy="347472"/>
           </a:xfrm>
           <a:prstGeom prst="rect">
             <a:avLst/>
@@ -4379,47 +4201,108 @@
           <a:noFill/>
         </p:spPr>
         <p:txBody>
-          <a:bodyPr wrap="square" anchor="ctr" lIns="0" rIns="0" tIns="0" bIns="0">
+          <a:bodyPr wrap="square" anchor="t" lIns="0" rIns="0" tIns="0" bIns="0">
             <a:spAutoFit/>
           </a:bodyPr>
           <a:lstStyle/>
           <a:p>
             <a:pPr algn="l"/>
             <a:r>
-              <a:rPr sz="1250" b="1">
+              <a:rPr sz="2100" b="1">
                 <a:solidFill>
                   <a:srgbClr val="F37919"/>
                 </a:solidFill>
                 <a:latin typeface="Manrope"/>
               </a:rPr>
-              <a:t>SNT em síntese: </a:t>
-            </a:r>
-            <a:r>
-              <a:rPr sz="1250" b="0">
+              <a:t>6,3 mi</a:t>
+            </a:r>
+          </a:p>
+        </p:txBody>
+      </p:sp>
+      <p:sp>
+        <p:nvSpPr>
+          <p:cNvPr id="1131" name="Rótulo alcance na imprensa"/>
+          <p:cNvSpPr txBox="1"/>
+          <p:nvPr/>
+        </p:nvSpPr>
+        <p:spPr>
+          <a:xfrm>
+            <a:off x="411480" y="1463040"/>
+            <a:ext cx="1636776" cy="137160"/>
+          </a:xfrm>
+          <a:prstGeom prst="rect">
+            <a:avLst/>
+          </a:prstGeom>
+          <a:noFill/>
+        </p:spPr>
+        <p:txBody>
+          <a:bodyPr wrap="square" anchor="t" lIns="0" rIns="0" tIns="0" bIns="0">
+            <a:spAutoFit/>
+          </a:bodyPr>
+          <a:lstStyle/>
+          <a:p>
+            <a:pPr algn="l"/>
+            <a:r>
+              <a:rPr sz="800" b="1">
                 <a:solidFill>
                   <a:srgbClr val="142B52"/>
                 </a:solidFill>
                 <a:latin typeface="Manrope"/>
               </a:rPr>
-              <a:t>uma mensagem, quatro frentes — e a imprensa entregou o maior alcance já registrado (6,3 mi), enquanto a Comunicação Interna foi o elo menos explorado.</a:t>
-            </a:r>
-          </a:p>
-        </p:txBody>
-      </p:sp>
-      <p:sp>
-        <p:nvSpPr>
-          <p:cNvPr id="1131" name="Card IMPRENSA"/>
+              <a:t>alcance na imprensa</a:t>
+            </a:r>
+          </a:p>
+        </p:txBody>
+      </p:sp>
+      <p:sp>
+        <p:nvSpPr>
+          <p:cNvPr id="1132" name="Sub alcance na imprensa"/>
+          <p:cNvSpPr txBox="1"/>
+          <p:nvPr/>
+        </p:nvSpPr>
+        <p:spPr>
+          <a:xfrm>
+            <a:off x="411480" y="1609344"/>
+            <a:ext cx="1636776" cy="137160"/>
+          </a:xfrm>
+          <a:prstGeom prst="rect">
+            <a:avLst/>
+          </a:prstGeom>
+          <a:noFill/>
+        </p:spPr>
+        <p:txBody>
+          <a:bodyPr wrap="square" anchor="t" lIns="0" rIns="0" tIns="0" bIns="0">
+            <a:spAutoFit/>
+          </a:bodyPr>
+          <a:lstStyle/>
+          <a:p>
+            <a:pPr algn="l"/>
+            <a:r>
+              <a:rPr sz="800" b="0">
+                <a:solidFill>
+                  <a:srgbClr val="6B7894"/>
+                </a:solidFill>
+                <a:latin typeface="Manrope"/>
+              </a:rPr>
+              <a:t>maior já registrado</a:t>
+            </a:r>
+          </a:p>
+        </p:txBody>
+      </p:sp>
+      <p:sp>
+        <p:nvSpPr>
+          <p:cNvPr id="1133" name="Tile inserções na imprensa"/>
           <p:cNvSpPr/>
           <p:nvPr/>
         </p:nvSpPr>
         <p:spPr>
           <a:xfrm>
-            <a:off x="411480" y="1783080"/>
-            <a:ext cx="2743200" cy="2468880"/>
+            <a:off x="2254910" y="1051560"/>
+            <a:ext cx="1819656" cy="749808"/>
           </a:xfrm>
           <a:prstGeom prst="roundRect">
             <a:avLst>
-              <a:gd name="adj" fmla="val 6000"/>
+              <a:gd name="adj" fmla="val 5000"/>
             </a:avLst>
           </a:prstGeom>
           <a:solidFill>
@@ -4427,7 +4310,7 @@
           </a:solidFill>
           <a:ln w="9525">
             <a:solidFill>
-              <a:srgbClr val="F37919"/>
+              <a:srgbClr val="DDE2ED"/>
             </a:solidFill>
           </a:ln>
           <a:effectLst/>
@@ -4456,14 +4339,14 @@
       </p:sp>
       <p:sp>
         <p:nvSpPr>
-          <p:cNvPr id="1132" name="Título IMPRENSA"/>
+          <p:cNvPr id="1134" name="Big inserções na imprensa"/>
           <p:cNvSpPr txBox="1"/>
           <p:nvPr/>
         </p:nvSpPr>
         <p:spPr>
           <a:xfrm>
-            <a:off x="576072" y="1911095"/>
-            <a:ext cx="2414016" cy="182880"/>
+            <a:off x="2364638" y="1088136"/>
+            <a:ext cx="1636776" cy="347472"/>
           </a:xfrm>
           <a:prstGeom prst="rect">
             <a:avLst/>
@@ -4478,27 +4361,27 @@
           <a:p>
             <a:pPr algn="l"/>
             <a:r>
-              <a:rPr sz="1000" b="1">
+              <a:rPr sz="2100" b="1">
                 <a:solidFill>
                   <a:srgbClr val="F37919"/>
                 </a:solidFill>
                 <a:latin typeface="Manrope"/>
               </a:rPr>
-              <a:t>IMPRENSA</a:t>
-            </a:r>
-          </a:p>
-        </p:txBody>
-      </p:sp>
-      <p:sp>
-        <p:nvSpPr>
-          <p:cNvPr id="1133" name="KPI alcance imprensa"/>
+              <a:t>69</a:t>
+            </a:r>
+          </a:p>
+        </p:txBody>
+      </p:sp>
+      <p:sp>
+        <p:nvSpPr>
+          <p:cNvPr id="1135" name="Rótulo inserções na imprensa"/>
           <p:cNvSpPr txBox="1"/>
           <p:nvPr/>
         </p:nvSpPr>
         <p:spPr>
           <a:xfrm>
-            <a:off x="576072" y="2167128"/>
-            <a:ext cx="2468880" cy="640080"/>
+            <a:off x="2364638" y="1463040"/>
+            <a:ext cx="1636776" cy="137160"/>
           </a:xfrm>
           <a:prstGeom prst="rect">
             <a:avLst/>
@@ -4513,27 +4396,27 @@
           <a:p>
             <a:pPr algn="l"/>
             <a:r>
-              <a:rPr sz="4000" b="1">
-                <a:solidFill>
-                  <a:srgbClr val="F37919"/>
+              <a:rPr sz="800" b="1">
+                <a:solidFill>
+                  <a:srgbClr val="142B52"/>
                 </a:solidFill>
                 <a:latin typeface="Manrope"/>
               </a:rPr>
-              <a:t>6,3 mi</a:t>
-            </a:r>
-          </a:p>
-        </p:txBody>
-      </p:sp>
-      <p:sp>
-        <p:nvSpPr>
-          <p:cNvPr id="1134" name="Rótulo alcance"/>
+              <a:t>inserções na imprensa</a:t>
+            </a:r>
+          </a:p>
+        </p:txBody>
+      </p:sp>
+      <p:sp>
+        <p:nvSpPr>
+          <p:cNvPr id="1136" name="Sub inserções na imprensa"/>
           <p:cNvSpPr txBox="1"/>
           <p:nvPr/>
         </p:nvSpPr>
         <p:spPr>
           <a:xfrm>
-            <a:off x="576072" y="2770632"/>
-            <a:ext cx="2377440" cy="182880"/>
+            <a:off x="2364638" y="1609344"/>
+            <a:ext cx="1636776" cy="137160"/>
           </a:xfrm>
           <a:prstGeom prst="rect">
             <a:avLst/>
@@ -4548,38 +4431,40 @@
           <a:p>
             <a:pPr algn="l"/>
             <a:r>
-              <a:rPr sz="950" b="0">
+              <a:rPr sz="800" b="0">
                 <a:solidFill>
                   <a:srgbClr val="6B7894"/>
                 </a:solidFill>
                 <a:latin typeface="Manrope"/>
               </a:rPr>
-              <a:t>de alcance em veículos</a:t>
-            </a:r>
-          </a:p>
-        </p:txBody>
-      </p:sp>
-      <p:sp>
-        <p:nvSpPr>
-          <p:cNvPr id="1135" name="Chip RECORDE HISTÓRICO"/>
+              <a:t>10,8 mi de alcance potencial</a:t>
+            </a:r>
+          </a:p>
+        </p:txBody>
+      </p:sp>
+      <p:sp>
+        <p:nvSpPr>
+          <p:cNvPr id="1137" name="Tile alcance digital (mídia on)"/>
           <p:cNvSpPr/>
           <p:nvPr/>
         </p:nvSpPr>
         <p:spPr>
           <a:xfrm>
-            <a:off x="576072" y="3044952"/>
-            <a:ext cx="1737360" cy="201168"/>
+            <a:off x="4208068" y="1051560"/>
+            <a:ext cx="1819656" cy="749808"/>
           </a:xfrm>
           <a:prstGeom prst="roundRect">
             <a:avLst>
-              <a:gd name="adj" fmla="val 50000"/>
+              <a:gd name="adj" fmla="val 5000"/>
             </a:avLst>
           </a:prstGeom>
           <a:solidFill>
-            <a:srgbClr val="F37919"/>
+            <a:srgbClr val="FFFFFF"/>
           </a:solidFill>
-          <a:ln>
-            <a:noFill/>
+          <a:ln w="9525">
+            <a:solidFill>
+              <a:srgbClr val="DDE2ED"/>
+            </a:solidFill>
           </a:ln>
           <a:effectLst/>
         </p:spPr>
@@ -4607,49 +4492,14 @@
       </p:sp>
       <p:sp>
         <p:nvSpPr>
-          <p:cNvPr id="1136" name="Chip texto"/>
+          <p:cNvPr id="1138" name="Big alcance digital (mídia on)"/>
           <p:cNvSpPr txBox="1"/>
           <p:nvPr/>
         </p:nvSpPr>
         <p:spPr>
           <a:xfrm>
-            <a:off x="576072" y="3044952"/>
-            <a:ext cx="1737360" cy="201168"/>
-          </a:xfrm>
-          <a:prstGeom prst="rect">
-            <a:avLst/>
-          </a:prstGeom>
-          <a:noFill/>
-        </p:spPr>
-        <p:txBody>
-          <a:bodyPr wrap="square" anchor="ctr" lIns="0" rIns="0" tIns="0" bIns="0">
-            <a:spAutoFit/>
-          </a:bodyPr>
-          <a:lstStyle/>
-          <a:p>
-            <a:pPr algn="ctr"/>
-            <a:r>
-              <a:rPr sz="900" b="1">
-                <a:solidFill>
-                  <a:srgbClr val="FFFFFF"/>
-                </a:solidFill>
-                <a:latin typeface="Manrope"/>
-              </a:rPr>
-              <a:t>RECORDE HISTÓRICO</a:t>
-            </a:r>
-          </a:p>
-        </p:txBody>
-      </p:sp>
-      <p:sp>
-        <p:nvSpPr>
-          <p:cNvPr id="1137" name="KPI inserções"/>
-          <p:cNvSpPr txBox="1"/>
-          <p:nvPr/>
-        </p:nvSpPr>
-        <p:spPr>
-          <a:xfrm>
-            <a:off x="576072" y="3355848"/>
-            <a:ext cx="1188720" cy="365760"/>
+            <a:off x="4317796" y="1088136"/>
+            <a:ext cx="1636776" cy="347472"/>
           </a:xfrm>
           <a:prstGeom prst="rect">
             <a:avLst/>
@@ -4664,27 +4514,27 @@
           <a:p>
             <a:pPr algn="l"/>
             <a:r>
-              <a:rPr sz="2200" b="1">
-                <a:solidFill>
-                  <a:srgbClr val="142B52"/>
+              <a:rPr sz="2100" b="1">
+                <a:solidFill>
+                  <a:srgbClr val="1971BA"/>
                 </a:solidFill>
                 <a:latin typeface="Manrope"/>
               </a:rPr>
-              <a:t>69</a:t>
-            </a:r>
-          </a:p>
-        </p:txBody>
-      </p:sp>
-      <p:sp>
-        <p:nvSpPr>
-          <p:cNvPr id="1138" name="Rótulo inserções"/>
+              <a:t>1,36 mi</a:t>
+            </a:r>
+          </a:p>
+        </p:txBody>
+      </p:sp>
+      <p:sp>
+        <p:nvSpPr>
+          <p:cNvPr id="1139" name="Rótulo alcance digital (mídia on)"/>
           <p:cNvSpPr txBox="1"/>
           <p:nvPr/>
         </p:nvSpPr>
         <p:spPr>
           <a:xfrm>
-            <a:off x="576072" y="3703320"/>
-            <a:ext cx="1188720" cy="182880"/>
+            <a:off x="4317796" y="1463040"/>
+            <a:ext cx="1636776" cy="137160"/>
           </a:xfrm>
           <a:prstGeom prst="rect">
             <a:avLst/>
@@ -4699,27 +4549,27 @@
           <a:p>
             <a:pPr algn="l"/>
             <a:r>
-              <a:rPr sz="950" b="0">
-                <a:solidFill>
-                  <a:srgbClr val="6B7894"/>
+              <a:rPr sz="800" b="1">
+                <a:solidFill>
+                  <a:srgbClr val="142B52"/>
                 </a:solidFill>
                 <a:latin typeface="Manrope"/>
               </a:rPr>
-              <a:t>inserções</a:t>
-            </a:r>
-          </a:p>
-        </p:txBody>
-      </p:sp>
-      <p:sp>
-        <p:nvSpPr>
-          <p:cNvPr id="1139" name="KPI potencial"/>
+              <a:t>alcance digital (mídia on)</a:t>
+            </a:r>
+          </a:p>
+        </p:txBody>
+      </p:sp>
+      <p:sp>
+        <p:nvSpPr>
+          <p:cNvPr id="1140" name="Sub alcance digital (mídia on)"/>
           <p:cNvSpPr txBox="1"/>
           <p:nvPr/>
         </p:nvSpPr>
         <p:spPr>
           <a:xfrm>
-            <a:off x="1783080" y="3355848"/>
-            <a:ext cx="1280160" cy="365760"/>
+            <a:off x="4317796" y="1609344"/>
+            <a:ext cx="1636776" cy="137160"/>
           </a:xfrm>
           <a:prstGeom prst="rect">
             <a:avLst/>
@@ -4734,66 +4584,31 @@
           <a:p>
             <a:pPr algn="l"/>
             <a:r>
-              <a:rPr sz="2200" b="1">
-                <a:solidFill>
-                  <a:srgbClr val="142B52"/>
+              <a:rPr sz="800" b="0">
+                <a:solidFill>
+                  <a:srgbClr val="6B7894"/>
                 </a:solidFill>
                 <a:latin typeface="Manrope"/>
               </a:rPr>
-              <a:t>10,8 mi</a:t>
-            </a:r>
-          </a:p>
-        </p:txBody>
-      </p:sp>
-      <p:sp>
-        <p:nvSpPr>
-          <p:cNvPr id="1140" name="Rótulo potencial"/>
-          <p:cNvSpPr txBox="1"/>
-          <p:nvPr/>
-        </p:nvSpPr>
-        <p:spPr>
-          <a:xfrm>
-            <a:off x="1783080" y="3703320"/>
-            <a:ext cx="1280160" cy="365760"/>
-          </a:xfrm>
-          <a:prstGeom prst="rect">
-            <a:avLst/>
-          </a:prstGeom>
-          <a:noFill/>
-        </p:spPr>
-        <p:txBody>
-          <a:bodyPr wrap="square" anchor="t" lIns="0" rIns="0" tIns="0" bIns="0">
-            <a:spAutoFit/>
-          </a:bodyPr>
-          <a:lstStyle/>
-          <a:p>
-            <a:pPr algn="l"/>
-            <a:r>
-              <a:rPr sz="950" b="0">
-                <a:solidFill>
-                  <a:srgbClr val="6B7894"/>
-                </a:solidFill>
-                <a:latin typeface="Manrope"/>
-              </a:rPr>
-              <a:t>alcance potencial em redes públicas</a:t>
-            </a:r>
-          </a:p>
-        </p:txBody>
-      </p:sp>
-      <p:sp>
-        <p:nvSpPr>
-          <p:cNvPr id="1141" name="Card MÍDIA ON"/>
+              <a:t>+15% vs projetado</a:t>
+            </a:r>
+          </a:p>
+        </p:txBody>
+      </p:sp>
+      <p:sp>
+        <p:nvSpPr>
+          <p:cNvPr id="1141" name="Tile cliques"/>
           <p:cNvSpPr/>
           <p:nvPr/>
         </p:nvSpPr>
         <p:spPr>
           <a:xfrm>
-            <a:off x="3337560" y="1783080"/>
-            <a:ext cx="2743200" cy="2468880"/>
+            <a:off x="6161227" y="1051560"/>
+            <a:ext cx="1819656" cy="749808"/>
           </a:xfrm>
           <a:prstGeom prst="roundRect">
             <a:avLst>
-              <a:gd name="adj" fmla="val 6000"/>
+              <a:gd name="adj" fmla="val 5000"/>
             </a:avLst>
           </a:prstGeom>
           <a:solidFill>
@@ -4830,14 +4645,14 @@
       </p:sp>
       <p:sp>
         <p:nvSpPr>
-          <p:cNvPr id="1142" name="Título MÍDIA ON"/>
+          <p:cNvPr id="1142" name="Big cliques"/>
           <p:cNvSpPr txBox="1"/>
           <p:nvPr/>
         </p:nvSpPr>
         <p:spPr>
           <a:xfrm>
-            <a:off x="3502152" y="1911095"/>
-            <a:ext cx="2414016" cy="182880"/>
+            <a:off x="6270955" y="1088136"/>
+            <a:ext cx="1636776" cy="347472"/>
           </a:xfrm>
           <a:prstGeom prst="rect">
             <a:avLst/>
@@ -4852,27 +4667,27 @@
           <a:p>
             <a:pPr algn="l"/>
             <a:r>
-              <a:rPr sz="1000" b="1">
-                <a:solidFill>
-                  <a:srgbClr val="43597E"/>
+              <a:rPr sz="2100" b="1">
+                <a:solidFill>
+                  <a:srgbClr val="1971BA"/>
                 </a:solidFill>
                 <a:latin typeface="Manrope"/>
               </a:rPr>
-              <a:t>MÍDIA ON</a:t>
-            </a:r>
-          </a:p>
-        </p:txBody>
-      </p:sp>
-      <p:sp>
-        <p:nvSpPr>
-          <p:cNvPr id="1143" name="KPI Alcance"/>
+              <a:t>29.233</a:t>
+            </a:r>
+          </a:p>
+        </p:txBody>
+      </p:sp>
+      <p:sp>
+        <p:nvSpPr>
+          <p:cNvPr id="1143" name="Rótulo cliques"/>
           <p:cNvSpPr txBox="1"/>
           <p:nvPr/>
         </p:nvSpPr>
         <p:spPr>
           <a:xfrm>
-            <a:off x="3502152" y="2167128"/>
-            <a:ext cx="1234440" cy="310896"/>
+            <a:off x="6270955" y="1463040"/>
+            <a:ext cx="1636776" cy="137160"/>
           </a:xfrm>
           <a:prstGeom prst="rect">
             <a:avLst/>
@@ -4887,27 +4702,27 @@
           <a:p>
             <a:pPr algn="l"/>
             <a:r>
-              <a:rPr sz="1700" b="1">
+              <a:rPr sz="800" b="1">
                 <a:solidFill>
                   <a:srgbClr val="142B52"/>
                 </a:solidFill>
                 <a:latin typeface="Manrope"/>
               </a:rPr>
-              <a:t>1,36 mi</a:t>
-            </a:r>
-          </a:p>
-        </p:txBody>
-      </p:sp>
-      <p:sp>
-        <p:nvSpPr>
-          <p:cNvPr id="1144" name="Rótulo Alcance"/>
+              <a:t>cliques</a:t>
+            </a:r>
+          </a:p>
+        </p:txBody>
+      </p:sp>
+      <p:sp>
+        <p:nvSpPr>
+          <p:cNvPr id="1144" name="Sub cliques"/>
           <p:cNvSpPr txBox="1"/>
           <p:nvPr/>
         </p:nvSpPr>
         <p:spPr>
           <a:xfrm>
-            <a:off x="3502152" y="2468880"/>
-            <a:ext cx="1234440" cy="164592"/>
+            <a:off x="6270955" y="1609344"/>
+            <a:ext cx="1636776" cy="137160"/>
           </a:xfrm>
           <a:prstGeom prst="rect">
             <a:avLst/>
@@ -4922,425 +4737,31 @@
           <a:p>
             <a:pPr algn="l"/>
             <a:r>
-              <a:rPr sz="900" b="0">
+              <a:rPr sz="800" b="0">
                 <a:solidFill>
                   <a:srgbClr val="6B7894"/>
                 </a:solidFill>
                 <a:latin typeface="Manrope"/>
               </a:rPr>
-              <a:t>Alcance</a:t>
-            </a:r>
-          </a:p>
-        </p:txBody>
-      </p:sp>
-      <p:sp>
-        <p:nvSpPr>
-          <p:cNvPr id="1145" name="Delta Alcance"/>
-          <p:cNvSpPr txBox="1"/>
-          <p:nvPr/>
-        </p:nvSpPr>
-        <p:spPr>
-          <a:xfrm>
-            <a:off x="3502152" y="2642616"/>
-            <a:ext cx="1234440" cy="164592"/>
-          </a:xfrm>
-          <a:prstGeom prst="rect">
-            <a:avLst/>
-          </a:prstGeom>
-          <a:noFill/>
-        </p:spPr>
-        <p:txBody>
-          <a:bodyPr wrap="square" anchor="t" lIns="0" rIns="0" tIns="0" bIns="0">
-            <a:spAutoFit/>
-          </a:bodyPr>
-          <a:lstStyle/>
-          <a:p>
-            <a:pPr algn="l"/>
-            <a:r>
-              <a:rPr sz="900" b="1">
-                <a:solidFill>
-                  <a:srgbClr val="1B7F4E"/>
-                </a:solidFill>
-                <a:latin typeface="Manrope"/>
-              </a:rPr>
-              <a:t>+15% vs proj.</a:t>
-            </a:r>
-          </a:p>
-        </p:txBody>
-      </p:sp>
-      <p:sp>
-        <p:nvSpPr>
-          <p:cNvPr id="1146" name="KPI Impressões"/>
-          <p:cNvSpPr txBox="1"/>
-          <p:nvPr/>
-        </p:nvSpPr>
-        <p:spPr>
-          <a:xfrm>
-            <a:off x="4782312" y="2167128"/>
-            <a:ext cx="1234440" cy="310896"/>
-          </a:xfrm>
-          <a:prstGeom prst="rect">
-            <a:avLst/>
-          </a:prstGeom>
-          <a:noFill/>
-        </p:spPr>
-        <p:txBody>
-          <a:bodyPr wrap="square" anchor="t" lIns="0" rIns="0" tIns="0" bIns="0">
-            <a:spAutoFit/>
-          </a:bodyPr>
-          <a:lstStyle/>
-          <a:p>
-            <a:pPr algn="l"/>
-            <a:r>
-              <a:rPr sz="1700" b="1">
-                <a:solidFill>
-                  <a:srgbClr val="142B52"/>
-                </a:solidFill>
-                <a:latin typeface="Manrope"/>
-              </a:rPr>
-              <a:t>2,45 mi</a:t>
-            </a:r>
-          </a:p>
-        </p:txBody>
-      </p:sp>
-      <p:sp>
-        <p:nvSpPr>
-          <p:cNvPr id="1147" name="Rótulo Impressões"/>
-          <p:cNvSpPr txBox="1"/>
-          <p:nvPr/>
-        </p:nvSpPr>
-        <p:spPr>
-          <a:xfrm>
-            <a:off x="4782312" y="2468880"/>
-            <a:ext cx="1234440" cy="164592"/>
-          </a:xfrm>
-          <a:prstGeom prst="rect">
-            <a:avLst/>
-          </a:prstGeom>
-          <a:noFill/>
-        </p:spPr>
-        <p:txBody>
-          <a:bodyPr wrap="square" anchor="t" lIns="0" rIns="0" tIns="0" bIns="0">
-            <a:spAutoFit/>
-          </a:bodyPr>
-          <a:lstStyle/>
-          <a:p>
-            <a:pPr algn="l"/>
-            <a:r>
-              <a:rPr sz="900" b="0">
-                <a:solidFill>
-                  <a:srgbClr val="6B7894"/>
-                </a:solidFill>
-                <a:latin typeface="Manrope"/>
-              </a:rPr>
-              <a:t>Impressões</a:t>
-            </a:r>
-          </a:p>
-        </p:txBody>
-      </p:sp>
-      <p:sp>
-        <p:nvSpPr>
-          <p:cNvPr id="1148" name="Delta Impressões"/>
-          <p:cNvSpPr txBox="1"/>
-          <p:nvPr/>
-        </p:nvSpPr>
-        <p:spPr>
-          <a:xfrm>
-            <a:off x="4782312" y="2642616"/>
-            <a:ext cx="1234440" cy="164592"/>
-          </a:xfrm>
-          <a:prstGeom prst="rect">
-            <a:avLst/>
-          </a:prstGeom>
-          <a:noFill/>
-        </p:spPr>
-        <p:txBody>
-          <a:bodyPr wrap="square" anchor="t" lIns="0" rIns="0" tIns="0" bIns="0">
-            <a:spAutoFit/>
-          </a:bodyPr>
-          <a:lstStyle/>
-          <a:p>
-            <a:pPr algn="l"/>
-            <a:r>
-              <a:rPr sz="900" b="1">
-                <a:solidFill>
-                  <a:srgbClr val="F37919"/>
-                </a:solidFill>
-                <a:latin typeface="Manrope"/>
-              </a:rPr>
-              <a:t>−33% vs proj.</a:t>
-            </a:r>
-          </a:p>
-        </p:txBody>
-      </p:sp>
-      <p:sp>
-        <p:nvSpPr>
-          <p:cNvPr id="1149" name="KPI Cliques"/>
-          <p:cNvSpPr txBox="1"/>
-          <p:nvPr/>
-        </p:nvSpPr>
-        <p:spPr>
-          <a:xfrm>
-            <a:off x="3502152" y="3035808"/>
-            <a:ext cx="1234440" cy="310896"/>
-          </a:xfrm>
-          <a:prstGeom prst="rect">
-            <a:avLst/>
-          </a:prstGeom>
-          <a:noFill/>
-        </p:spPr>
-        <p:txBody>
-          <a:bodyPr wrap="square" anchor="t" lIns="0" rIns="0" tIns="0" bIns="0">
-            <a:spAutoFit/>
-          </a:bodyPr>
-          <a:lstStyle/>
-          <a:p>
-            <a:pPr algn="l"/>
-            <a:r>
-              <a:rPr sz="1700" b="1">
-                <a:solidFill>
-                  <a:srgbClr val="142B52"/>
-                </a:solidFill>
-                <a:latin typeface="Manrope"/>
-              </a:rPr>
-              <a:t>29.233</a:t>
-            </a:r>
-          </a:p>
-        </p:txBody>
-      </p:sp>
-      <p:sp>
-        <p:nvSpPr>
-          <p:cNvPr id="1150" name="Rótulo Cliques"/>
-          <p:cNvSpPr txBox="1"/>
-          <p:nvPr/>
-        </p:nvSpPr>
-        <p:spPr>
-          <a:xfrm>
-            <a:off x="3502152" y="3337560"/>
-            <a:ext cx="1234440" cy="164592"/>
-          </a:xfrm>
-          <a:prstGeom prst="rect">
-            <a:avLst/>
-          </a:prstGeom>
-          <a:noFill/>
-        </p:spPr>
-        <p:txBody>
-          <a:bodyPr wrap="square" anchor="t" lIns="0" rIns="0" tIns="0" bIns="0">
-            <a:spAutoFit/>
-          </a:bodyPr>
-          <a:lstStyle/>
-          <a:p>
-            <a:pPr algn="l"/>
-            <a:r>
-              <a:rPr sz="900" b="0">
-                <a:solidFill>
-                  <a:srgbClr val="6B7894"/>
-                </a:solidFill>
-                <a:latin typeface="Manrope"/>
-              </a:rPr>
-              <a:t>Cliques</a:t>
-            </a:r>
-          </a:p>
-        </p:txBody>
-      </p:sp>
-      <p:sp>
-        <p:nvSpPr>
-          <p:cNvPr id="1151" name="Delta Cliques"/>
-          <p:cNvSpPr txBox="1"/>
-          <p:nvPr/>
-        </p:nvSpPr>
-        <p:spPr>
-          <a:xfrm>
-            <a:off x="3502152" y="3511296"/>
-            <a:ext cx="1234440" cy="164592"/>
-          </a:xfrm>
-          <a:prstGeom prst="rect">
-            <a:avLst/>
-          </a:prstGeom>
-          <a:noFill/>
-        </p:spPr>
-        <p:txBody>
-          <a:bodyPr wrap="square" anchor="t" lIns="0" rIns="0" tIns="0" bIns="0">
-            <a:spAutoFit/>
-          </a:bodyPr>
-          <a:lstStyle/>
-          <a:p>
-            <a:pPr algn="l"/>
-            <a:r>
-              <a:rPr sz="900" b="1">
-                <a:solidFill>
-                  <a:srgbClr val="1B7F4E"/>
-                </a:solidFill>
-                <a:latin typeface="Manrope"/>
-              </a:rPr>
-              <a:t>+26% vs proj.</a:t>
-            </a:r>
-          </a:p>
-        </p:txBody>
-      </p:sp>
-      <p:sp>
-        <p:nvSpPr>
-          <p:cNvPr id="1152" name="KPI Novos seguidores"/>
-          <p:cNvSpPr txBox="1"/>
-          <p:nvPr/>
-        </p:nvSpPr>
-        <p:spPr>
-          <a:xfrm>
-            <a:off x="4782312" y="3035808"/>
-            <a:ext cx="1234440" cy="310896"/>
-          </a:xfrm>
-          <a:prstGeom prst="rect">
-            <a:avLst/>
-          </a:prstGeom>
-          <a:noFill/>
-        </p:spPr>
-        <p:txBody>
-          <a:bodyPr wrap="square" anchor="t" lIns="0" rIns="0" tIns="0" bIns="0">
-            <a:spAutoFit/>
-          </a:bodyPr>
-          <a:lstStyle/>
-          <a:p>
-            <a:pPr algn="l"/>
-            <a:r>
-              <a:rPr sz="1700" b="1">
-                <a:solidFill>
-                  <a:srgbClr val="142B52"/>
-                </a:solidFill>
-                <a:latin typeface="Manrope"/>
-              </a:rPr>
-              <a:t>137</a:t>
-            </a:r>
-          </a:p>
-        </p:txBody>
-      </p:sp>
-      <p:sp>
-        <p:nvSpPr>
-          <p:cNvPr id="1153" name="Rótulo Novos seguidores"/>
-          <p:cNvSpPr txBox="1"/>
-          <p:nvPr/>
-        </p:nvSpPr>
-        <p:spPr>
-          <a:xfrm>
-            <a:off x="4782312" y="3337560"/>
-            <a:ext cx="1234440" cy="164592"/>
-          </a:xfrm>
-          <a:prstGeom prst="rect">
-            <a:avLst/>
-          </a:prstGeom>
-          <a:noFill/>
-        </p:spPr>
-        <p:txBody>
-          <a:bodyPr wrap="square" anchor="t" lIns="0" rIns="0" tIns="0" bIns="0">
-            <a:spAutoFit/>
-          </a:bodyPr>
-          <a:lstStyle/>
-          <a:p>
-            <a:pPr algn="l"/>
-            <a:r>
-              <a:rPr sz="900" b="0">
-                <a:solidFill>
-                  <a:srgbClr val="6B7894"/>
-                </a:solidFill>
-                <a:latin typeface="Manrope"/>
-              </a:rPr>
-              <a:t>Novos seguidores</a:t>
-            </a:r>
-          </a:p>
-        </p:txBody>
-      </p:sp>
-      <p:sp>
-        <p:nvSpPr>
-          <p:cNvPr id="1154" name="Delta Novos seguidores"/>
-          <p:cNvSpPr txBox="1"/>
-          <p:nvPr/>
-        </p:nvSpPr>
-        <p:spPr>
-          <a:xfrm>
-            <a:off x="4782312" y="3511296"/>
-            <a:ext cx="1234440" cy="164592"/>
-          </a:xfrm>
-          <a:prstGeom prst="rect">
-            <a:avLst/>
-          </a:prstGeom>
-          <a:noFill/>
-        </p:spPr>
-        <p:txBody>
-          <a:bodyPr wrap="square" anchor="t" lIns="0" rIns="0" tIns="0" bIns="0">
-            <a:spAutoFit/>
-          </a:bodyPr>
-          <a:lstStyle/>
-          <a:p>
-            <a:pPr algn="l"/>
-            <a:r>
-              <a:rPr sz="900" b="1">
-                <a:solidFill>
-                  <a:srgbClr val="1B7F4E"/>
-                </a:solidFill>
-                <a:latin typeface="Manrope"/>
-              </a:rPr>
-              <a:t>+2.640% vs proj.</a:t>
-            </a:r>
-          </a:p>
-        </p:txBody>
-      </p:sp>
-      <p:sp>
-        <p:nvSpPr>
-          <p:cNvPr id="1155" name="Invest ON"/>
-          <p:cNvSpPr txBox="1"/>
-          <p:nvPr/>
-        </p:nvSpPr>
-        <p:spPr>
-          <a:xfrm>
-            <a:off x="3502152" y="3931920"/>
-            <a:ext cx="2468880" cy="182880"/>
-          </a:xfrm>
-          <a:prstGeom prst="rect">
-            <a:avLst/>
-          </a:prstGeom>
-          <a:noFill/>
-        </p:spPr>
-        <p:txBody>
-          <a:bodyPr wrap="square" anchor="t" lIns="0" rIns="0" tIns="0" bIns="0">
-            <a:spAutoFit/>
-          </a:bodyPr>
-          <a:lstStyle/>
-          <a:p>
-            <a:pPr algn="l"/>
-            <a:r>
-              <a:rPr sz="950" b="0">
-                <a:solidFill>
-                  <a:srgbClr val="6B7894"/>
-                </a:solidFill>
-                <a:latin typeface="Manrope"/>
-              </a:rPr>
-              <a:t>Investimento líquido  </a:t>
-            </a:r>
-            <a:r>
-              <a:rPr sz="950" b="1">
-                <a:solidFill>
-                  <a:srgbClr val="142B52"/>
-                </a:solidFill>
-                <a:latin typeface="Manrope"/>
-              </a:rPr>
-              <a:t>R$ 10.539,60</a:t>
-            </a:r>
-          </a:p>
-        </p:txBody>
-      </p:sp>
-      <p:sp>
-        <p:nvSpPr>
-          <p:cNvPr id="1156" name="Card MÍDIA OFF | OOH BETIM (MG)"/>
+              <a:t>+26% vs projetado</a:t>
+            </a:r>
+          </a:p>
+        </p:txBody>
+      </p:sp>
+      <p:sp>
+        <p:nvSpPr>
+          <p:cNvPr id="1145" name="Tile leitura no ZAP (interno)"/>
           <p:cNvSpPr/>
           <p:nvPr/>
         </p:nvSpPr>
         <p:spPr>
           <a:xfrm>
-            <a:off x="6263640" y="1783080"/>
-            <a:ext cx="2743200" cy="2468880"/>
+            <a:off x="8114385" y="1051560"/>
+            <a:ext cx="1819656" cy="749808"/>
           </a:xfrm>
           <a:prstGeom prst="roundRect">
             <a:avLst>
-              <a:gd name="adj" fmla="val 6000"/>
+              <a:gd name="adj" fmla="val 5000"/>
             </a:avLst>
           </a:prstGeom>
           <a:solidFill>
@@ -5377,14 +4798,14 @@
       </p:sp>
       <p:sp>
         <p:nvSpPr>
-          <p:cNvPr id="1157" name="Título MÍDIA OFF | OOH BETIM (MG)"/>
+          <p:cNvPr id="1146" name="Big leitura no ZAP (interno)"/>
           <p:cNvSpPr txBox="1"/>
           <p:nvPr/>
         </p:nvSpPr>
         <p:spPr>
           <a:xfrm>
-            <a:off x="6428232" y="1911095"/>
-            <a:ext cx="2414016" cy="182880"/>
+            <a:off x="8224113" y="1088136"/>
+            <a:ext cx="1636776" cy="347472"/>
           </a:xfrm>
           <a:prstGeom prst="rect">
             <a:avLst/>
@@ -5399,27 +4820,27 @@
           <a:p>
             <a:pPr algn="l"/>
             <a:r>
-              <a:rPr sz="1000" b="1">
+              <a:rPr sz="2100" b="1">
                 <a:solidFill>
                   <a:srgbClr val="43597E"/>
                 </a:solidFill>
                 <a:latin typeface="Manrope"/>
               </a:rPr>
-              <a:t>MÍDIA OFF | OOH BETIM (MG)</a:t>
-            </a:r>
-          </a:p>
-        </p:txBody>
-      </p:sp>
-      <p:sp>
-        <p:nvSpPr>
-          <p:cNvPr id="1158" name="KPI pontos"/>
+              <a:t>56,5%</a:t>
+            </a:r>
+          </a:p>
+        </p:txBody>
+      </p:sp>
+      <p:sp>
+        <p:nvSpPr>
+          <p:cNvPr id="1147" name="Rótulo leitura no ZAP (interno)"/>
           <p:cNvSpPr txBox="1"/>
           <p:nvPr/>
         </p:nvSpPr>
         <p:spPr>
           <a:xfrm>
-            <a:off x="6428232" y="2167128"/>
-            <a:ext cx="1188720" cy="365760"/>
+            <a:off x="8224113" y="1463040"/>
+            <a:ext cx="1636776" cy="137160"/>
           </a:xfrm>
           <a:prstGeom prst="rect">
             <a:avLst/>
@@ -5434,27 +4855,27 @@
           <a:p>
             <a:pPr algn="l"/>
             <a:r>
-              <a:rPr sz="2600" b="1">
+              <a:rPr sz="800" b="1">
                 <a:solidFill>
                   <a:srgbClr val="142B52"/>
                 </a:solidFill>
                 <a:latin typeface="Manrope"/>
               </a:rPr>
-              <a:t>4</a:t>
-            </a:r>
-          </a:p>
-        </p:txBody>
-      </p:sp>
-      <p:sp>
-        <p:nvSpPr>
-          <p:cNvPr id="1159" name="Rótulo pontos"/>
+              <a:t>leitura no ZAP (interno)</a:t>
+            </a:r>
+          </a:p>
+        </p:txBody>
+      </p:sp>
+      <p:sp>
+        <p:nvSpPr>
+          <p:cNvPr id="1148" name="Sub leitura no ZAP (interno)"/>
           <p:cNvSpPr txBox="1"/>
           <p:nvPr/>
         </p:nvSpPr>
         <p:spPr>
           <a:xfrm>
-            <a:off x="6428232" y="2587752"/>
-            <a:ext cx="1188720" cy="329184"/>
+            <a:off x="8224113" y="1609344"/>
+            <a:ext cx="1636776" cy="137160"/>
           </a:xfrm>
           <a:prstGeom prst="rect">
             <a:avLst/>
@@ -5469,137 +4890,36 @@
           <a:p>
             <a:pPr algn="l"/>
             <a:r>
-              <a:rPr sz="900" b="0">
+              <a:rPr sz="800" b="0">
                 <a:solidFill>
                   <a:srgbClr val="6B7894"/>
                 </a:solidFill>
                 <a:latin typeface="Manrope"/>
               </a:rPr>
-              <a:t>pontos próximos à passagem em nível</a:t>
-            </a:r>
-          </a:p>
-        </p:txBody>
-      </p:sp>
-      <p:sp>
-        <p:nvSpPr>
-          <p:cNvPr id="1160" name="KPI dias"/>
-          <p:cNvSpPr txBox="1"/>
-          <p:nvPr/>
-        </p:nvSpPr>
-        <p:spPr>
-          <a:xfrm>
-            <a:off x="7680960" y="2167128"/>
-            <a:ext cx="1280160" cy="365760"/>
-          </a:xfrm>
-          <a:prstGeom prst="rect">
-            <a:avLst/>
-          </a:prstGeom>
-          <a:noFill/>
-        </p:spPr>
-        <p:txBody>
-          <a:bodyPr wrap="square" anchor="t" lIns="0" rIns="0" tIns="0" bIns="0">
-            <a:spAutoFit/>
-          </a:bodyPr>
-          <a:lstStyle/>
-          <a:p>
-            <a:pPr algn="l"/>
-            <a:r>
-              <a:rPr sz="1900" b="1">
-                <a:solidFill>
-                  <a:srgbClr val="142B52"/>
-                </a:solidFill>
-                <a:latin typeface="Manrope"/>
-              </a:rPr>
-              <a:t>20 dias</a:t>
-            </a:r>
-          </a:p>
-        </p:txBody>
-      </p:sp>
-      <p:sp>
-        <p:nvSpPr>
-          <p:cNvPr id="1161" name="Rótulo dias"/>
-          <p:cNvSpPr txBox="1"/>
-          <p:nvPr/>
-        </p:nvSpPr>
-        <p:spPr>
-          <a:xfrm>
-            <a:off x="7680960" y="2587752"/>
-            <a:ext cx="1280160" cy="329184"/>
-          </a:xfrm>
-          <a:prstGeom prst="rect">
-            <a:avLst/>
-          </a:prstGeom>
-          <a:noFill/>
-        </p:spPr>
-        <p:txBody>
-          <a:bodyPr wrap="square" anchor="t" lIns="0" rIns="0" tIns="0" bIns="0">
-            <a:spAutoFit/>
-          </a:bodyPr>
-          <a:lstStyle/>
-          <a:p>
-            <a:pPr algn="l"/>
-            <a:r>
-              <a:rPr sz="900" b="0">
-                <a:solidFill>
-                  <a:srgbClr val="6B7894"/>
-                </a:solidFill>
-                <a:latin typeface="Manrope"/>
-              </a:rPr>
-              <a:t>veiculação 15/09 a 04/10</a:t>
-            </a:r>
-          </a:p>
-        </p:txBody>
-      </p:sp>
-      <p:sp>
-        <p:nvSpPr>
-          <p:cNvPr id="1162" name="Formatos OOH"/>
-          <p:cNvSpPr txBox="1"/>
-          <p:nvPr/>
-        </p:nvSpPr>
-        <p:spPr>
-          <a:xfrm>
-            <a:off x="6428232" y="2971800"/>
-            <a:ext cx="2423160" cy="274320"/>
-          </a:xfrm>
-          <a:prstGeom prst="rect">
-            <a:avLst/>
-          </a:prstGeom>
-          <a:noFill/>
-        </p:spPr>
-        <p:txBody>
-          <a:bodyPr wrap="square" anchor="t" lIns="0" rIns="0" tIns="0" bIns="0">
-            <a:spAutoFit/>
-          </a:bodyPr>
-          <a:lstStyle/>
-          <a:p>
-            <a:pPr algn="l"/>
-            <a:r>
-              <a:rPr sz="950" b="0">
-                <a:solidFill>
-                  <a:srgbClr val="43597E"/>
-                </a:solidFill>
-                <a:latin typeface="Manrope"/>
-              </a:rPr>
-              <a:t>Painel de LED, banca de LED e outdoor, cobrindo pré, durante e pós Dia D.</a:t>
-            </a:r>
-          </a:p>
-        </p:txBody>
-      </p:sp>
-      <p:sp>
-        <p:nvSpPr>
-          <p:cNvPr id="1163" name="Divisor"/>
+              <a:t>181 interações</a:t>
+            </a:r>
+          </a:p>
+        </p:txBody>
+      </p:sp>
+      <p:sp>
+        <p:nvSpPr>
+          <p:cNvPr id="1149" name="Tile custo vs orçado"/>
           <p:cNvSpPr/>
           <p:nvPr/>
         </p:nvSpPr>
         <p:spPr>
           <a:xfrm>
-            <a:off x="6428232" y="3447288"/>
-            <a:ext cx="2414016" cy="0"/>
-          </a:xfrm>
-          <a:prstGeom prst="rect">
-            <a:avLst/>
-          </a:prstGeom>
-          <a:noFill/>
+            <a:off x="10067544" y="1051560"/>
+            <a:ext cx="1819656" cy="749808"/>
+          </a:xfrm>
+          <a:prstGeom prst="roundRect">
+            <a:avLst>
+              <a:gd name="adj" fmla="val 5000"/>
+            </a:avLst>
+          </a:prstGeom>
+          <a:solidFill>
+            <a:srgbClr val="FFFFFF"/>
+          </a:solidFill>
           <a:ln w="9525">
             <a:solidFill>
               <a:srgbClr val="DDE2ED"/>
@@ -5631,14 +4951,14 @@
       </p:sp>
       <p:sp>
         <p:nvSpPr>
-          <p:cNvPr id="1164" name="Collab"/>
+          <p:cNvPr id="1150" name="Big custo vs orçado"/>
           <p:cNvSpPr txBox="1"/>
           <p:nvPr/>
         </p:nvSpPr>
         <p:spPr>
           <a:xfrm>
-            <a:off x="6428232" y="3538728"/>
-            <a:ext cx="2468880" cy="182880"/>
+            <a:off x="10177272" y="1088136"/>
+            <a:ext cx="1636776" cy="347472"/>
           </a:xfrm>
           <a:prstGeom prst="rect">
             <a:avLst/>
@@ -5653,36 +4973,27 @@
           <a:p>
             <a:pPr algn="l"/>
             <a:r>
-              <a:rPr sz="950" b="1">
-                <a:solidFill>
-                  <a:srgbClr val="F37919"/>
+              <a:rPr sz="2100" b="1">
+                <a:solidFill>
+                  <a:srgbClr val="1B7F4E"/>
                 </a:solidFill>
                 <a:latin typeface="Manrope"/>
               </a:rPr>
-              <a:t>155 mil</a:t>
-            </a:r>
-            <a:r>
-              <a:rPr sz="950" b="0">
-                <a:solidFill>
-                  <a:srgbClr val="43597E"/>
-                </a:solidFill>
-                <a:latin typeface="Manrope"/>
-              </a:rPr>
-              <a:t> views orgânicas nos posts Collab com ANTF e operadoras</a:t>
-            </a:r>
-          </a:p>
-        </p:txBody>
-      </p:sp>
-      <p:sp>
-        <p:nvSpPr>
-          <p:cNvPr id="1165" name="Invest OFF"/>
+              <a:t>−42%</a:t>
+            </a:r>
+          </a:p>
+        </p:txBody>
+      </p:sp>
+      <p:sp>
+        <p:nvSpPr>
+          <p:cNvPr id="1151" name="Rótulo custo vs orçado"/>
           <p:cNvSpPr txBox="1"/>
           <p:nvPr/>
         </p:nvSpPr>
         <p:spPr>
           <a:xfrm>
-            <a:off x="6428232" y="3977639"/>
-            <a:ext cx="2468880" cy="182880"/>
+            <a:off x="10177272" y="1463040"/>
+            <a:ext cx="1636776" cy="137160"/>
           </a:xfrm>
           <a:prstGeom prst="rect">
             <a:avLst/>
@@ -5697,49 +5008,73 @@
           <a:p>
             <a:pPr algn="l"/>
             <a:r>
-              <a:rPr sz="950" b="0">
-                <a:solidFill>
-                  <a:srgbClr val="6B7894"/>
+              <a:rPr sz="800" b="1">
+                <a:solidFill>
+                  <a:srgbClr val="142B52"/>
                 </a:solidFill>
                 <a:latin typeface="Manrope"/>
               </a:rPr>
-              <a:t>Investimento líquido  </a:t>
-            </a:r>
-            <a:r>
-              <a:rPr sz="950" b="1">
-                <a:solidFill>
-                  <a:srgbClr val="142B52"/>
+              <a:t>custo vs orçado</a:t>
+            </a:r>
+          </a:p>
+        </p:txBody>
+      </p:sp>
+      <p:sp>
+        <p:nvSpPr>
+          <p:cNvPr id="1152" name="Sub custo vs orçado"/>
+          <p:cNvSpPr txBox="1"/>
+          <p:nvPr/>
+        </p:nvSpPr>
+        <p:spPr>
+          <a:xfrm>
+            <a:off x="10177272" y="1609344"/>
+            <a:ext cx="1636776" cy="137160"/>
+          </a:xfrm>
+          <a:prstGeom prst="rect">
+            <a:avLst/>
+          </a:prstGeom>
+          <a:noFill/>
+        </p:spPr>
+        <p:txBody>
+          <a:bodyPr wrap="square" anchor="t" lIns="0" rIns="0" tIns="0" bIns="0">
+            <a:spAutoFit/>
+          </a:bodyPr>
+          <a:lstStyle/>
+          <a:p>
+            <a:pPr algn="l"/>
+            <a:r>
+              <a:rPr sz="800" b="0">
+                <a:solidFill>
+                  <a:srgbClr val="6B7894"/>
                 </a:solidFill>
                 <a:latin typeface="Manrope"/>
               </a:rPr>
-              <a:t>R$ 5.738,01</a:t>
-            </a:r>
-          </a:p>
-        </p:txBody>
-      </p:sp>
-      <p:sp>
-        <p:nvSpPr>
-          <p:cNvPr id="1166" name="Card INTERNA"/>
+              <a:t>R$ ~35 mil de R$ 60 mil</a:t>
+            </a:r>
+          </a:p>
+        </p:txBody>
+      </p:sp>
+      <p:sp>
+        <p:nvSpPr>
+          <p:cNvPr id="1153" name="Seção DIGITAL  |  MÍDIA ON E OFF"/>
           <p:cNvSpPr/>
           <p:nvPr/>
         </p:nvSpPr>
         <p:spPr>
           <a:xfrm>
-            <a:off x="9189720" y="1783080"/>
-            <a:ext cx="2743200" cy="2468880"/>
+            <a:off x="301752" y="1892807"/>
+            <a:ext cx="7424927" cy="237744"/>
           </a:xfrm>
           <a:prstGeom prst="roundRect">
             <a:avLst>
-              <a:gd name="adj" fmla="val 6000"/>
+              <a:gd name="adj" fmla="val 30000"/>
             </a:avLst>
           </a:prstGeom>
           <a:solidFill>
-            <a:srgbClr val="FFFFFF"/>
+            <a:srgbClr val="1971BA"/>
           </a:solidFill>
-          <a:ln w="9525">
-            <a:solidFill>
-              <a:srgbClr val="DDE2ED"/>
-            </a:solidFill>
+          <a:ln>
+            <a:noFill/>
           </a:ln>
           <a:effectLst/>
         </p:spPr>
@@ -5767,14 +5102,14 @@
       </p:sp>
       <p:sp>
         <p:nvSpPr>
-          <p:cNvPr id="1167" name="Título INTERNA"/>
+          <p:cNvPr id="1154" name="Seção texto DIGITAL  |  MÍDIA ON E OFF"/>
           <p:cNvSpPr txBox="1"/>
           <p:nvPr/>
         </p:nvSpPr>
         <p:spPr>
           <a:xfrm>
-            <a:off x="9354312" y="1911095"/>
-            <a:ext cx="2414016" cy="182880"/>
+            <a:off x="411480" y="1892807"/>
+            <a:ext cx="7242047" cy="237744"/>
           </a:xfrm>
           <a:prstGeom prst="rect">
             <a:avLst/>
@@ -5782,45 +5117,47 @@
           <a:noFill/>
         </p:spPr>
         <p:txBody>
-          <a:bodyPr wrap="square" anchor="t" lIns="0" rIns="0" tIns="0" bIns="0">
+          <a:bodyPr wrap="square" anchor="ctr" lIns="0" rIns="0" tIns="0" bIns="0">
             <a:spAutoFit/>
           </a:bodyPr>
           <a:lstStyle/>
           <a:p>
             <a:pPr algn="l"/>
             <a:r>
-              <a:rPr sz="1000" b="1">
-                <a:solidFill>
-                  <a:srgbClr val="43597E"/>
+              <a:rPr sz="900" b="1">
+                <a:solidFill>
+                  <a:srgbClr val="FFFFFF"/>
                 </a:solidFill>
                 <a:latin typeface="Manrope"/>
               </a:rPr>
-              <a:t>INTERNA</a:t>
-            </a:r>
-          </a:p>
-        </p:txBody>
-      </p:sp>
-      <p:sp>
-        <p:nvSpPr>
-          <p:cNvPr id="1168" name="Chip JORNADA INTEGRADA"/>
+              <a:t>DIGITAL  |  MÍDIA ON E OFF</a:t>
+            </a:r>
+          </a:p>
+        </p:txBody>
+      </p:sp>
+      <p:sp>
+        <p:nvSpPr>
+          <p:cNvPr id="1155" name="KPI ALCANCE"/>
           <p:cNvSpPr/>
           <p:nvPr/>
         </p:nvSpPr>
         <p:spPr>
           <a:xfrm>
-            <a:off x="10378440" y="1892807"/>
-            <a:ext cx="1389888" cy="201168"/>
+            <a:off x="301752" y="2212848"/>
+            <a:ext cx="1234440" cy="694944"/>
           </a:xfrm>
           <a:prstGeom prst="roundRect">
             <a:avLst>
-              <a:gd name="adj" fmla="val 50000"/>
+              <a:gd name="adj" fmla="val 5000"/>
             </a:avLst>
           </a:prstGeom>
           <a:solidFill>
-            <a:srgbClr val="E6EBF3"/>
+            <a:srgbClr val="FFFFFF"/>
           </a:solidFill>
-          <a:ln>
-            <a:noFill/>
+          <a:ln w="9525">
+            <a:solidFill>
+              <a:srgbClr val="DDE2ED"/>
+            </a:solidFill>
           </a:ln>
           <a:effectLst/>
         </p:spPr>
@@ -5848,49 +5185,14 @@
       </p:sp>
       <p:sp>
         <p:nvSpPr>
-          <p:cNvPr id="1169" name="Chip texto"/>
+          <p:cNvPr id="1156" name="KPI rótulo ALCANCE"/>
           <p:cNvSpPr txBox="1"/>
           <p:nvPr/>
         </p:nvSpPr>
         <p:spPr>
           <a:xfrm>
-            <a:off x="10378440" y="1892807"/>
-            <a:ext cx="1389888" cy="201168"/>
-          </a:xfrm>
-          <a:prstGeom prst="rect">
-            <a:avLst/>
-          </a:prstGeom>
-          <a:noFill/>
-        </p:spPr>
-        <p:txBody>
-          <a:bodyPr wrap="square" anchor="ctr" lIns="0" rIns="0" tIns="0" bIns="0">
-            <a:spAutoFit/>
-          </a:bodyPr>
-          <a:lstStyle/>
-          <a:p>
-            <a:pPr algn="ctr"/>
-            <a:r>
-              <a:rPr sz="900" b="1">
-                <a:solidFill>
-                  <a:srgbClr val="43597E"/>
-                </a:solidFill>
-                <a:latin typeface="Manrope"/>
-              </a:rPr>
-              <a:t>JORNADA INTEGRADA</a:t>
-            </a:r>
-          </a:p>
-        </p:txBody>
-      </p:sp>
-      <p:sp>
-        <p:nvSpPr>
-          <p:cNvPr id="1170" name="Canal E-MAIL MKT"/>
-          <p:cNvSpPr txBox="1"/>
-          <p:nvPr/>
-        </p:nvSpPr>
-        <p:spPr>
-          <a:xfrm>
-            <a:off x="9354312" y="2194560"/>
-            <a:ext cx="1280160" cy="146304"/>
+            <a:off x="393192" y="2276856"/>
+            <a:ext cx="1097280" cy="109728"/>
           </a:xfrm>
           <a:prstGeom prst="rect">
             <a:avLst/>
@@ -5905,27 +5207,27 @@
           <a:p>
             <a:pPr algn="l"/>
             <a:r>
-              <a:rPr sz="850" b="1">
-                <a:solidFill>
-                  <a:srgbClr val="43597E"/>
+              <a:rPr sz="700" b="1">
+                <a:solidFill>
+                  <a:srgbClr val="6B7894"/>
                 </a:solidFill>
                 <a:latin typeface="Manrope"/>
               </a:rPr>
-              <a:t>E-MAIL MKT</a:t>
-            </a:r>
-          </a:p>
-        </p:txBody>
-      </p:sp>
-      <p:sp>
-        <p:nvSpPr>
-          <p:cNvPr id="1171" name="KPI E-MAIL MKT"/>
+              <a:t>ALCANCE</a:t>
+            </a:r>
+          </a:p>
+        </p:txBody>
+      </p:sp>
+      <p:sp>
+        <p:nvSpPr>
+          <p:cNvPr id="1157" name="KPI valor ALCANCE"/>
           <p:cNvSpPr txBox="1"/>
           <p:nvPr/>
         </p:nvSpPr>
         <p:spPr>
           <a:xfrm>
-            <a:off x="9354312" y="2331720"/>
-            <a:ext cx="1188720" cy="292608"/>
+            <a:off x="393192" y="2414016"/>
+            <a:ext cx="1097280" cy="228600"/>
           </a:xfrm>
           <a:prstGeom prst="rect">
             <a:avLst/>
@@ -5940,47 +5242,75 @@
           <a:p>
             <a:pPr algn="l"/>
             <a:r>
-              <a:rPr sz="1600" b="1">
+              <a:rPr sz="1300" b="1">
                 <a:solidFill>
                   <a:srgbClr val="142B52"/>
                 </a:solidFill>
                 <a:latin typeface="Manrope"/>
               </a:rPr>
-              <a:t>16,7%</a:t>
-            </a:r>
-            <a:r>
-              <a:rPr sz="900" b="0">
-                <a:solidFill>
-                  <a:srgbClr val="6B7894"/>
+              <a:t>1.360.593</a:t>
+            </a:r>
+          </a:p>
+        </p:txBody>
+      </p:sp>
+      <p:sp>
+        <p:nvSpPr>
+          <p:cNvPr id="1158" name="KPI delta ALCANCE"/>
+          <p:cNvSpPr txBox="1"/>
+          <p:nvPr/>
+        </p:nvSpPr>
+        <p:spPr>
+          <a:xfrm>
+            <a:off x="393192" y="2688336"/>
+            <a:ext cx="1097280" cy="128016"/>
+          </a:xfrm>
+          <a:prstGeom prst="rect">
+            <a:avLst/>
+          </a:prstGeom>
+          <a:noFill/>
+        </p:spPr>
+        <p:txBody>
+          <a:bodyPr wrap="square" anchor="t" lIns="0" rIns="0" tIns="0" bIns="0">
+            <a:spAutoFit/>
+          </a:bodyPr>
+          <a:lstStyle/>
+          <a:p>
+            <a:pPr algn="l"/>
+            <a:r>
+              <a:rPr sz="800" b="1">
+                <a:solidFill>
+                  <a:srgbClr val="1B7F4E"/>
                 </a:solidFill>
                 <a:latin typeface="Manrope"/>
               </a:rPr>
-              <a:t> abertura</a:t>
-            </a:r>
-          </a:p>
-        </p:txBody>
-      </p:sp>
-      <p:sp>
-        <p:nvSpPr>
-          <p:cNvPr id="1172" name="Trilho E-MAIL MKT"/>
+              <a:t>+15% proj.</a:t>
+            </a:r>
+          </a:p>
+        </p:txBody>
+      </p:sp>
+      <p:sp>
+        <p:nvSpPr>
+          <p:cNvPr id="1159" name="KPI IMPRESSÕES"/>
           <p:cNvSpPr/>
           <p:nvPr/>
         </p:nvSpPr>
         <p:spPr>
           <a:xfrm>
-            <a:off x="10671048" y="2423160"/>
-            <a:ext cx="1097280" cy="91440"/>
+            <a:off x="1581912" y="2212848"/>
+            <a:ext cx="1234440" cy="694944"/>
           </a:xfrm>
           <a:prstGeom prst="roundRect">
             <a:avLst>
-              <a:gd name="adj" fmla="val 50000"/>
+              <a:gd name="adj" fmla="val 5000"/>
             </a:avLst>
           </a:prstGeom>
           <a:solidFill>
-            <a:srgbClr val="E6EBF3"/>
+            <a:srgbClr val="FFFFFF"/>
           </a:solidFill>
-          <a:ln>
-            <a:noFill/>
+          <a:ln w="9525">
+            <a:solidFill>
+              <a:srgbClr val="DDE2ED"/>
+            </a:solidFill>
           </a:ln>
           <a:effectLst/>
         </p:spPr>
@@ -6008,25 +5338,132 @@
       </p:sp>
       <p:sp>
         <p:nvSpPr>
-          <p:cNvPr id="1173" name="Barra E-MAIL MKT"/>
+          <p:cNvPr id="1160" name="KPI rótulo IMPRESSÕES"/>
+          <p:cNvSpPr txBox="1"/>
+          <p:nvPr/>
+        </p:nvSpPr>
+        <p:spPr>
+          <a:xfrm>
+            <a:off x="1673352" y="2276856"/>
+            <a:ext cx="1097280" cy="109728"/>
+          </a:xfrm>
+          <a:prstGeom prst="rect">
+            <a:avLst/>
+          </a:prstGeom>
+          <a:noFill/>
+        </p:spPr>
+        <p:txBody>
+          <a:bodyPr wrap="square" anchor="t" lIns="0" rIns="0" tIns="0" bIns="0">
+            <a:spAutoFit/>
+          </a:bodyPr>
+          <a:lstStyle/>
+          <a:p>
+            <a:pPr algn="l"/>
+            <a:r>
+              <a:rPr sz="700" b="1">
+                <a:solidFill>
+                  <a:srgbClr val="6B7894"/>
+                </a:solidFill>
+                <a:latin typeface="Manrope"/>
+              </a:rPr>
+              <a:t>IMPRESSÕES</a:t>
+            </a:r>
+          </a:p>
+        </p:txBody>
+      </p:sp>
+      <p:sp>
+        <p:nvSpPr>
+          <p:cNvPr id="1161" name="KPI valor IMPRESSÕES"/>
+          <p:cNvSpPr txBox="1"/>
+          <p:nvPr/>
+        </p:nvSpPr>
+        <p:spPr>
+          <a:xfrm>
+            <a:off x="1673352" y="2414016"/>
+            <a:ext cx="1097280" cy="228600"/>
+          </a:xfrm>
+          <a:prstGeom prst="rect">
+            <a:avLst/>
+          </a:prstGeom>
+          <a:noFill/>
+        </p:spPr>
+        <p:txBody>
+          <a:bodyPr wrap="square" anchor="t" lIns="0" rIns="0" tIns="0" bIns="0">
+            <a:spAutoFit/>
+          </a:bodyPr>
+          <a:lstStyle/>
+          <a:p>
+            <a:pPr algn="l"/>
+            <a:r>
+              <a:rPr sz="1300" b="1">
+                <a:solidFill>
+                  <a:srgbClr val="142B52"/>
+                </a:solidFill>
+                <a:latin typeface="Manrope"/>
+              </a:rPr>
+              <a:t>2.449.067</a:t>
+            </a:r>
+          </a:p>
+        </p:txBody>
+      </p:sp>
+      <p:sp>
+        <p:nvSpPr>
+          <p:cNvPr id="1162" name="KPI delta IMPRESSÕES"/>
+          <p:cNvSpPr txBox="1"/>
+          <p:nvPr/>
+        </p:nvSpPr>
+        <p:spPr>
+          <a:xfrm>
+            <a:off x="1673352" y="2688336"/>
+            <a:ext cx="1097280" cy="128016"/>
+          </a:xfrm>
+          <a:prstGeom prst="rect">
+            <a:avLst/>
+          </a:prstGeom>
+          <a:noFill/>
+        </p:spPr>
+        <p:txBody>
+          <a:bodyPr wrap="square" anchor="t" lIns="0" rIns="0" tIns="0" bIns="0">
+            <a:spAutoFit/>
+          </a:bodyPr>
+          <a:lstStyle/>
+          <a:p>
+            <a:pPr algn="l"/>
+            <a:r>
+              <a:rPr sz="800" b="1">
+                <a:solidFill>
+                  <a:srgbClr val="F37919"/>
+                </a:solidFill>
+                <a:latin typeface="Manrope"/>
+              </a:rPr>
+              <a:t>−33% proj.</a:t>
+            </a:r>
+          </a:p>
+        </p:txBody>
+      </p:sp>
+      <p:sp>
+        <p:nvSpPr>
+          <p:cNvPr id="1163" name="KPI CLIQUES"/>
           <p:cNvSpPr/>
           <p:nvPr/>
         </p:nvSpPr>
         <p:spPr>
           <a:xfrm>
-            <a:off x="10671048" y="2423160"/>
-            <a:ext cx="183245" cy="91440"/>
+            <a:off x="301752" y="2971800"/>
+            <a:ext cx="1234440" cy="694944"/>
           </a:xfrm>
           <a:prstGeom prst="roundRect">
             <a:avLst>
-              <a:gd name="adj" fmla="val 50000"/>
+              <a:gd name="adj" fmla="val 5000"/>
             </a:avLst>
           </a:prstGeom>
           <a:solidFill>
-            <a:srgbClr val="7AAAD4"/>
+            <a:srgbClr val="FFFFFF"/>
           </a:solidFill>
-          <a:ln>
-            <a:noFill/>
+          <a:ln w="9525">
+            <a:solidFill>
+              <a:srgbClr val="DDE2ED"/>
+            </a:solidFill>
           </a:ln>
           <a:effectLst/>
         </p:spPr>
@@ -6054,14 +5491,14 @@
       </p:sp>
       <p:sp>
         <p:nvSpPr>
-          <p:cNvPr id="1174" name="Detalhe E-MAIL MKT"/>
+          <p:cNvPr id="1164" name="KPI rótulo CLIQUES"/>
           <p:cNvSpPr txBox="1"/>
           <p:nvPr/>
         </p:nvSpPr>
         <p:spPr>
           <a:xfrm>
-            <a:off x="9354312" y="2651760"/>
-            <a:ext cx="2468880" cy="274320"/>
+            <a:off x="393192" y="3035808"/>
+            <a:ext cx="1097280" cy="109728"/>
           </a:xfrm>
           <a:prstGeom prst="rect">
             <a:avLst/>
@@ -6076,27 +5513,27 @@
           <a:p>
             <a:pPr algn="l"/>
             <a:r>
-              <a:rPr sz="850" b="0">
+              <a:rPr sz="700" b="1">
                 <a:solidFill>
                   <a:srgbClr val="6B7894"/>
                 </a:solidFill>
                 <a:latin typeface="Manrope"/>
               </a:rPr>
-              <a:t>4.794 enviados · 4.345 entregues · 50 cliques</a:t>
-            </a:r>
-          </a:p>
-        </p:txBody>
-      </p:sp>
-      <p:sp>
-        <p:nvSpPr>
-          <p:cNvPr id="1175" name="Canal ZAP VLI"/>
+              <a:t>CLIQUES</a:t>
+            </a:r>
+          </a:p>
+        </p:txBody>
+      </p:sp>
+      <p:sp>
+        <p:nvSpPr>
+          <p:cNvPr id="1165" name="KPI valor CLIQUES"/>
           <p:cNvSpPr txBox="1"/>
           <p:nvPr/>
         </p:nvSpPr>
         <p:spPr>
           <a:xfrm>
-            <a:off x="9354312" y="2862072"/>
-            <a:ext cx="1280160" cy="146304"/>
+            <a:off x="393192" y="3172968"/>
+            <a:ext cx="1097280" cy="228600"/>
           </a:xfrm>
           <a:prstGeom prst="rect">
             <a:avLst/>
@@ -6111,27 +5548,27 @@
           <a:p>
             <a:pPr algn="l"/>
             <a:r>
-              <a:rPr sz="850" b="1">
-                <a:solidFill>
-                  <a:srgbClr val="43597E"/>
+              <a:rPr sz="1300" b="1">
+                <a:solidFill>
+                  <a:srgbClr val="142B52"/>
                 </a:solidFill>
                 <a:latin typeface="Manrope"/>
               </a:rPr>
-              <a:t>ZAP VLI</a:t>
-            </a:r>
-          </a:p>
-        </p:txBody>
-      </p:sp>
-      <p:sp>
-        <p:nvSpPr>
-          <p:cNvPr id="1176" name="KPI ZAP VLI"/>
+              <a:t>29.233</a:t>
+            </a:r>
+          </a:p>
+        </p:txBody>
+      </p:sp>
+      <p:sp>
+        <p:nvSpPr>
+          <p:cNvPr id="1166" name="KPI delta CLIQUES"/>
           <p:cNvSpPr txBox="1"/>
           <p:nvPr/>
         </p:nvSpPr>
         <p:spPr>
           <a:xfrm>
-            <a:off x="9354312" y="2999232"/>
-            <a:ext cx="1188720" cy="292608"/>
+            <a:off x="393192" y="3447288"/>
+            <a:ext cx="1097280" cy="128016"/>
           </a:xfrm>
           <a:prstGeom prst="rect">
             <a:avLst/>
@@ -6146,47 +5583,40 @@
           <a:p>
             <a:pPr algn="l"/>
             <a:r>
-              <a:rPr sz="1600" b="1">
-                <a:solidFill>
-                  <a:srgbClr val="142B52"/>
+              <a:rPr sz="800" b="1">
+                <a:solidFill>
+                  <a:srgbClr val="1B7F4E"/>
                 </a:solidFill>
                 <a:latin typeface="Manrope"/>
               </a:rPr>
-              <a:t>56,5%</a:t>
-            </a:r>
-            <a:r>
-              <a:rPr sz="900" b="0">
-                <a:solidFill>
-                  <a:srgbClr val="6B7894"/>
-                </a:solidFill>
-                <a:latin typeface="Manrope"/>
-              </a:rPr>
-              <a:t> leitura</a:t>
-            </a:r>
-          </a:p>
-        </p:txBody>
-      </p:sp>
-      <p:sp>
-        <p:nvSpPr>
-          <p:cNvPr id="1177" name="Trilho ZAP VLI"/>
+              <a:t>+26% proj.</a:t>
+            </a:r>
+          </a:p>
+        </p:txBody>
+      </p:sp>
+      <p:sp>
+        <p:nvSpPr>
+          <p:cNvPr id="1167" name="KPI NOVOS SEGUIDORES"/>
           <p:cNvSpPr/>
           <p:nvPr/>
         </p:nvSpPr>
         <p:spPr>
           <a:xfrm>
-            <a:off x="10671048" y="3090672"/>
-            <a:ext cx="1097280" cy="91440"/>
+            <a:off x="1581912" y="2971800"/>
+            <a:ext cx="1234440" cy="694944"/>
           </a:xfrm>
           <a:prstGeom prst="roundRect">
             <a:avLst>
-              <a:gd name="adj" fmla="val 50000"/>
+              <a:gd name="adj" fmla="val 5000"/>
             </a:avLst>
           </a:prstGeom>
           <a:solidFill>
-            <a:srgbClr val="E6EBF3"/>
+            <a:srgbClr val="FFFFFF"/>
           </a:solidFill>
-          <a:ln>
-            <a:noFill/>
+          <a:ln w="9525">
+            <a:solidFill>
+              <a:srgbClr val="DDE2ED"/>
+            </a:solidFill>
           </a:ln>
           <a:effectLst/>
         </p:spPr>
@@ -6214,25 +5644,377 @@
       </p:sp>
       <p:sp>
         <p:nvSpPr>
-          <p:cNvPr id="1178" name="Barra ZAP VLI"/>
+          <p:cNvPr id="1168" name="KPI rótulo NOVOS SEGUIDORES"/>
+          <p:cNvSpPr txBox="1"/>
+          <p:nvPr/>
+        </p:nvSpPr>
+        <p:spPr>
+          <a:xfrm>
+            <a:off x="1673352" y="3035808"/>
+            <a:ext cx="1097280" cy="109728"/>
+          </a:xfrm>
+          <a:prstGeom prst="rect">
+            <a:avLst/>
+          </a:prstGeom>
+          <a:noFill/>
+        </p:spPr>
+        <p:txBody>
+          <a:bodyPr wrap="square" anchor="t" lIns="0" rIns="0" tIns="0" bIns="0">
+            <a:spAutoFit/>
+          </a:bodyPr>
+          <a:lstStyle/>
+          <a:p>
+            <a:pPr algn="l"/>
+            <a:r>
+              <a:rPr sz="700" b="1">
+                <a:solidFill>
+                  <a:srgbClr val="6B7894"/>
+                </a:solidFill>
+                <a:latin typeface="Manrope"/>
+              </a:rPr>
+              <a:t>NOVOS SEGUIDORES</a:t>
+            </a:r>
+          </a:p>
+        </p:txBody>
+      </p:sp>
+      <p:sp>
+        <p:nvSpPr>
+          <p:cNvPr id="1169" name="KPI valor NOVOS SEGUIDORES"/>
+          <p:cNvSpPr txBox="1"/>
+          <p:nvPr/>
+        </p:nvSpPr>
+        <p:spPr>
+          <a:xfrm>
+            <a:off x="1673352" y="3172968"/>
+            <a:ext cx="1097280" cy="228600"/>
+          </a:xfrm>
+          <a:prstGeom prst="rect">
+            <a:avLst/>
+          </a:prstGeom>
+          <a:noFill/>
+        </p:spPr>
+        <p:txBody>
+          <a:bodyPr wrap="square" anchor="t" lIns="0" rIns="0" tIns="0" bIns="0">
+            <a:spAutoFit/>
+          </a:bodyPr>
+          <a:lstStyle/>
+          <a:p>
+            <a:pPr algn="l"/>
+            <a:r>
+              <a:rPr sz="1300" b="1">
+                <a:solidFill>
+                  <a:srgbClr val="142B52"/>
+                </a:solidFill>
+                <a:latin typeface="Manrope"/>
+              </a:rPr>
+              <a:t>137</a:t>
+            </a:r>
+          </a:p>
+        </p:txBody>
+      </p:sp>
+      <p:sp>
+        <p:nvSpPr>
+          <p:cNvPr id="1170" name="KPI delta NOVOS SEGUIDORES"/>
+          <p:cNvSpPr txBox="1"/>
+          <p:nvPr/>
+        </p:nvSpPr>
+        <p:spPr>
+          <a:xfrm>
+            <a:off x="1673352" y="3447288"/>
+            <a:ext cx="1097280" cy="128016"/>
+          </a:xfrm>
+          <a:prstGeom prst="rect">
+            <a:avLst/>
+          </a:prstGeom>
+          <a:noFill/>
+        </p:spPr>
+        <p:txBody>
+          <a:bodyPr wrap="square" anchor="t" lIns="0" rIns="0" tIns="0" bIns="0">
+            <a:spAutoFit/>
+          </a:bodyPr>
+          <a:lstStyle/>
+          <a:p>
+            <a:pPr algn="l"/>
+            <a:r>
+              <a:rPr sz="800" b="1">
+                <a:solidFill>
+                  <a:srgbClr val="1B7F4E"/>
+                </a:solidFill>
+                <a:latin typeface="Manrope"/>
+              </a:rPr>
+              <a:t>+2.640% proj.</a:t>
+            </a:r>
+          </a:p>
+        </p:txBody>
+      </p:sp>
+      <p:sp>
+        <p:nvSpPr>
+          <p:cNvPr id="1171" name="Invest ON"/>
+          <p:cNvSpPr txBox="1"/>
+          <p:nvPr/>
+        </p:nvSpPr>
+        <p:spPr>
+          <a:xfrm>
+            <a:off x="301752" y="3749039"/>
+            <a:ext cx="2514600" cy="146304"/>
+          </a:xfrm>
+          <a:prstGeom prst="rect">
+            <a:avLst/>
+          </a:prstGeom>
+          <a:noFill/>
+        </p:spPr>
+        <p:txBody>
+          <a:bodyPr wrap="square" anchor="t" lIns="0" rIns="0" tIns="0" bIns="0">
+            <a:spAutoFit/>
+          </a:bodyPr>
+          <a:lstStyle/>
+          <a:p>
+            <a:pPr algn="l"/>
+            <a:r>
+              <a:rPr sz="850" b="0">
+                <a:solidFill>
+                  <a:srgbClr val="6B7894"/>
+                </a:solidFill>
+                <a:latin typeface="Manrope"/>
+              </a:rPr>
+              <a:t>Investimento líquido on  </a:t>
+            </a:r>
+            <a:r>
+              <a:rPr sz="850" b="1">
+                <a:solidFill>
+                  <a:srgbClr val="142B52"/>
+                </a:solidFill>
+                <a:latin typeface="Manrope"/>
+              </a:rPr>
+              <a:t>R$ 10.539,60</a:t>
+            </a:r>
+          </a:p>
+        </p:txBody>
+      </p:sp>
+      <p:sp>
+        <p:nvSpPr>
+          <p:cNvPr id="1172" name="Título off"/>
+          <p:cNvSpPr txBox="1"/>
+          <p:nvPr/>
+        </p:nvSpPr>
+        <p:spPr>
+          <a:xfrm>
+            <a:off x="301752" y="4041648"/>
+            <a:ext cx="2514600" cy="164592"/>
+          </a:xfrm>
+          <a:prstGeom prst="rect">
+            <a:avLst/>
+          </a:prstGeom>
+          <a:noFill/>
+        </p:spPr>
+        <p:txBody>
+          <a:bodyPr wrap="square" anchor="t" lIns="0" rIns="0" tIns="0" bIns="0">
+            <a:spAutoFit/>
+          </a:bodyPr>
+          <a:lstStyle/>
+          <a:p>
+            <a:pPr algn="l"/>
+            <a:r>
+              <a:rPr sz="900" b="1">
+                <a:solidFill>
+                  <a:srgbClr val="43597E"/>
+                </a:solidFill>
+                <a:latin typeface="Manrope"/>
+              </a:rPr>
+              <a:t>MÍDIA OFF</a:t>
+            </a:r>
+          </a:p>
+        </p:txBody>
+      </p:sp>
+      <p:pic>
+        <p:nvPicPr>
+          <p:cNvPr id="1173" name="Foto OOH" descr="image.png"/>
+          <p:cNvPicPr>
+            <a:picLocks noChangeAspect="1"/>
+          </p:cNvPicPr>
+          <p:nvPr/>
+        </p:nvPicPr>
+        <p:blipFill>
+          <a:blip r:embed="rId5"/>
+          <a:stretch>
+            <a:fillRect/>
+          </a:stretch>
+        </p:blipFill>
+        <p:spPr>
+          <a:xfrm>
+            <a:off x="301752" y="4261104"/>
+            <a:ext cx="1097280" cy="734684"/>
+          </a:xfrm>
+          <a:prstGeom prst="rect">
+            <a:avLst/>
+          </a:prstGeom>
+        </p:spPr>
+      </p:pic>
+      <p:sp>
+        <p:nvSpPr>
+          <p:cNvPr id="1174" name="Texto OOH"/>
+          <p:cNvSpPr txBox="1"/>
+          <p:nvPr/>
+        </p:nvSpPr>
+        <p:spPr>
+          <a:xfrm>
+            <a:off x="1481328" y="4261104"/>
+            <a:ext cx="1371600" cy="822960"/>
+          </a:xfrm>
+          <a:prstGeom prst="rect">
+            <a:avLst/>
+          </a:prstGeom>
+          <a:noFill/>
+        </p:spPr>
+        <p:txBody>
+          <a:bodyPr wrap="square" anchor="t" lIns="0" rIns="0" tIns="0" bIns="0">
+            <a:spAutoFit/>
+          </a:bodyPr>
+          <a:lstStyle/>
+          <a:p>
+            <a:pPr algn="l">
+              <a:spcAft>
+                <a:spcPts val="200"/>
+              </a:spcAft>
+            </a:pPr>
+            <a:r>
+              <a:rPr sz="800" b="1">
+                <a:solidFill>
+                  <a:srgbClr val="142B52"/>
+                </a:solidFill>
+                <a:latin typeface="Manrope"/>
+              </a:rPr>
+              <a:t>OOH: </a:t>
+            </a:r>
+            <a:r>
+              <a:rPr sz="800" b="0">
+                <a:solidFill>
+                  <a:srgbClr val="142B52"/>
+                </a:solidFill>
+                <a:latin typeface="Manrope"/>
+              </a:rPr>
+              <a:t>Painel de LED, Banca de Led e Outdoor</a:t>
+            </a:r>
+          </a:p>
+          <a:p>
+            <a:pPr algn="l">
+              <a:spcAft>
+                <a:spcPts val="200"/>
+              </a:spcAft>
+            </a:pPr>
+            <a:r>
+              <a:rPr sz="800" b="1">
+                <a:solidFill>
+                  <a:srgbClr val="142B52"/>
+                </a:solidFill>
+                <a:latin typeface="Manrope"/>
+              </a:rPr>
+              <a:t>Veiculação: </a:t>
+            </a:r>
+            <a:r>
+              <a:rPr sz="800" b="0">
+                <a:solidFill>
+                  <a:srgbClr val="142B52"/>
+                </a:solidFill>
+                <a:latin typeface="Manrope"/>
+              </a:rPr>
+              <a:t>15/09 a 04/10</a:t>
+            </a:r>
+          </a:p>
+          <a:p>
+            <a:pPr algn="l">
+              <a:spcAft>
+                <a:spcPts val="200"/>
+              </a:spcAft>
+            </a:pPr>
+            <a:r>
+              <a:rPr sz="800" b="1">
+                <a:solidFill>
+                  <a:srgbClr val="142B52"/>
+                </a:solidFill>
+                <a:latin typeface="Manrope"/>
+              </a:rPr>
+              <a:t>Local: </a:t>
+            </a:r>
+            <a:r>
+              <a:rPr sz="800" b="0">
+                <a:solidFill>
+                  <a:srgbClr val="142B52"/>
+                </a:solidFill>
+                <a:latin typeface="Manrope"/>
+              </a:rPr>
+              <a:t>Betim (MG) – 4 pontos próximos a passagem em nível</a:t>
+            </a:r>
+          </a:p>
+        </p:txBody>
+      </p:sp>
+      <p:sp>
+        <p:nvSpPr>
+          <p:cNvPr id="1175" name="Invest OFF"/>
+          <p:cNvSpPr txBox="1"/>
+          <p:nvPr/>
+        </p:nvSpPr>
+        <p:spPr>
+          <a:xfrm>
+            <a:off x="301752" y="5230368"/>
+            <a:ext cx="2514600" cy="146304"/>
+          </a:xfrm>
+          <a:prstGeom prst="rect">
+            <a:avLst/>
+          </a:prstGeom>
+          <a:noFill/>
+        </p:spPr>
+        <p:txBody>
+          <a:bodyPr wrap="square" anchor="t" lIns="0" rIns="0" tIns="0" bIns="0">
+            <a:spAutoFit/>
+          </a:bodyPr>
+          <a:lstStyle/>
+          <a:p>
+            <a:pPr algn="l"/>
+            <a:r>
+              <a:rPr sz="850" b="0">
+                <a:solidFill>
+                  <a:srgbClr val="6B7894"/>
+                </a:solidFill>
+                <a:latin typeface="Manrope"/>
+              </a:rPr>
+              <a:t>Investimento líquido off  </a:t>
+            </a:r>
+            <a:r>
+              <a:rPr sz="850" b="1">
+                <a:solidFill>
+                  <a:srgbClr val="142B52"/>
+                </a:solidFill>
+                <a:latin typeface="Manrope"/>
+              </a:rPr>
+              <a:t>R$ 5.738,01</a:t>
+            </a:r>
+          </a:p>
+        </p:txBody>
+      </p:sp>
+      <p:sp>
+        <p:nvSpPr>
+          <p:cNvPr id="1176" name="Destaques"/>
           <p:cNvSpPr/>
           <p:nvPr/>
         </p:nvSpPr>
         <p:spPr>
           <a:xfrm>
-            <a:off x="10671048" y="3090672"/>
-            <a:ext cx="619963" cy="91440"/>
+            <a:off x="2926080" y="2212848"/>
+            <a:ext cx="4800600" cy="1097280"/>
           </a:xfrm>
           <a:prstGeom prst="roundRect">
             <a:avLst>
-              <a:gd name="adj" fmla="val 50000"/>
+              <a:gd name="adj" fmla="val 5000"/>
             </a:avLst>
           </a:prstGeom>
           <a:solidFill>
-            <a:srgbClr val="F37919"/>
+            <a:srgbClr val="FFFFFF"/>
           </a:solidFill>
-          <a:ln>
-            <a:noFill/>
+          <a:ln w="9525">
+            <a:solidFill>
+              <a:srgbClr val="DDE2ED"/>
+            </a:solidFill>
           </a:ln>
           <a:effectLst/>
         </p:spPr>
@@ -6260,14 +6042,14 @@
       </p:sp>
       <p:sp>
         <p:nvSpPr>
-          <p:cNvPr id="1179" name="Detalhe ZAP VLI"/>
+          <p:cNvPr id="1177" name="Destaques título"/>
           <p:cNvSpPr txBox="1"/>
           <p:nvPr/>
         </p:nvSpPr>
         <p:spPr>
           <a:xfrm>
-            <a:off x="9354312" y="3319272"/>
-            <a:ext cx="2468880" cy="274320"/>
+            <a:off x="3035808" y="2267712"/>
+            <a:ext cx="4581144" cy="128016"/>
           </a:xfrm>
           <a:prstGeom prst="rect">
             <a:avLst/>
@@ -6282,27 +6064,27 @@
           <a:p>
             <a:pPr algn="l"/>
             <a:r>
-              <a:rPr sz="850" b="0">
-                <a:solidFill>
-                  <a:srgbClr val="6B7894"/>
+              <a:rPr sz="800" b="1">
+                <a:solidFill>
+                  <a:srgbClr val="43597E"/>
                 </a:solidFill>
                 <a:latin typeface="Manrope"/>
               </a:rPr>
-              <a:t>3.516 recebidas · 181 interações (9,1%)</a:t>
-            </a:r>
-          </a:p>
-        </p:txBody>
-      </p:sp>
-      <p:sp>
-        <p:nvSpPr>
-          <p:cNvPr id="1180" name="Canal INTRANET VLI@"/>
+              <a:t>DESTAQUES</a:t>
+            </a:r>
+          </a:p>
+        </p:txBody>
+      </p:sp>
+      <p:sp>
+        <p:nvSpPr>
+          <p:cNvPr id="1178" name="Destaques texto"/>
           <p:cNvSpPr txBox="1"/>
           <p:nvPr/>
         </p:nvSpPr>
         <p:spPr>
           <a:xfrm>
-            <a:off x="9354312" y="3529584"/>
-            <a:ext cx="1280160" cy="146304"/>
+            <a:off x="3035808" y="2423160"/>
+            <a:ext cx="4581144" cy="1024128"/>
           </a:xfrm>
           <a:prstGeom prst="rect">
             <a:avLst/>
@@ -6315,29 +6097,92 @@
           </a:bodyPr>
           <a:lstStyle/>
           <a:p>
-            <a:pPr algn="l"/>
-            <a:r>
-              <a:rPr sz="850" b="1">
-                <a:solidFill>
-                  <a:srgbClr val="43597E"/>
+            <a:pPr algn="l">
+              <a:spcAft>
+                <a:spcPts val="300"/>
+              </a:spcAft>
+            </a:pPr>
+            <a:r>
+              <a:rPr sz="800" b="1">
+                <a:solidFill>
+                  <a:srgbClr val="142B52"/>
                 </a:solidFill>
                 <a:latin typeface="Manrope"/>
               </a:rPr>
-              <a:t>INTRANET VLI@</a:t>
-            </a:r>
-          </a:p>
-        </p:txBody>
-      </p:sp>
-      <p:sp>
-        <p:nvSpPr>
-          <p:cNvPr id="1181" name="KPI INTRANET VLI@"/>
+              <a:t>Criativo: </a:t>
+            </a:r>
+            <a:r>
+              <a:rPr sz="800" b="0">
+                <a:solidFill>
+                  <a:srgbClr val="142B52"/>
+                </a:solidFill>
+                <a:latin typeface="Manrope"/>
+              </a:rPr>
+              <a:t>identidade unificada do Movimento Nacional pela Segurança Ferroviária, com as demais concessionárias, e a ID de Maio Amarelo adaptada, garantindo visibilidade à VLI.</a:t>
+            </a:r>
+          </a:p>
+          <a:p>
+            <a:pPr algn="l">
+              <a:spcAft>
+                <a:spcPts val="300"/>
+              </a:spcAft>
+            </a:pPr>
+            <a:r>
+              <a:rPr sz="800" b="1">
+                <a:solidFill>
+                  <a:srgbClr val="142B52"/>
+                </a:solidFill>
+                <a:latin typeface="Manrope"/>
+              </a:rPr>
+              <a:t>Mídia on e off: </a:t>
+            </a:r>
+            <a:r>
+              <a:rPr sz="800" b="0">
+                <a:solidFill>
+                  <a:srgbClr val="142B52"/>
+                </a:solidFill>
+                <a:latin typeface="Manrope"/>
+              </a:rPr>
+              <a:t>convite para o Dia D + segurança no trânsito. Público 45+ concentrou quase metade do alcance; OOH com cobertura pré, durante e pós evento em Betim.</a:t>
+            </a:r>
+          </a:p>
+          <a:p>
+            <a:pPr algn="l">
+              <a:spcAft>
+                <a:spcPts val="300"/>
+              </a:spcAft>
+            </a:pPr>
+            <a:r>
+              <a:rPr sz="800" b="1">
+                <a:solidFill>
+                  <a:srgbClr val="142B52"/>
+                </a:solidFill>
+                <a:latin typeface="Manrope"/>
+              </a:rPr>
+              <a:t>Conteúdos: </a:t>
+            </a:r>
+            <a:r>
+              <a:rPr sz="800" b="0">
+                <a:solidFill>
+                  <a:srgbClr val="142B52"/>
+                </a:solidFill>
+                <a:latin typeface="Manrope"/>
+              </a:rPr>
+              <a:t>tom próximo e acessível gerou altíssima visibilidade e elevou a média de alcance do mês.</a:t>
+            </a:r>
+          </a:p>
+        </p:txBody>
+      </p:sp>
+      <p:sp>
+        <p:nvSpPr>
+          <p:cNvPr id="1179" name="Título tabela"/>
           <p:cNvSpPr txBox="1"/>
           <p:nvPr/>
         </p:nvSpPr>
         <p:spPr>
           <a:xfrm>
-            <a:off x="9354312" y="3666744"/>
-            <a:ext cx="1188720" cy="292608"/>
+            <a:off x="2926080" y="3383280"/>
+            <a:ext cx="4800600" cy="128016"/>
           </a:xfrm>
           <a:prstGeom prst="rect">
             <a:avLst/>
@@ -6352,123 +6197,400 @@
           <a:p>
             <a:pPr algn="l"/>
             <a:r>
-              <a:rPr sz="1600" b="1">
-                <a:solidFill>
-                  <a:srgbClr val="142B52"/>
+              <a:rPr sz="800" b="1">
+                <a:solidFill>
+                  <a:srgbClr val="43597E"/>
                 </a:solidFill>
                 <a:latin typeface="Manrope"/>
               </a:rPr>
-              <a:t>114</a:t>
-            </a:r>
-            <a:r>
-              <a:rPr sz="900" b="0">
-                <a:solidFill>
-                  <a:srgbClr val="6B7894"/>
-                </a:solidFill>
-                <a:latin typeface="Manrope"/>
-              </a:rPr>
-              <a:t> exibições</a:t>
-            </a:r>
-          </a:p>
-        </p:txBody>
-      </p:sp>
-      <p:sp>
-        <p:nvSpPr>
-          <p:cNvPr id="1182" name="Detalhe INTRANET VLI@"/>
-          <p:cNvSpPr txBox="1"/>
-          <p:nvPr/>
-        </p:nvSpPr>
-        <p:spPr>
-          <a:xfrm>
-            <a:off x="9354312" y="3986783"/>
-            <a:ext cx="2468880" cy="274320"/>
-          </a:xfrm>
-          <a:prstGeom prst="rect">
-            <a:avLst/>
-          </a:prstGeom>
-          <a:noFill/>
-        </p:spPr>
-        <p:txBody>
-          <a:bodyPr wrap="square" anchor="t" lIns="0" rIns="0" tIns="0" bIns="0">
-            <a:spAutoFit/>
-          </a:bodyPr>
-          <a:lstStyle/>
-          <a:p>
-            <a:pPr algn="l"/>
-            <a:r>
-              <a:rPr sz="850" b="0">
-                <a:solidFill>
-                  <a:srgbClr val="6B7894"/>
-                </a:solidFill>
-                <a:latin typeface="Manrope"/>
-              </a:rPr>
-              <a:t>matéria educativa, com dicas para o trânsito</a:t>
-            </a:r>
-          </a:p>
-        </p:txBody>
-      </p:sp>
-      <p:sp>
-        <p:nvSpPr>
-          <p:cNvPr id="1183" name="Título criativos"/>
-          <p:cNvSpPr txBox="1"/>
-          <p:nvPr/>
-        </p:nvSpPr>
-        <p:spPr>
-          <a:xfrm>
-            <a:off x="411480" y="4434840"/>
-            <a:ext cx="5029200" cy="182880"/>
-          </a:xfrm>
-          <a:prstGeom prst="rect">
-            <a:avLst/>
-          </a:prstGeom>
-          <a:noFill/>
-        </p:spPr>
-        <p:txBody>
-          <a:bodyPr wrap="square" anchor="t" lIns="0" rIns="0" tIns="0" bIns="0">
-            <a:spAutoFit/>
-          </a:bodyPr>
-          <a:lstStyle/>
-          <a:p>
-            <a:pPr algn="l"/>
-            <a:r>
-              <a:rPr sz="1000" b="1">
-                <a:solidFill>
-                  <a:srgbClr val="43597E"/>
-                </a:solidFill>
-                <a:latin typeface="Manrope"/>
-              </a:rPr>
-              <a:t>CRIATIVOS DA CAMPANHA</a:t>
-            </a:r>
-          </a:p>
-        </p:txBody>
-      </p:sp>
+              <a:t>CONTEÚDO DE REDES | DESTAQUES</a:t>
+            </a:r>
+          </a:p>
+        </p:txBody>
+      </p:sp>
+      <p:graphicFrame>
+        <p:nvGraphicFramePr>
+          <p:cNvPr id="1180" name="Tabela conteúdos"/>
+          <p:cNvGraphicFramePr>
+            <a:graphicFrameLocks noGrp="1"/>
+          </p:cNvGraphicFramePr>
+          <p:nvPr/>
+        </p:nvGraphicFramePr>
+        <p:xfrm>
+          <a:off x="2926080" y="3547872"/>
+          <a:ext cx="4800600" cy="603504"/>
+        </p:xfrm>
+        <a:graphic>
+          <a:graphicData uri="http://schemas.openxmlformats.org/drawingml/2006/table">
+            <a:tbl>
+              <a:tblPr firstRow="0" bandRow="0">
+                <a:tableStyleId>{5C22544A-7EE6-4342-B048-85BDC9FD1C3A}</a:tableStyleId>
+              </a:tblPr>
+              <a:tblGrid>
+                <a:gridCol w="1691640"/>
+                <a:gridCol w="502920"/>
+                <a:gridCol w="822960"/>
+                <a:gridCol w="457200"/>
+                <a:gridCol w="1325880"/>
+              </a:tblGrid>
+              <a:tr h="201168">
+                <a:tc>
+                  <a:txBody>
+                    <a:bodyPr/>
+                    <a:lstStyle/>
+                    <a:p>
+                      <a:pPr algn="l"/>
+                      <a:r>
+                        <a:rPr sz="750" b="1">
+                          <a:solidFill>
+                            <a:srgbClr val="FFFFFF"/>
+                          </a:solidFill>
+                          <a:latin typeface="Manrope"/>
+                        </a:rPr>
+                        <a:t>CONTEÚDO</a:t>
+                      </a:r>
+                    </a:p>
+                  </a:txBody>
+                  <a:tcPr marL="54864" marR="54864" marT="18288" marB="18288" anchor="ctr">
+                    <a:solidFill>
+                      <a:srgbClr val="1971BA"/>
+                    </a:solidFill>
+                  </a:tcPr>
+                </a:tc>
+                <a:tc>
+                  <a:txBody>
+                    <a:bodyPr/>
+                    <a:lstStyle/>
+                    <a:p>
+                      <a:pPr algn="ctr"/>
+                      <a:r>
+                        <a:rPr sz="750" b="1">
+                          <a:solidFill>
+                            <a:srgbClr val="FFFFFF"/>
+                          </a:solidFill>
+                          <a:latin typeface="Manrope"/>
+                        </a:rPr>
+                        <a:t>REDE</a:t>
+                      </a:r>
+                    </a:p>
+                  </a:txBody>
+                  <a:tcPr marL="54864" marR="54864" marT="18288" marB="18288" anchor="ctr">
+                    <a:solidFill>
+                      <a:srgbClr val="1971BA"/>
+                    </a:solidFill>
+                  </a:tcPr>
+                </a:tc>
+                <a:tc>
+                  <a:txBody>
+                    <a:bodyPr/>
+                    <a:lstStyle/>
+                    <a:p>
+                      <a:pPr algn="ctr"/>
+                      <a:r>
+                        <a:rPr sz="750" b="1">
+                          <a:solidFill>
+                            <a:srgbClr val="FFFFFF"/>
+                          </a:solidFill>
+                          <a:latin typeface="Manrope"/>
+                        </a:rPr>
+                        <a:t>ALCANCE</a:t>
+                      </a:r>
+                    </a:p>
+                  </a:txBody>
+                  <a:tcPr marL="54864" marR="54864" marT="18288" marB="18288" anchor="ctr">
+                    <a:solidFill>
+                      <a:srgbClr val="1971BA"/>
+                    </a:solidFill>
+                  </a:tcPr>
+                </a:tc>
+                <a:tc>
+                  <a:txBody>
+                    <a:bodyPr/>
+                    <a:lstStyle/>
+                    <a:p>
+                      <a:pPr algn="ctr"/>
+                      <a:r>
+                        <a:rPr sz="750" b="1">
+                          <a:solidFill>
+                            <a:srgbClr val="FFFFFF"/>
+                          </a:solidFill>
+                          <a:latin typeface="Manrope"/>
+                        </a:rPr>
+                        <a:t>ENG.</a:t>
+                      </a:r>
+                    </a:p>
+                  </a:txBody>
+                  <a:tcPr marL="54864" marR="54864" marT="18288" marB="18288" anchor="ctr">
+                    <a:solidFill>
+                      <a:srgbClr val="1971BA"/>
+                    </a:solidFill>
+                  </a:tcPr>
+                </a:tc>
+                <a:tc>
+                  <a:txBody>
+                    <a:bodyPr/>
+                    <a:lstStyle/>
+                    <a:p>
+                      <a:pPr algn="ctr"/>
+                      <a:r>
+                        <a:rPr sz="750" b="1">
+                          <a:solidFill>
+                            <a:srgbClr val="FFFFFF"/>
+                          </a:solidFill>
+                          <a:latin typeface="Manrope"/>
+                        </a:rPr>
+                        <a:t>DESTAQUE</a:t>
+                      </a:r>
+                    </a:p>
+                  </a:txBody>
+                  <a:tcPr marL="54864" marR="54864" marT="18288" marB="18288" anchor="ctr">
+                    <a:solidFill>
+                      <a:srgbClr val="1971BA"/>
+                    </a:solidFill>
+                  </a:tcPr>
+                </a:tc>
+              </a:tr>
+              <a:tr h="201168">
+                <a:tc>
+                  <a:txBody>
+                    <a:bodyPr/>
+                    <a:lstStyle/>
+                    <a:p>
+                      <a:pPr algn="l"/>
+                      <a:r>
+                        <a:rPr sz="750" b="0">
+                          <a:solidFill>
+                            <a:srgbClr val="142B52"/>
+                          </a:solidFill>
+                          <a:latin typeface="Manrope"/>
+                        </a:rPr>
+                        <a:t>Chamada para a SNT</a:t>
+                      </a:r>
+                    </a:p>
+                  </a:txBody>
+                  <a:tcPr marL="54864" marR="54864" marT="18288" marB="18288" anchor="ctr">
+                    <a:solidFill>
+                      <a:srgbClr val="FFFFFF"/>
+                    </a:solidFill>
+                  </a:tcPr>
+                </a:tc>
+                <a:tc>
+                  <a:txBody>
+                    <a:bodyPr/>
+                    <a:lstStyle/>
+                    <a:p>
+                      <a:pPr algn="ctr"/>
+                      <a:r>
+                        <a:rPr sz="750" b="0">
+                          <a:solidFill>
+                            <a:srgbClr val="142B52"/>
+                          </a:solidFill>
+                          <a:latin typeface="Manrope"/>
+                        </a:rPr>
+                        <a:t>META</a:t>
+                      </a:r>
+                    </a:p>
+                  </a:txBody>
+                  <a:tcPr marL="54864" marR="54864" marT="18288" marB="18288" anchor="ctr">
+                    <a:solidFill>
+                      <a:srgbClr val="FFFFFF"/>
+                    </a:solidFill>
+                  </a:tcPr>
+                </a:tc>
+                <a:tc>
+                  <a:txBody>
+                    <a:bodyPr/>
+                    <a:lstStyle/>
+                    <a:p>
+                      <a:pPr algn="ctr"/>
+                      <a:r>
+                        <a:rPr sz="750" b="1">
+                          <a:solidFill>
+                            <a:srgbClr val="142B52"/>
+                          </a:solidFill>
+                          <a:latin typeface="Manrope"/>
+                        </a:rPr>
+                        <a:t>1.940.878</a:t>
+                      </a:r>
+                    </a:p>
+                  </a:txBody>
+                  <a:tcPr marL="54864" marR="54864" marT="18288" marB="18288" anchor="ctr">
+                    <a:solidFill>
+                      <a:srgbClr val="FFFFFF"/>
+                    </a:solidFill>
+                  </a:tcPr>
+                </a:tc>
+                <a:tc>
+                  <a:txBody>
+                    <a:bodyPr/>
+                    <a:lstStyle/>
+                    <a:p>
+                      <a:pPr algn="ctr"/>
+                      <a:r>
+                        <a:rPr sz="750" b="0">
+                          <a:solidFill>
+                            <a:srgbClr val="142B52"/>
+                          </a:solidFill>
+                          <a:latin typeface="Manrope"/>
+                        </a:rPr>
+                        <a:t>1,12%</a:t>
+                      </a:r>
+                    </a:p>
+                  </a:txBody>
+                  <a:tcPr marL="54864" marR="54864" marT="18288" marB="18288" anchor="ctr">
+                    <a:solidFill>
+                      <a:srgbClr val="FFFFFF"/>
+                    </a:solidFill>
+                  </a:tcPr>
+                </a:tc>
+                <a:tc>
+                  <a:txBody>
+                    <a:bodyPr/>
+                    <a:lstStyle/>
+                    <a:p>
+                      <a:pPr algn="ctr"/>
+                      <a:r>
+                        <a:rPr sz="750" b="0">
+                          <a:solidFill>
+                            <a:srgbClr val="142B52"/>
+                          </a:solidFill>
+                          <a:latin typeface="Manrope"/>
+                        </a:rPr>
+                        <a:t>TOP 5 Alcance</a:t>
+                      </a:r>
+                    </a:p>
+                  </a:txBody>
+                  <a:tcPr marL="54864" marR="54864" marT="18288" marB="18288" anchor="ctr">
+                    <a:solidFill>
+                      <a:srgbClr val="FFFFFF"/>
+                    </a:solidFill>
+                  </a:tcPr>
+                </a:tc>
+              </a:tr>
+              <a:tr h="201168">
+                <a:tc>
+                  <a:txBody>
+                    <a:bodyPr/>
+                    <a:lstStyle/>
+                    <a:p>
+                      <a:pPr algn="l"/>
+                      <a:r>
+                        <a:rPr sz="750" b="0">
+                          <a:solidFill>
+                            <a:srgbClr val="142B52"/>
+                          </a:solidFill>
+                          <a:latin typeface="Manrope"/>
+                        </a:rPr>
+                        <a:t>Setembro Amarelo com Dummy</a:t>
+                      </a:r>
+                    </a:p>
+                  </a:txBody>
+                  <a:tcPr marL="54864" marR="54864" marT="18288" marB="18288" anchor="ctr">
+                    <a:solidFill>
+                      <a:srgbClr val="E6EBF3"/>
+                    </a:solidFill>
+                  </a:tcPr>
+                </a:tc>
+                <a:tc>
+                  <a:txBody>
+                    <a:bodyPr/>
+                    <a:lstStyle/>
+                    <a:p>
+                      <a:pPr algn="ctr"/>
+                      <a:r>
+                        <a:rPr sz="750" b="0">
+                          <a:solidFill>
+                            <a:srgbClr val="142B52"/>
+                          </a:solidFill>
+                          <a:latin typeface="Manrope"/>
+                        </a:rPr>
+                        <a:t>META</a:t>
+                      </a:r>
+                    </a:p>
+                  </a:txBody>
+                  <a:tcPr marL="54864" marR="54864" marT="18288" marB="18288" anchor="ctr">
+                    <a:solidFill>
+                      <a:srgbClr val="E6EBF3"/>
+                    </a:solidFill>
+                  </a:tcPr>
+                </a:tc>
+                <a:tc>
+                  <a:txBody>
+                    <a:bodyPr/>
+                    <a:lstStyle/>
+                    <a:p>
+                      <a:pPr algn="ctr"/>
+                      <a:r>
+                        <a:rPr sz="750" b="1">
+                          <a:solidFill>
+                            <a:srgbClr val="142B52"/>
+                          </a:solidFill>
+                          <a:latin typeface="Manrope"/>
+                        </a:rPr>
+                        <a:t>1.853.420</a:t>
+                      </a:r>
+                    </a:p>
+                  </a:txBody>
+                  <a:tcPr marL="54864" marR="54864" marT="18288" marB="18288" anchor="ctr">
+                    <a:solidFill>
+                      <a:srgbClr val="E6EBF3"/>
+                    </a:solidFill>
+                  </a:tcPr>
+                </a:tc>
+                <a:tc>
+                  <a:txBody>
+                    <a:bodyPr/>
+                    <a:lstStyle/>
+                    <a:p>
+                      <a:pPr algn="ctr"/>
+                      <a:r>
+                        <a:rPr sz="750" b="0">
+                          <a:solidFill>
+                            <a:srgbClr val="142B52"/>
+                          </a:solidFill>
+                          <a:latin typeface="Manrope"/>
+                        </a:rPr>
+                        <a:t>0,2%</a:t>
+                      </a:r>
+                    </a:p>
+                  </a:txBody>
+                  <a:tcPr marL="54864" marR="54864" marT="18288" marB="18288" anchor="ctr">
+                    <a:solidFill>
+                      <a:srgbClr val="E6EBF3"/>
+                    </a:solidFill>
+                  </a:tcPr>
+                </a:tc>
+                <a:tc>
+                  <a:txBody>
+                    <a:bodyPr/>
+                    <a:lstStyle/>
+                    <a:p>
+                      <a:pPr algn="ctr"/>
+                      <a:r>
+                        <a:rPr sz="750" b="0">
+                          <a:solidFill>
+                            <a:srgbClr val="142B52"/>
+                          </a:solidFill>
+                          <a:latin typeface="Manrope"/>
+                        </a:rPr>
+                        <a:t>TOP 5 Alcance</a:t>
+                      </a:r>
+                    </a:p>
+                  </a:txBody>
+                  <a:tcPr marL="54864" marR="54864" marT="18288" marB="18288" anchor="ctr">
+                    <a:solidFill>
+                      <a:srgbClr val="E6EBF3"/>
+                    </a:solidFill>
+                  </a:tcPr>
+                </a:tc>
+              </a:tr>
+            </a:tbl>
+          </a:graphicData>
+        </a:graphic>
+      </p:graphicFrame>
       <p:pic>
         <p:nvPicPr>
-          <p:cNvPr id="1184" name="Criativo 1" descr="image.png"/>
-          <p:cNvPicPr>
-            <a:picLocks noChangeAspect="1"/>
-          </p:cNvPicPr>
-          <p:nvPr/>
-        </p:nvPicPr>
-        <p:blipFill>
-          <a:blip r:embed="rId5"/>
-          <a:stretch>
-            <a:fillRect/>
-          </a:stretch>
-        </p:blipFill>
-        <p:spPr>
-          <a:xfrm>
-            <a:off x="411480" y="4709159"/>
-            <a:ext cx="1108858" cy="1737360"/>
-          </a:xfrm>
-          <a:prstGeom prst="rect">
-            <a:avLst/>
-          </a:prstGeom>
-        </p:spPr>
-      </p:pic>
-      <p:pic>
-        <p:nvPicPr>
-          <p:cNvPr id="1185" name="Criativo 2" descr="image.png"/>
+          <p:cNvPr id="1181" name="Story 1" descr="image.png"/>
           <p:cNvPicPr>
             <a:picLocks noChangeAspect="1"/>
           </p:cNvPicPr>
@@ -6482,8 +6604,8 @@
         </p:blipFill>
         <p:spPr>
           <a:xfrm>
-            <a:off x="1691639" y="4709159"/>
-            <a:ext cx="1110478" cy="1737360"/>
+            <a:off x="2926080" y="4251960"/>
+            <a:ext cx="758692" cy="1188720"/>
           </a:xfrm>
           <a:prstGeom prst="rect">
             <a:avLst/>
@@ -6492,7 +6614,7 @@
       </p:pic>
       <p:pic>
         <p:nvPicPr>
-          <p:cNvPr id="1186" name="Criativo 3" descr="image.png"/>
+          <p:cNvPr id="1182" name="Story 2" descr="image.png"/>
           <p:cNvPicPr>
             <a:picLocks noChangeAspect="1"/>
           </p:cNvPicPr>
@@ -6506,8 +6628,8 @@
         </p:blipFill>
         <p:spPr>
           <a:xfrm>
-            <a:off x="2971800" y="4709159"/>
-            <a:ext cx="1052011" cy="1737360"/>
+            <a:off x="3749040" y="4251960"/>
+            <a:ext cx="759800" cy="1188720"/>
           </a:xfrm>
           <a:prstGeom prst="rect">
             <a:avLst/>
@@ -6516,7 +6638,7 @@
       </p:pic>
       <p:pic>
         <p:nvPicPr>
-          <p:cNvPr id="1187" name="Criativo 4" descr="image.png"/>
+          <p:cNvPr id="1183" name="Story 3" descr="image.png"/>
           <p:cNvPicPr>
             <a:picLocks noChangeAspect="1"/>
           </p:cNvPicPr>
@@ -6530,24 +6652,48 @@
         </p:blipFill>
         <p:spPr>
           <a:xfrm>
-            <a:off x="4251959" y="4709159"/>
-            <a:ext cx="1042416" cy="1737360"/>
+            <a:off x="4572000" y="4251960"/>
+            <a:ext cx="719797" cy="1188720"/>
           </a:xfrm>
           <a:prstGeom prst="rect">
             <a:avLst/>
           </a:prstGeom>
         </p:spPr>
       </p:pic>
-      <p:sp>
-        <p:nvSpPr>
-          <p:cNvPr id="1188" name="Legenda criativos"/>
+      <p:pic>
+        <p:nvPicPr>
+          <p:cNvPr id="1184" name="Story 4" descr="image.png"/>
+          <p:cNvPicPr>
+            <a:picLocks noChangeAspect="1"/>
+          </p:cNvPicPr>
+          <p:nvPr/>
+        </p:nvPicPr>
+        <p:blipFill>
+          <a:blip r:embed="rId9"/>
+          <a:stretch>
+            <a:fillRect/>
+          </a:stretch>
+        </p:blipFill>
+        <p:spPr>
+          <a:xfrm>
+            <a:off x="5394960" y="4251960"/>
+            <a:ext cx="713232" cy="1188720"/>
+          </a:xfrm>
+          <a:prstGeom prst="rect">
+            <a:avLst/>
+          </a:prstGeom>
+        </p:spPr>
+      </p:pic>
+      <p:sp>
+        <p:nvSpPr>
+          <p:cNvPr id="1185" name="Rótulo criativo"/>
           <p:cNvSpPr txBox="1"/>
           <p:nvPr/>
         </p:nvSpPr>
         <p:spPr>
           <a:xfrm>
-            <a:off x="411480" y="6537960"/>
-            <a:ext cx="5120640" cy="182880"/>
+            <a:off x="6446520" y="4251960"/>
+            <a:ext cx="1188720" cy="118872"/>
           </a:xfrm>
           <a:prstGeom prst="rect">
             <a:avLst/>
@@ -6562,35 +6708,83 @@
           <a:p>
             <a:pPr algn="l"/>
             <a:r>
-              <a:rPr sz="850" b="0">
+              <a:rPr sz="650" b="1">
                 <a:solidFill>
                   <a:srgbClr val="6B7894"/>
                 </a:solidFill>
                 <a:latin typeface="Manrope"/>
               </a:rPr>
-              <a:t>Stories do Movimento Nacional pela Segurança Ferroviária</a:t>
-            </a:r>
-          </a:p>
-        </p:txBody>
-      </p:sp>
-      <p:sp>
-        <p:nvSpPr>
-          <p:cNvPr id="1189" name="Painel leituras"/>
+              <a:t>CRIATIVO PRINCIPAL</a:t>
+            </a:r>
+          </a:p>
+        </p:txBody>
+      </p:sp>
+      <p:pic>
+        <p:nvPicPr>
+          <p:cNvPr id="1186" name="Criativo principal" descr="image.png"/>
+          <p:cNvPicPr>
+            <a:picLocks noChangeAspect="1"/>
+          </p:cNvPicPr>
+          <p:nvPr/>
+        </p:nvPicPr>
+        <p:blipFill>
+          <a:blip r:embed="rId10"/>
+          <a:stretch>
+            <a:fillRect/>
+          </a:stretch>
+        </p:blipFill>
+        <p:spPr>
+          <a:xfrm>
+            <a:off x="6446520" y="4407408"/>
+            <a:ext cx="1188720" cy="388335"/>
+          </a:xfrm>
+          <a:prstGeom prst="rect">
+            <a:avLst/>
+          </a:prstGeom>
+        </p:spPr>
+      </p:pic>
+      <p:pic>
+        <p:nvPicPr>
+          <p:cNvPr id="1187" name="Banner movimento" descr="image.png"/>
+          <p:cNvPicPr>
+            <a:picLocks noChangeAspect="1"/>
+          </p:cNvPicPr>
+          <p:nvPr/>
+        </p:nvPicPr>
+        <p:blipFill>
+          <a:blip r:embed="rId11"/>
+          <a:stretch>
+            <a:fillRect/>
+          </a:stretch>
+        </p:blipFill>
+        <p:spPr>
+          <a:xfrm>
+            <a:off x="6446520" y="4800600"/>
+            <a:ext cx="1188720" cy="241622"/>
+          </a:xfrm>
+          <a:prstGeom prst="rect">
+            <a:avLst/>
+          </a:prstGeom>
+        </p:spPr>
+      </p:pic>
+      <p:sp>
+        <p:nvSpPr>
+          <p:cNvPr id="1188" name="Seção IMPRENSA"/>
           <p:cNvSpPr/>
           <p:nvPr/>
         </p:nvSpPr>
         <p:spPr>
           <a:xfrm>
-            <a:off x="5806440" y="4434840"/>
-            <a:ext cx="6126480" cy="2057400"/>
+            <a:off x="7863840" y="1892807"/>
+            <a:ext cx="4023360" cy="237744"/>
           </a:xfrm>
           <a:prstGeom prst="roundRect">
             <a:avLst>
-              <a:gd name="adj" fmla="val 6000"/>
+              <a:gd name="adj" fmla="val 30000"/>
             </a:avLst>
           </a:prstGeom>
           <a:solidFill>
-            <a:srgbClr val="E6EBF3"/>
+            <a:srgbClr val="F37919"/>
           </a:solidFill>
           <a:ln>
             <a:noFill/>
@@ -6621,14 +6815,14 @@
       </p:sp>
       <p:sp>
         <p:nvSpPr>
-          <p:cNvPr id="1190" name="Título leituras"/>
+          <p:cNvPr id="1189" name="Seção texto IMPRENSA"/>
           <p:cNvSpPr txBox="1"/>
           <p:nvPr/>
         </p:nvSpPr>
         <p:spPr>
           <a:xfrm>
-            <a:off x="5989320" y="4544568"/>
-            <a:ext cx="3657600" cy="182880"/>
+            <a:off x="7973567" y="1892807"/>
+            <a:ext cx="3840480" cy="237744"/>
           </a:xfrm>
           <a:prstGeom prst="rect">
             <a:avLst/>
@@ -6636,43 +6830,47 @@
           <a:noFill/>
         </p:spPr>
         <p:txBody>
-          <a:bodyPr wrap="square" anchor="t" lIns="0" rIns="0" tIns="0" bIns="0">
+          <a:bodyPr wrap="square" anchor="ctr" lIns="0" rIns="0" tIns="0" bIns="0">
             <a:spAutoFit/>
           </a:bodyPr>
           <a:lstStyle/>
           <a:p>
             <a:pPr algn="l"/>
             <a:r>
-              <a:rPr sz="1000" b="1">
-                <a:solidFill>
-                  <a:srgbClr val="43597E"/>
+              <a:rPr sz="900" b="1">
+                <a:solidFill>
+                  <a:srgbClr val="FFFFFF"/>
                 </a:solidFill>
                 <a:latin typeface="Manrope"/>
               </a:rPr>
-              <a:t>O QUE OS DADOS DIZEM</a:t>
-            </a:r>
-          </a:p>
-        </p:txBody>
-      </p:sp>
-      <p:sp>
-        <p:nvSpPr>
-          <p:cNvPr id="1191" name="Número 1"/>
+              <a:t>IMPRENSA</a:t>
+            </a:r>
+          </a:p>
+        </p:txBody>
+      </p:sp>
+      <p:sp>
+        <p:nvSpPr>
+          <p:cNvPr id="1190" name="Card imprensa"/>
           <p:cNvSpPr/>
           <p:nvPr/>
         </p:nvSpPr>
         <p:spPr>
           <a:xfrm>
-            <a:off x="5989320" y="4818888"/>
-            <a:ext cx="237744" cy="237744"/>
-          </a:xfrm>
-          <a:prstGeom prst="ellipse">
-            <a:avLst/>
+            <a:off x="7863840" y="2212848"/>
+            <a:ext cx="4023360" cy="3227832"/>
+          </a:xfrm>
+          <a:prstGeom prst="roundRect">
+            <a:avLst>
+              <a:gd name="adj" fmla="val 5000"/>
+            </a:avLst>
           </a:prstGeom>
           <a:solidFill>
-            <a:srgbClr val="F37919"/>
+            <a:srgbClr val="FFFFFF"/>
           </a:solidFill>
-          <a:ln>
-            <a:noFill/>
+          <a:ln w="9525">
+            <a:solidFill>
+              <a:srgbClr val="F37919"/>
+            </a:solidFill>
           </a:ln>
           <a:effectLst/>
         </p:spPr>
@@ -6700,49 +6898,14 @@
       </p:sp>
       <p:sp>
         <p:nvSpPr>
-          <p:cNvPr id="1192" name="Num texto 1"/>
+          <p:cNvPr id="1191" name="Imprensa alcance"/>
           <p:cNvSpPr txBox="1"/>
           <p:nvPr/>
         </p:nvSpPr>
         <p:spPr>
           <a:xfrm>
-            <a:off x="5989320" y="4818888"/>
-            <a:ext cx="237744" cy="237744"/>
-          </a:xfrm>
-          <a:prstGeom prst="rect">
-            <a:avLst/>
-          </a:prstGeom>
-          <a:noFill/>
-        </p:spPr>
-        <p:txBody>
-          <a:bodyPr wrap="square" anchor="ctr" lIns="0" rIns="0" tIns="0" bIns="0">
-            <a:spAutoFit/>
-          </a:bodyPr>
-          <a:lstStyle/>
-          <a:p>
-            <a:pPr algn="ctr"/>
-            <a:r>
-              <a:rPr sz="950" b="1">
-                <a:solidFill>
-                  <a:srgbClr val="FFFFFF"/>
-                </a:solidFill>
-                <a:latin typeface="Manrope"/>
-              </a:rPr>
-              <a:t>1</a:t>
-            </a:r>
-          </a:p>
-        </p:txBody>
-      </p:sp>
-      <p:sp>
-        <p:nvSpPr>
-          <p:cNvPr id="1193" name="Leitura 1"/>
-          <p:cNvSpPr txBox="1"/>
-          <p:nvPr/>
-        </p:nvSpPr>
-        <p:spPr>
-          <a:xfrm>
-            <a:off x="6336792" y="4800600"/>
-            <a:ext cx="3154680" cy="548640"/>
+            <a:off x="8001000" y="2249424"/>
+            <a:ext cx="1737360" cy="548640"/>
           </a:xfrm>
           <a:prstGeom prst="rect">
             <a:avLst/>
@@ -6757,42 +6920,70 @@
           <a:p>
             <a:pPr algn="l"/>
             <a:r>
-              <a:rPr sz="900" b="1">
-                <a:solidFill>
-                  <a:srgbClr val="142B52"/>
+              <a:rPr sz="3200" b="1">
+                <a:solidFill>
+                  <a:srgbClr val="F37919"/>
                 </a:solidFill>
                 <a:latin typeface="Manrope"/>
               </a:rPr>
-              <a:t>Imprensa foi o grande ganho. </a:t>
-            </a:r>
-            <a:r>
-              <a:rPr sz="900" b="0">
-                <a:solidFill>
-                  <a:srgbClr val="43597E"/>
+              <a:t>6,3 mi</a:t>
+            </a:r>
+          </a:p>
+        </p:txBody>
+      </p:sp>
+      <p:sp>
+        <p:nvSpPr>
+          <p:cNvPr id="1192" name="Rótulo alcance imprensa"/>
+          <p:cNvSpPr txBox="1"/>
+          <p:nvPr/>
+        </p:nvSpPr>
+        <p:spPr>
+          <a:xfrm>
+            <a:off x="8001000" y="2770632"/>
+            <a:ext cx="1737360" cy="137160"/>
+          </a:xfrm>
+          <a:prstGeom prst="rect">
+            <a:avLst/>
+          </a:prstGeom>
+          <a:noFill/>
+        </p:spPr>
+        <p:txBody>
+          <a:bodyPr wrap="square" anchor="t" lIns="0" rIns="0" tIns="0" bIns="0">
+            <a:spAutoFit/>
+          </a:bodyPr>
+          <a:lstStyle/>
+          <a:p>
+            <a:pPr algn="l"/>
+            <a:r>
+              <a:rPr sz="850" b="0">
+                <a:solidFill>
+                  <a:srgbClr val="6B7894"/>
                 </a:solidFill>
                 <a:latin typeface="Manrope"/>
               </a:rPr>
-              <a:t>Simulado e dados de segurança mobilizaram imprensa e comunidades locais, fortalecendo o IR da VLI em setembro.</a:t>
-            </a:r>
-          </a:p>
-        </p:txBody>
-      </p:sp>
-      <p:sp>
-        <p:nvSpPr>
-          <p:cNvPr id="1194" name="Número 2"/>
+              <a:t>de alcance</a:t>
+            </a:r>
+          </a:p>
+        </p:txBody>
+      </p:sp>
+      <p:sp>
+        <p:nvSpPr>
+          <p:cNvPr id="1193" name="Selo recorde"/>
           <p:cNvSpPr/>
           <p:nvPr/>
         </p:nvSpPr>
         <p:spPr>
           <a:xfrm>
-            <a:off x="5989320" y="5367527"/>
-            <a:ext cx="237744" cy="237744"/>
-          </a:xfrm>
-          <a:prstGeom prst="ellipse">
-            <a:avLst/>
+            <a:off x="8001000" y="2962656"/>
+            <a:ext cx="1463040" cy="182880"/>
+          </a:xfrm>
+          <a:prstGeom prst="roundRect">
+            <a:avLst>
+              <a:gd name="adj" fmla="val 50000"/>
+            </a:avLst>
           </a:prstGeom>
           <a:solidFill>
-            <a:srgbClr val="43597E"/>
+            <a:srgbClr val="F37919"/>
           </a:solidFill>
           <a:ln>
             <a:noFill/>
@@ -6823,14 +7014,14 @@
       </p:sp>
       <p:sp>
         <p:nvSpPr>
-          <p:cNvPr id="1195" name="Num texto 2"/>
+          <p:cNvPr id="1194" name="Selo texto"/>
           <p:cNvSpPr txBox="1"/>
           <p:nvPr/>
         </p:nvSpPr>
         <p:spPr>
           <a:xfrm>
-            <a:off x="5989320" y="5367527"/>
-            <a:ext cx="237744" cy="237744"/>
+            <a:off x="8001000" y="2962656"/>
+            <a:ext cx="1463040" cy="182880"/>
           </a:xfrm>
           <a:prstGeom prst="rect">
             <a:avLst/>
@@ -6845,27 +7036,27 @@
           <a:p>
             <a:pPr algn="ctr"/>
             <a:r>
-              <a:rPr sz="950" b="1">
+              <a:rPr sz="700" b="1">
                 <a:solidFill>
                   <a:srgbClr val="FFFFFF"/>
                 </a:solidFill>
                 <a:latin typeface="Manrope"/>
               </a:rPr>
-              <a:t>2</a:t>
-            </a:r>
-          </a:p>
-        </p:txBody>
-      </p:sp>
-      <p:sp>
-        <p:nvSpPr>
-          <p:cNvPr id="1196" name="Leitura 2"/>
+              <a:t>MAIOR JÁ REGISTRADO</a:t>
+            </a:r>
+          </a:p>
+        </p:txBody>
+      </p:sp>
+      <p:sp>
+        <p:nvSpPr>
+          <p:cNvPr id="1195" name="Imprensa inserções"/>
           <p:cNvSpPr txBox="1"/>
           <p:nvPr/>
         </p:nvSpPr>
         <p:spPr>
           <a:xfrm>
-            <a:off x="6336792" y="5349240"/>
-            <a:ext cx="3154680" cy="548640"/>
+            <a:off x="9738359" y="2267712"/>
+            <a:ext cx="868680" cy="274320"/>
           </a:xfrm>
           <a:prstGeom prst="rect">
             <a:avLst/>
@@ -6880,45 +7071,216 @@
           <a:p>
             <a:pPr algn="l"/>
             <a:r>
-              <a:rPr sz="900" b="1">
+              <a:rPr sz="2200" b="1">
                 <a:solidFill>
                   <a:srgbClr val="142B52"/>
                 </a:solidFill>
                 <a:latin typeface="Manrope"/>
               </a:rPr>
-              <a:t>Mídia paga: eficiência em cliques. </a:t>
-            </a:r>
-            <a:r>
-              <a:rPr sz="900" b="0">
-                <a:solidFill>
-                  <a:srgbClr val="43597E"/>
+              <a:t>69</a:t>
+            </a:r>
+          </a:p>
+        </p:txBody>
+      </p:sp>
+      <p:sp>
+        <p:nvSpPr>
+          <p:cNvPr id="1196" name="Rótulo inserções"/>
+          <p:cNvSpPr txBox="1"/>
+          <p:nvPr/>
+        </p:nvSpPr>
+        <p:spPr>
+          <a:xfrm>
+            <a:off x="9738359" y="2596896"/>
+            <a:ext cx="868680" cy="137160"/>
+          </a:xfrm>
+          <a:prstGeom prst="rect">
+            <a:avLst/>
+          </a:prstGeom>
+          <a:noFill/>
+        </p:spPr>
+        <p:txBody>
+          <a:bodyPr wrap="square" anchor="t" lIns="0" rIns="0" tIns="0" bIns="0">
+            <a:spAutoFit/>
+          </a:bodyPr>
+          <a:lstStyle/>
+          <a:p>
+            <a:pPr algn="l"/>
+            <a:r>
+              <a:rPr sz="850" b="0">
+                <a:solidFill>
+                  <a:srgbClr val="6B7894"/>
                 </a:solidFill>
                 <a:latin typeface="Manrope"/>
               </a:rPr>
-              <a:t>Cliques +26% e seguidores acima do projetado, mesmo com impressões −33%. Público 45+ foi quase metade do alcance.</a:t>
-            </a:r>
-          </a:p>
-        </p:txBody>
-      </p:sp>
-      <p:sp>
-        <p:nvSpPr>
-          <p:cNvPr id="1197" name="Número 3"/>
+              <a:t>inserções</a:t>
+            </a:r>
+          </a:p>
+        </p:txBody>
+      </p:sp>
+      <p:pic>
+        <p:nvPicPr>
+          <p:cNvPr id="1197" name="Imprensa foto 1" descr="image.png"/>
+          <p:cNvPicPr>
+            <a:picLocks noChangeAspect="1"/>
+          </p:cNvPicPr>
+          <p:nvPr/>
+        </p:nvPicPr>
+        <p:blipFill>
+          <a:blip r:embed="rId12"/>
+          <a:stretch>
+            <a:fillRect/>
+          </a:stretch>
+        </p:blipFill>
+        <p:spPr>
+          <a:xfrm>
+            <a:off x="10561320" y="2286000"/>
+            <a:ext cx="690118" cy="868680"/>
+          </a:xfrm>
+          <a:prstGeom prst="rect">
+            <a:avLst/>
+          </a:prstGeom>
+        </p:spPr>
+      </p:pic>
+      <p:pic>
+        <p:nvPicPr>
+          <p:cNvPr id="1198" name="Imprensa foto 2" descr="image.png"/>
+          <p:cNvPicPr>
+            <a:picLocks noChangeAspect="1"/>
+          </p:cNvPicPr>
+          <p:nvPr/>
+        </p:nvPicPr>
+        <p:blipFill>
+          <a:blip r:embed="rId13"/>
+          <a:stretch>
+            <a:fillRect/>
+          </a:stretch>
+        </p:blipFill>
+        <p:spPr>
+          <a:xfrm>
+            <a:off x="11292840" y="2331720"/>
+            <a:ext cx="543143" cy="868680"/>
+          </a:xfrm>
+          <a:prstGeom prst="rect">
+            <a:avLst/>
+          </a:prstGeom>
+        </p:spPr>
+      </p:pic>
+      <p:sp>
+        <p:nvSpPr>
+          <p:cNvPr id="1199" name="Título repercussão"/>
+          <p:cNvSpPr txBox="1"/>
+          <p:nvPr/>
+        </p:nvSpPr>
+        <p:spPr>
+          <a:xfrm>
+            <a:off x="8001000" y="3246120"/>
+            <a:ext cx="3749040" cy="137160"/>
+          </a:xfrm>
+          <a:prstGeom prst="rect">
+            <a:avLst/>
+          </a:prstGeom>
+          <a:noFill/>
+        </p:spPr>
+        <p:txBody>
+          <a:bodyPr wrap="square" anchor="t" lIns="0" rIns="0" tIns="0" bIns="0">
+            <a:spAutoFit/>
+          </a:bodyPr>
+          <a:lstStyle/>
+          <a:p>
+            <a:pPr algn="l"/>
+            <a:r>
+              <a:rPr sz="800" b="1">
+                <a:solidFill>
+                  <a:srgbClr val="F37919"/>
+                </a:solidFill>
+                <a:latin typeface="Manrope"/>
+              </a:rPr>
+              <a:t>O CUIDADO ECOOU EM MAR ABERTO</a:t>
+            </a:r>
+          </a:p>
+        </p:txBody>
+      </p:sp>
+      <p:sp>
+        <p:nvSpPr>
+          <p:cNvPr id="1200" name="Texto repercussão"/>
+          <p:cNvSpPr txBox="1"/>
+          <p:nvPr/>
+        </p:nvSpPr>
+        <p:spPr>
+          <a:xfrm>
+            <a:off x="8001000" y="3401568"/>
+            <a:ext cx="3749040" cy="777240"/>
+          </a:xfrm>
+          <a:prstGeom prst="rect">
+            <a:avLst/>
+          </a:prstGeom>
+          <a:noFill/>
+        </p:spPr>
+        <p:txBody>
+          <a:bodyPr wrap="square" anchor="t" lIns="0" rIns="0" tIns="0" bIns="0">
+            <a:spAutoFit/>
+          </a:bodyPr>
+          <a:lstStyle/>
+          <a:p>
+            <a:pPr algn="l"/>
+            <a:r>
+              <a:rPr sz="800" b="0">
+                <a:solidFill>
+                  <a:srgbClr val="142B52"/>
+                </a:solidFill>
+                <a:latin typeface="Manrope"/>
+              </a:rPr>
+              <a:t>A repercussão positiva mobilizou imprensa e comunidades locais, que compartilharam imagens e comentários sobre o simulado da VLI e dados de segurança, gerando um alcance potencial de </a:t>
+            </a:r>
+            <a:r>
+              <a:rPr sz="800" b="1">
+                <a:solidFill>
+                  <a:srgbClr val="142B52"/>
+                </a:solidFill>
+                <a:latin typeface="Manrope"/>
+              </a:rPr>
+              <a:t>10,8 milhões</a:t>
+            </a:r>
+            <a:r>
+              <a:rPr sz="800" b="0">
+                <a:solidFill>
+                  <a:srgbClr val="142B52"/>
+                </a:solidFill>
+                <a:latin typeface="Manrope"/>
+              </a:rPr>
+              <a:t> nas redes públicas. </a:t>
+            </a:r>
+            <a:r>
+              <a:rPr sz="800" b="1">
+                <a:solidFill>
+                  <a:srgbClr val="142B52"/>
+                </a:solidFill>
+                <a:latin typeface="Manrope"/>
+              </a:rPr>
+              <a:t>Fortaleceu diretamente o IR da VLI em setembro.</a:t>
+            </a:r>
+          </a:p>
+        </p:txBody>
+      </p:sp>
+      <p:sp>
+        <p:nvSpPr>
+          <p:cNvPr id="1201" name="Divisor imprensa"/>
           <p:cNvSpPr/>
           <p:nvPr/>
         </p:nvSpPr>
         <p:spPr>
           <a:xfrm>
-            <a:off x="5989320" y="5916167"/>
-            <a:ext cx="237744" cy="237744"/>
-          </a:xfrm>
-          <a:prstGeom prst="ellipse">
-            <a:avLst/>
-          </a:prstGeom>
-          <a:solidFill>
-            <a:srgbClr val="43597E"/>
-          </a:solidFill>
-          <a:ln>
-            <a:noFill/>
+            <a:off x="8001000" y="4224528"/>
+            <a:ext cx="3749040" cy="0"/>
+          </a:xfrm>
+          <a:prstGeom prst="rect">
+            <a:avLst/>
+          </a:prstGeom>
+          <a:noFill/>
+          <a:ln w="9525">
+            <a:solidFill>
+              <a:srgbClr val="DDE2ED"/>
+            </a:solidFill>
           </a:ln>
           <a:effectLst/>
         </p:spPr>
@@ -6946,14 +7308,196 @@
       </p:sp>
       <p:sp>
         <p:nvSpPr>
-          <p:cNvPr id="1198" name="Num texto 3"/>
+          <p:cNvPr id="1202" name="Título operadoras"/>
           <p:cNvSpPr txBox="1"/>
           <p:nvPr/>
         </p:nvSpPr>
         <p:spPr>
           <a:xfrm>
-            <a:off x="5989320" y="5916167"/>
-            <a:ext cx="237744" cy="237744"/>
+            <a:off x="8001000" y="4297680"/>
+            <a:ext cx="2743200" cy="256032"/>
+          </a:xfrm>
+          <a:prstGeom prst="rect">
+            <a:avLst/>
+          </a:prstGeom>
+          <a:noFill/>
+        </p:spPr>
+        <p:txBody>
+          <a:bodyPr wrap="square" anchor="t" lIns="0" rIns="0" tIns="0" bIns="0">
+            <a:spAutoFit/>
+          </a:bodyPr>
+          <a:lstStyle/>
+          <a:p>
+            <a:pPr algn="l"/>
+            <a:r>
+              <a:rPr sz="800" b="1">
+                <a:solidFill>
+                  <a:srgbClr val="43597E"/>
+                </a:solidFill>
+                <a:latin typeface="Manrope"/>
+              </a:rPr>
+              <a:t>O QUE AS OPERADORAS LOGÍSTICAS TÊM EM COMUM?</a:t>
+            </a:r>
+          </a:p>
+        </p:txBody>
+      </p:sp>
+      <p:sp>
+        <p:nvSpPr>
+          <p:cNvPr id="1203" name="Texto operadoras"/>
+          <p:cNvSpPr txBox="1"/>
+          <p:nvPr/>
+        </p:nvSpPr>
+        <p:spPr>
+          <a:xfrm>
+            <a:off x="8001000" y="4572000"/>
+            <a:ext cx="2468880" cy="822960"/>
+          </a:xfrm>
+          <a:prstGeom prst="rect">
+            <a:avLst/>
+          </a:prstGeom>
+          <a:noFill/>
+        </p:spPr>
+        <p:txBody>
+          <a:bodyPr wrap="square" anchor="t" lIns="0" rIns="0" tIns="0" bIns="0">
+            <a:spAutoFit/>
+          </a:bodyPr>
+          <a:lstStyle/>
+          <a:p>
+            <a:pPr algn="l"/>
+            <a:r>
+              <a:rPr sz="800" b="0">
+                <a:solidFill>
+                  <a:srgbClr val="142B52"/>
+                </a:solidFill>
+                <a:latin typeface="Manrope"/>
+              </a:rPr>
+              <a:t>VLI, ANTF, Rumo, MRS, Brado e FIPS falaram a mesma língua: os posts Collab do Movimento ultrapassaram </a:t>
+            </a:r>
+            <a:r>
+              <a:rPr sz="800" b="1">
+                <a:solidFill>
+                  <a:srgbClr val="142B52"/>
+                </a:solidFill>
+                <a:latin typeface="Manrope"/>
+              </a:rPr>
+              <a:t>155 mil visualizações orgânicas</a:t>
+            </a:r>
+            <a:r>
+              <a:rPr sz="800" b="0">
+                <a:solidFill>
+                  <a:srgbClr val="142B52"/>
+                </a:solidFill>
+                <a:latin typeface="Manrope"/>
+              </a:rPr>
+              <a:t>, prova de que o cuidado com a vida nos trilhos é um propósito de todo o setor.</a:t>
+            </a:r>
+          </a:p>
+        </p:txBody>
+      </p:sp>
+      <p:pic>
+        <p:nvPicPr>
+          <p:cNvPr id="1204" name="Collab 1" descr="image.png"/>
+          <p:cNvPicPr>
+            <a:picLocks noChangeAspect="1"/>
+          </p:cNvPicPr>
+          <p:nvPr/>
+        </p:nvPicPr>
+        <p:blipFill>
+          <a:blip r:embed="rId14"/>
+          <a:stretch>
+            <a:fillRect/>
+          </a:stretch>
+        </p:blipFill>
+        <p:spPr>
+          <a:xfrm>
+            <a:off x="10469880" y="4343400"/>
+            <a:ext cx="649554" cy="868680"/>
+          </a:xfrm>
+          <a:prstGeom prst="rect">
+            <a:avLst/>
+          </a:prstGeom>
+        </p:spPr>
+      </p:pic>
+      <p:pic>
+        <p:nvPicPr>
+          <p:cNvPr id="1205" name="Collab 2" descr="image.png"/>
+          <p:cNvPicPr>
+            <a:picLocks noChangeAspect="1"/>
+          </p:cNvPicPr>
+          <p:nvPr/>
+        </p:nvPicPr>
+        <p:blipFill>
+          <a:blip r:embed="rId15"/>
+          <a:stretch>
+            <a:fillRect/>
+          </a:stretch>
+        </p:blipFill>
+        <p:spPr>
+          <a:xfrm>
+            <a:off x="11155680" y="4343400"/>
+            <a:ext cx="644336" cy="868680"/>
+          </a:xfrm>
+          <a:prstGeom prst="rect">
+            <a:avLst/>
+          </a:prstGeom>
+        </p:spPr>
+      </p:pic>
+      <p:sp>
+        <p:nvSpPr>
+          <p:cNvPr id="1206" name="Seção COMUNICAÇÃO INTERNA  |  Jornada integrada: E-mail MKT + ZAP + Intranet"/>
+          <p:cNvSpPr/>
+          <p:nvPr/>
+        </p:nvSpPr>
+        <p:spPr>
+          <a:xfrm>
+            <a:off x="301752" y="5559552"/>
+            <a:ext cx="11585448" cy="237744"/>
+          </a:xfrm>
+          <a:prstGeom prst="roundRect">
+            <a:avLst>
+              <a:gd name="adj" fmla="val 30000"/>
+            </a:avLst>
+          </a:prstGeom>
+          <a:solidFill>
+            <a:srgbClr val="43597E"/>
+          </a:solidFill>
+          <a:ln>
+            <a:noFill/>
+          </a:ln>
+          <a:effectLst/>
+        </p:spPr>
+        <p:style>
+          <a:lnRef idx="1">
+            <a:schemeClr val="accent1"/>
+          </a:lnRef>
+          <a:fillRef idx="3">
+            <a:schemeClr val="accent1"/>
+          </a:fillRef>
+          <a:effectRef idx="2">
+            <a:schemeClr val="accent1"/>
+          </a:effectRef>
+          <a:fontRef idx="minor">
+            <a:schemeClr val="lt1"/>
+          </a:fontRef>
+        </p:style>
+        <p:txBody>
+          <a:bodyPr rtlCol="0" anchor="ctr"/>
+          <a:lstStyle/>
+          <a:p>
+            <a:pPr algn="ctr"/>
+          </a:p>
+        </p:txBody>
+      </p:sp>
+      <p:sp>
+        <p:nvSpPr>
+          <p:cNvPr id="1207" name="Seção texto COMUNICAÇÃO INTERNA  |  Jornada integrada: E-mail MKT + ZAP + Intranet"/>
+          <p:cNvSpPr txBox="1"/>
+          <p:nvPr/>
+        </p:nvSpPr>
+        <p:spPr>
+          <a:xfrm>
+            <a:off x="411480" y="5559552"/>
+            <a:ext cx="11402568" cy="237744"/>
           </a:xfrm>
           <a:prstGeom prst="rect">
             <a:avLst/>
@@ -6966,29 +7510,77 @@
           </a:bodyPr>
           <a:lstStyle/>
           <a:p>
-            <a:pPr algn="ctr"/>
-            <a:r>
-              <a:rPr sz="950" b="1">
+            <a:pPr algn="l"/>
+            <a:r>
+              <a:rPr sz="900" b="1">
                 <a:solidFill>
                   <a:srgbClr val="FFFFFF"/>
                 </a:solidFill>
                 <a:latin typeface="Manrope"/>
               </a:rPr>
-              <a:t>3</a:t>
-            </a:r>
-          </a:p>
-        </p:txBody>
-      </p:sp>
-      <p:sp>
-        <p:nvSpPr>
-          <p:cNvPr id="1199" name="Leitura 3"/>
+              <a:t>COMUNICAÇÃO INTERNA  |  Jornada integrada: E-mail MKT + ZAP + Intranet</a:t>
+            </a:r>
+          </a:p>
+        </p:txBody>
+      </p:sp>
+      <p:sp>
+        <p:nvSpPr>
+          <p:cNvPr id="1208" name="Canal E-MAIL MKT"/>
+          <p:cNvSpPr/>
+          <p:nvPr/>
+        </p:nvSpPr>
+        <p:spPr>
+          <a:xfrm>
+            <a:off x="301752" y="5852160"/>
+            <a:ext cx="2258568" cy="822960"/>
+          </a:xfrm>
+          <a:prstGeom prst="roundRect">
+            <a:avLst>
+              <a:gd name="adj" fmla="val 5000"/>
+            </a:avLst>
+          </a:prstGeom>
+          <a:solidFill>
+            <a:srgbClr val="FFFFFF"/>
+          </a:solidFill>
+          <a:ln w="9525">
+            <a:solidFill>
+              <a:srgbClr val="DDE2ED"/>
+            </a:solidFill>
+          </a:ln>
+          <a:effectLst/>
+        </p:spPr>
+        <p:style>
+          <a:lnRef idx="1">
+            <a:schemeClr val="accent1"/>
+          </a:lnRef>
+          <a:fillRef idx="3">
+            <a:schemeClr val="accent1"/>
+          </a:fillRef>
+          <a:effectRef idx="2">
+            <a:schemeClr val="accent1"/>
+          </a:effectRef>
+          <a:fontRef idx="minor">
+            <a:schemeClr val="lt1"/>
+          </a:fontRef>
+        </p:style>
+        <p:txBody>
+          <a:bodyPr rtlCol="0" anchor="ctr"/>
+          <a:lstStyle/>
+          <a:p>
+            <a:pPr algn="ctr"/>
+          </a:p>
+        </p:txBody>
+      </p:sp>
+      <p:sp>
+        <p:nvSpPr>
+          <p:cNvPr id="1209" name="Canal rótulo E-MAIL MKT"/>
           <p:cNvSpPr txBox="1"/>
           <p:nvPr/>
         </p:nvSpPr>
         <p:spPr>
           <a:xfrm>
-            <a:off x="6336792" y="5897879"/>
-            <a:ext cx="3154680" cy="548640"/>
+            <a:off x="393192" y="5897880"/>
+            <a:ext cx="2103120" cy="128016"/>
           </a:xfrm>
           <a:prstGeom prst="rect">
             <a:avLst/>
@@ -7003,36 +7595,27 @@
           <a:p>
             <a:pPr algn="l"/>
             <a:r>
-              <a:rPr sz="900" b="1">
-                <a:solidFill>
-                  <a:srgbClr val="142B52"/>
+              <a:rPr sz="750" b="1">
+                <a:solidFill>
+                  <a:srgbClr val="43597E"/>
                 </a:solidFill>
                 <a:latin typeface="Manrope"/>
               </a:rPr>
-              <a:t>Interna: tema forte, execução pontual. </a:t>
-            </a:r>
-            <a:r>
-              <a:rPr sz="900" b="0">
-                <a:solidFill>
-                  <a:srgbClr val="43597E"/>
-                </a:solidFill>
-                <a:latin typeface="Manrope"/>
-              </a:rPr>
-              <a:t>No ZAP, mesmo volume de envios (4.046): 9,1% de interações contra 24,6% da Virada MFA. Faltou jornada contínua.</a:t>
-            </a:r>
-          </a:p>
-        </p:txBody>
-      </p:sp>
-      <p:sp>
-        <p:nvSpPr>
-          <p:cNvPr id="1200" name="Título gráfico"/>
+              <a:t>E-MAIL MKT</a:t>
+            </a:r>
+          </a:p>
+        </p:txBody>
+      </p:sp>
+      <p:sp>
+        <p:nvSpPr>
+          <p:cNvPr id="1210" name="Canal KPI E-MAIL MKT"/>
           <p:cNvSpPr txBox="1"/>
           <p:nvPr/>
         </p:nvSpPr>
         <p:spPr>
           <a:xfrm>
-            <a:off x="9646920" y="4544568"/>
-            <a:ext cx="2148840" cy="310896"/>
+            <a:off x="393192" y="6035040"/>
+            <a:ext cx="2103120" cy="274320"/>
           </a:xfrm>
           <a:prstGeom prst="rect">
             <a:avLst/>
@@ -7047,45 +7630,36 @@
           <a:p>
             <a:pPr algn="l"/>
             <a:r>
-              <a:rPr sz="900" b="1">
-                <a:solidFill>
-                  <a:srgbClr val="43597E"/>
+              <a:rPr sz="1700" b="1">
+                <a:solidFill>
+                  <a:srgbClr val="142B52"/>
                 </a:solidFill>
                 <a:latin typeface="Manrope"/>
               </a:rPr>
-              <a:t>ZAP: % de interações por disparo</a:t>
-            </a:r>
-          </a:p>
-        </p:txBody>
-      </p:sp>
-      <p:graphicFrame>
-        <p:nvGraphicFramePr>
-          <p:cNvPr id="1201" name="Gráfico ZAP"/>
-          <p:cNvGraphicFramePr>
-            <a:graphicFrameLocks noGrp="1"/>
-          </p:cNvGraphicFramePr>
-          <p:nvPr/>
-        </p:nvGraphicFramePr>
-        <p:xfrm>
-          <a:off x="9555480" y="4892040"/>
-          <a:ext cx="2286000" cy="1508760"/>
-        </p:xfrm>
-        <a:graphic>
-          <a:graphicData uri="http://schemas.openxmlformats.org/drawingml/2006/chart">
-            <c:chart xmlns:c="http://schemas.openxmlformats.org/drawingml/2006/chart" r:id="rId9"/>
-          </a:graphicData>
-        </a:graphic>
-      </p:graphicFrame>
-      <p:sp>
-        <p:nvSpPr>
-          <p:cNvPr id="1202" name="Fonte"/>
+              <a:t>16,7%</a:t>
+            </a:r>
+            <a:r>
+              <a:rPr sz="850" b="0">
+                <a:solidFill>
+                  <a:srgbClr val="6B7894"/>
+                </a:solidFill>
+                <a:latin typeface="Manrope"/>
+              </a:rPr>
+              <a:t>  abertura</a:t>
+            </a:r>
+          </a:p>
+        </p:txBody>
+      </p:sp>
+      <p:sp>
+        <p:nvSpPr>
+          <p:cNvPr id="1211" name="Canal detalhe E-MAIL MKT"/>
           <p:cNvSpPr txBox="1"/>
           <p:nvPr/>
         </p:nvSpPr>
         <p:spPr>
           <a:xfrm>
-            <a:off x="5806440" y="6537960"/>
-            <a:ext cx="6126480" cy="182880"/>
+            <a:off x="393192" y="6345936"/>
+            <a:ext cx="2103120" cy="310896"/>
           </a:xfrm>
           <a:prstGeom prst="rect">
             <a:avLst/>
@@ -7098,15 +7672,493 @@
           </a:bodyPr>
           <a:lstStyle/>
           <a:p>
-            <a:pPr algn="r"/>
-            <a:r>
-              <a:rPr sz="800" b="0">
+            <a:pPr algn="l"/>
+            <a:r>
+              <a:rPr sz="750" b="0">
                 <a:solidFill>
                   <a:srgbClr val="6B7894"/>
                 </a:solidFill>
                 <a:latin typeface="Manrope"/>
               </a:rPr>
-              <a:t>Fontes: ANR SNT (Komuh) e Relatório de Comunicação Interna, setembro. Projeções referem-se ao planejado da campanha.</a:t>
+              <a:t>4.794 enviados · 4.345 entregues · 727 aberturas únicas · 50 cliques</a:t>
+            </a:r>
+          </a:p>
+        </p:txBody>
+      </p:sp>
+      <p:sp>
+        <p:nvSpPr>
+          <p:cNvPr id="1212" name="Canal ZAP VLI"/>
+          <p:cNvSpPr/>
+          <p:nvPr/>
+        </p:nvSpPr>
+        <p:spPr>
+          <a:xfrm>
+            <a:off x="2633472" y="5852160"/>
+            <a:ext cx="2258568" cy="822960"/>
+          </a:xfrm>
+          <a:prstGeom prst="roundRect">
+            <a:avLst>
+              <a:gd name="adj" fmla="val 5000"/>
+            </a:avLst>
+          </a:prstGeom>
+          <a:solidFill>
+            <a:srgbClr val="FFFFFF"/>
+          </a:solidFill>
+          <a:ln w="9525">
+            <a:solidFill>
+              <a:srgbClr val="DDE2ED"/>
+            </a:solidFill>
+          </a:ln>
+          <a:effectLst/>
+        </p:spPr>
+        <p:style>
+          <a:lnRef idx="1">
+            <a:schemeClr val="accent1"/>
+          </a:lnRef>
+          <a:fillRef idx="3">
+            <a:schemeClr val="accent1"/>
+          </a:fillRef>
+          <a:effectRef idx="2">
+            <a:schemeClr val="accent1"/>
+          </a:effectRef>
+          <a:fontRef idx="minor">
+            <a:schemeClr val="lt1"/>
+          </a:fontRef>
+        </p:style>
+        <p:txBody>
+          <a:bodyPr rtlCol="0" anchor="ctr"/>
+          <a:lstStyle/>
+          <a:p>
+            <a:pPr algn="ctr"/>
+          </a:p>
+        </p:txBody>
+      </p:sp>
+      <p:sp>
+        <p:nvSpPr>
+          <p:cNvPr id="1213" name="Canal rótulo ZAP VLI"/>
+          <p:cNvSpPr txBox="1"/>
+          <p:nvPr/>
+        </p:nvSpPr>
+        <p:spPr>
+          <a:xfrm>
+            <a:off x="2724912" y="5897880"/>
+            <a:ext cx="2103120" cy="128016"/>
+          </a:xfrm>
+          <a:prstGeom prst="rect">
+            <a:avLst/>
+          </a:prstGeom>
+          <a:noFill/>
+        </p:spPr>
+        <p:txBody>
+          <a:bodyPr wrap="square" anchor="t" lIns="0" rIns="0" tIns="0" bIns="0">
+            <a:spAutoFit/>
+          </a:bodyPr>
+          <a:lstStyle/>
+          <a:p>
+            <a:pPr algn="l"/>
+            <a:r>
+              <a:rPr sz="750" b="1">
+                <a:solidFill>
+                  <a:srgbClr val="43597E"/>
+                </a:solidFill>
+                <a:latin typeface="Manrope"/>
+              </a:rPr>
+              <a:t>ZAP VLI</a:t>
+            </a:r>
+          </a:p>
+        </p:txBody>
+      </p:sp>
+      <p:sp>
+        <p:nvSpPr>
+          <p:cNvPr id="1214" name="Canal KPI ZAP VLI"/>
+          <p:cNvSpPr txBox="1"/>
+          <p:nvPr/>
+        </p:nvSpPr>
+        <p:spPr>
+          <a:xfrm>
+            <a:off x="2724912" y="6035040"/>
+            <a:ext cx="2103120" cy="274320"/>
+          </a:xfrm>
+          <a:prstGeom prst="rect">
+            <a:avLst/>
+          </a:prstGeom>
+          <a:noFill/>
+        </p:spPr>
+        <p:txBody>
+          <a:bodyPr wrap="square" anchor="t" lIns="0" rIns="0" tIns="0" bIns="0">
+            <a:spAutoFit/>
+          </a:bodyPr>
+          <a:lstStyle/>
+          <a:p>
+            <a:pPr algn="l"/>
+            <a:r>
+              <a:rPr sz="1700" b="1">
+                <a:solidFill>
+                  <a:srgbClr val="142B52"/>
+                </a:solidFill>
+                <a:latin typeface="Manrope"/>
+              </a:rPr>
+              <a:t>56,5%</a:t>
+            </a:r>
+            <a:r>
+              <a:rPr sz="850" b="0">
+                <a:solidFill>
+                  <a:srgbClr val="6B7894"/>
+                </a:solidFill>
+                <a:latin typeface="Manrope"/>
+              </a:rPr>
+              <a:t>  leitura</a:t>
+            </a:r>
+          </a:p>
+        </p:txBody>
+      </p:sp>
+      <p:sp>
+        <p:nvSpPr>
+          <p:cNvPr id="1215" name="Canal detalhe ZAP VLI"/>
+          <p:cNvSpPr txBox="1"/>
+          <p:nvPr/>
+        </p:nvSpPr>
+        <p:spPr>
+          <a:xfrm>
+            <a:off x="2724912" y="6345936"/>
+            <a:ext cx="2103120" cy="310896"/>
+          </a:xfrm>
+          <a:prstGeom prst="rect">
+            <a:avLst/>
+          </a:prstGeom>
+          <a:noFill/>
+        </p:spPr>
+        <p:txBody>
+          <a:bodyPr wrap="square" anchor="t" lIns="0" rIns="0" tIns="0" bIns="0">
+            <a:spAutoFit/>
+          </a:bodyPr>
+          <a:lstStyle/>
+          <a:p>
+            <a:pPr algn="l"/>
+            <a:r>
+              <a:rPr sz="750" b="0">
+                <a:solidFill>
+                  <a:srgbClr val="6B7894"/>
+                </a:solidFill>
+                <a:latin typeface="Manrope"/>
+              </a:rPr>
+              <a:t>3.516 recebidas · 1.985 leituras · 181 interações (9,1%)</a:t>
+            </a:r>
+          </a:p>
+        </p:txBody>
+      </p:sp>
+      <p:sp>
+        <p:nvSpPr>
+          <p:cNvPr id="1216" name="Canal INTRANET VLI@"/>
+          <p:cNvSpPr/>
+          <p:nvPr/>
+        </p:nvSpPr>
+        <p:spPr>
+          <a:xfrm>
+            <a:off x="4965192" y="5852160"/>
+            <a:ext cx="2258568" cy="822960"/>
+          </a:xfrm>
+          <a:prstGeom prst="roundRect">
+            <a:avLst>
+              <a:gd name="adj" fmla="val 5000"/>
+            </a:avLst>
+          </a:prstGeom>
+          <a:solidFill>
+            <a:srgbClr val="FFFFFF"/>
+          </a:solidFill>
+          <a:ln w="9525">
+            <a:solidFill>
+              <a:srgbClr val="DDE2ED"/>
+            </a:solidFill>
+          </a:ln>
+          <a:effectLst/>
+        </p:spPr>
+        <p:style>
+          <a:lnRef idx="1">
+            <a:schemeClr val="accent1"/>
+          </a:lnRef>
+          <a:fillRef idx="3">
+            <a:schemeClr val="accent1"/>
+          </a:fillRef>
+          <a:effectRef idx="2">
+            <a:schemeClr val="accent1"/>
+          </a:effectRef>
+          <a:fontRef idx="minor">
+            <a:schemeClr val="lt1"/>
+          </a:fontRef>
+        </p:style>
+        <p:txBody>
+          <a:bodyPr rtlCol="0" anchor="ctr"/>
+          <a:lstStyle/>
+          <a:p>
+            <a:pPr algn="ctr"/>
+          </a:p>
+        </p:txBody>
+      </p:sp>
+      <p:sp>
+        <p:nvSpPr>
+          <p:cNvPr id="1217" name="Canal rótulo INTRANET VLI@"/>
+          <p:cNvSpPr txBox="1"/>
+          <p:nvPr/>
+        </p:nvSpPr>
+        <p:spPr>
+          <a:xfrm>
+            <a:off x="5056631" y="5897880"/>
+            <a:ext cx="2103120" cy="128016"/>
+          </a:xfrm>
+          <a:prstGeom prst="rect">
+            <a:avLst/>
+          </a:prstGeom>
+          <a:noFill/>
+        </p:spPr>
+        <p:txBody>
+          <a:bodyPr wrap="square" anchor="t" lIns="0" rIns="0" tIns="0" bIns="0">
+            <a:spAutoFit/>
+          </a:bodyPr>
+          <a:lstStyle/>
+          <a:p>
+            <a:pPr algn="l"/>
+            <a:r>
+              <a:rPr sz="750" b="1">
+                <a:solidFill>
+                  <a:srgbClr val="43597E"/>
+                </a:solidFill>
+                <a:latin typeface="Manrope"/>
+              </a:rPr>
+              <a:t>INTRANET VLI@</a:t>
+            </a:r>
+          </a:p>
+        </p:txBody>
+      </p:sp>
+      <p:sp>
+        <p:nvSpPr>
+          <p:cNvPr id="1218" name="Canal KPI INTRANET VLI@"/>
+          <p:cNvSpPr txBox="1"/>
+          <p:nvPr/>
+        </p:nvSpPr>
+        <p:spPr>
+          <a:xfrm>
+            <a:off x="5056631" y="6035040"/>
+            <a:ext cx="2103120" cy="274320"/>
+          </a:xfrm>
+          <a:prstGeom prst="rect">
+            <a:avLst/>
+          </a:prstGeom>
+          <a:noFill/>
+        </p:spPr>
+        <p:txBody>
+          <a:bodyPr wrap="square" anchor="t" lIns="0" rIns="0" tIns="0" bIns="0">
+            <a:spAutoFit/>
+          </a:bodyPr>
+          <a:lstStyle/>
+          <a:p>
+            <a:pPr algn="l"/>
+            <a:r>
+              <a:rPr sz="1700" b="1">
+                <a:solidFill>
+                  <a:srgbClr val="142B52"/>
+                </a:solidFill>
+                <a:latin typeface="Manrope"/>
+              </a:rPr>
+              <a:t>114</a:t>
+            </a:r>
+            <a:r>
+              <a:rPr sz="850" b="0">
+                <a:solidFill>
+                  <a:srgbClr val="6B7894"/>
+                </a:solidFill>
+                <a:latin typeface="Manrope"/>
+              </a:rPr>
+              <a:t>  exibições</a:t>
+            </a:r>
+          </a:p>
+        </p:txBody>
+      </p:sp>
+      <p:sp>
+        <p:nvSpPr>
+          <p:cNvPr id="1219" name="Canal detalhe INTRANET VLI@"/>
+          <p:cNvSpPr txBox="1"/>
+          <p:nvPr/>
+        </p:nvSpPr>
+        <p:spPr>
+          <a:xfrm>
+            <a:off x="5056631" y="6345936"/>
+            <a:ext cx="2103120" cy="310896"/>
+          </a:xfrm>
+          <a:prstGeom prst="rect">
+            <a:avLst/>
+          </a:prstGeom>
+          <a:noFill/>
+        </p:spPr>
+        <p:txBody>
+          <a:bodyPr wrap="square" anchor="t" lIns="0" rIns="0" tIns="0" bIns="0">
+            <a:spAutoFit/>
+          </a:bodyPr>
+          <a:lstStyle/>
+          <a:p>
+            <a:pPr algn="l"/>
+            <a:r>
+              <a:rPr sz="750" b="0">
+                <a:solidFill>
+                  <a:srgbClr val="6B7894"/>
+                </a:solidFill>
+                <a:latin typeface="Manrope"/>
+              </a:rPr>
+              <a:t>Matéria com ações educativas e dicas para o trânsito</a:t>
+            </a:r>
+          </a:p>
+        </p:txBody>
+      </p:sp>
+      <p:sp>
+        <p:nvSpPr>
+          <p:cNvPr id="1220" name="Leitura interna"/>
+          <p:cNvSpPr/>
+          <p:nvPr/>
+        </p:nvSpPr>
+        <p:spPr>
+          <a:xfrm>
+            <a:off x="7296912" y="5852160"/>
+            <a:ext cx="4590288" cy="822960"/>
+          </a:xfrm>
+          <a:prstGeom prst="roundRect">
+            <a:avLst>
+              <a:gd name="adj" fmla="val 5000"/>
+            </a:avLst>
+          </a:prstGeom>
+          <a:solidFill>
+            <a:srgbClr val="E6EBF3"/>
+          </a:solidFill>
+          <a:ln>
+            <a:noFill/>
+          </a:ln>
+          <a:effectLst/>
+        </p:spPr>
+        <p:style>
+          <a:lnRef idx="1">
+            <a:schemeClr val="accent1"/>
+          </a:lnRef>
+          <a:fillRef idx="3">
+            <a:schemeClr val="accent1"/>
+          </a:fillRef>
+          <a:effectRef idx="2">
+            <a:schemeClr val="accent1"/>
+          </a:effectRef>
+          <a:fontRef idx="minor">
+            <a:schemeClr val="lt1"/>
+          </a:fontRef>
+        </p:style>
+        <p:txBody>
+          <a:bodyPr rtlCol="0" anchor="ctr"/>
+          <a:lstStyle/>
+          <a:p>
+            <a:pPr algn="ctr"/>
+          </a:p>
+        </p:txBody>
+      </p:sp>
+      <p:sp>
+        <p:nvSpPr>
+          <p:cNvPr id="1221" name="Leitura interna texto"/>
+          <p:cNvSpPr txBox="1"/>
+          <p:nvPr/>
+        </p:nvSpPr>
+        <p:spPr>
+          <a:xfrm>
+            <a:off x="7406640" y="5897880"/>
+            <a:ext cx="4389120" cy="749808"/>
+          </a:xfrm>
+          <a:prstGeom prst="rect">
+            <a:avLst/>
+          </a:prstGeom>
+          <a:noFill/>
+        </p:spPr>
+        <p:txBody>
+          <a:bodyPr wrap="square" anchor="t" lIns="0" rIns="0" tIns="0" bIns="0">
+            <a:spAutoFit/>
+          </a:bodyPr>
+          <a:lstStyle/>
+          <a:p>
+            <a:pPr algn="l">
+              <a:spcAft>
+                <a:spcPts val="200"/>
+              </a:spcAft>
+            </a:pPr>
+            <a:r>
+              <a:rPr sz="800" b="1">
+                <a:solidFill>
+                  <a:srgbClr val="F37919"/>
+                </a:solidFill>
+                <a:latin typeface="Manrope"/>
+              </a:rPr>
+              <a:t>Leitura: </a:t>
+            </a:r>
+            <a:r>
+              <a:rPr sz="800" b="0">
+                <a:solidFill>
+                  <a:srgbClr val="142B52"/>
+                </a:solidFill>
+                <a:latin typeface="Manrope"/>
+              </a:rPr>
+              <a:t>com o mesmo volume de envios da Virada MFA (4.046), a SNT teve 9,1% de interações no ZAP contra 24,6%.</a:t>
+            </a:r>
+          </a:p>
+          <a:p>
+            <a:pPr algn="l">
+              <a:spcAft>
+                <a:spcPts val="200"/>
+              </a:spcAft>
+            </a:pPr>
+            <a:r>
+              <a:rPr sz="800" b="1">
+                <a:solidFill>
+                  <a:srgbClr val="F37919"/>
+                </a:solidFill>
+                <a:latin typeface="Manrope"/>
+              </a:rPr>
+              <a:t>Oportunidade: </a:t>
+            </a:r>
+            <a:r>
+              <a:rPr sz="800" b="0">
+                <a:solidFill>
+                  <a:srgbClr val="142B52"/>
+                </a:solidFill>
+                <a:latin typeface="Manrope"/>
+              </a:rPr>
+              <a:t>transformar a pauta em jornada contínua ao longo da semana, com histórias reais e depoimentos de empregados.</a:t>
+            </a:r>
+          </a:p>
+        </p:txBody>
+      </p:sp>
+      <p:sp>
+        <p:nvSpPr>
+          <p:cNvPr id="1222" name="Rodapé"/>
+          <p:cNvSpPr txBox="1"/>
+          <p:nvPr/>
+        </p:nvSpPr>
+        <p:spPr>
+          <a:xfrm>
+            <a:off x="301752" y="6702552"/>
+            <a:ext cx="11585448" cy="128016"/>
+          </a:xfrm>
+          <a:prstGeom prst="rect">
+            <a:avLst/>
+          </a:prstGeom>
+          <a:noFill/>
+        </p:spPr>
+        <p:txBody>
+          <a:bodyPr wrap="square" anchor="t" lIns="0" rIns="0" tIns="0" bIns="0">
+            <a:spAutoFit/>
+          </a:bodyPr>
+          <a:lstStyle/>
+          <a:p>
+            <a:pPr algn="l"/>
+            <a:r>
+              <a:rPr sz="700" b="0">
+                <a:solidFill>
+                  <a:srgbClr val="6B7894"/>
+                </a:solidFill>
+                <a:latin typeface="Manrope"/>
+              </a:rPr>
+              <a:t>Custo: orçamento inicial de R$ 60 mil; realizado em torno de R$ 35 mil (economia ≈ R$ 25 mil). Mídia líquida: on R$ 10.539,60 + off R$ 5.738,01. Fontes: ANR SNT e Relatório de Comunicação Interna, setembro.</a:t>
             </a:r>
           </a:p>
         </p:txBody>

</xml_diff>

<commit_message>
SNT summary: move repercussão to digital orgânico, add cost vs previous campaign
Co-Authored-By: Claude Sonnet 5.5 <noreply@anthropic.com>
Claude-Session: https://claude.ai/code/session_01Y8xeok1NgQ689Ht8iSN8YH
</commit_message>
<xml_diff>
--- a/ANR_SNT_executivo.pptx
+++ b/ANR_SNT_executivo.pptx
@@ -557,7 +557,7 @@
           <a:lstStyle/>
           <a:p>
             <a:r>
-              <a:t>Quadro resumo SNT: Digital (mídia on/off), Imprensa (69 inserções, 6,3 mi de alcance, recorde), Comunicação Interna e contenção de custo (R$ 60 mil orçados, ~R$ 35 mil realizados).</a:t>
+              <a:t>Quadro resumo SNT: Digital (mídia on/off), Imprensa (69 inserções, 6,3 mi de alcance, recorde), Comunicação Interna e contenção de custo (R$ 60 mil orçados, ~R$ 35 mil realizados; −70% vs última campanha de R$ 115 mil).</a:t>
             </a:r>
           </a:p>
         </p:txBody>
@@ -4437,14 +4437,14 @@
                 </a:solidFill>
                 <a:latin typeface="Manrope"/>
               </a:rPr>
-              <a:t>10,8 mi de alcance potencial</a:t>
-            </a:r>
-          </a:p>
-        </p:txBody>
-      </p:sp>
-      <p:sp>
-        <p:nvSpPr>
-          <p:cNvPr id="1137" name="Tile alcance digital (mídia on)"/>
+              <a:t>clipping da SNT</a:t>
+            </a:r>
+          </a:p>
+        </p:txBody>
+      </p:sp>
+      <p:sp>
+        <p:nvSpPr>
+          <p:cNvPr id="1137" name="Tile repercussão digital orgânica"/>
           <p:cNvSpPr/>
           <p:nvPr/>
         </p:nvSpPr>
@@ -4492,7 +4492,7 @@
       </p:sp>
       <p:sp>
         <p:nvSpPr>
-          <p:cNvPr id="1138" name="Big alcance digital (mídia on)"/>
+          <p:cNvPr id="1138" name="Big repercussão digital orgânica"/>
           <p:cNvSpPr txBox="1"/>
           <p:nvPr/>
         </p:nvSpPr>
@@ -4520,14 +4520,14 @@
                 </a:solidFill>
                 <a:latin typeface="Manrope"/>
               </a:rPr>
-              <a:t>1,36 mi</a:t>
-            </a:r>
-          </a:p>
-        </p:txBody>
-      </p:sp>
-      <p:sp>
-        <p:nvSpPr>
-          <p:cNvPr id="1139" name="Rótulo alcance digital (mídia on)"/>
+              <a:t>10,8 mi</a:t>
+            </a:r>
+          </a:p>
+        </p:txBody>
+      </p:sp>
+      <p:sp>
+        <p:nvSpPr>
+          <p:cNvPr id="1139" name="Rótulo repercussão digital orgânica"/>
           <p:cNvSpPr txBox="1"/>
           <p:nvPr/>
         </p:nvSpPr>
@@ -4555,14 +4555,14 @@
                 </a:solidFill>
                 <a:latin typeface="Manrope"/>
               </a:rPr>
-              <a:t>alcance digital (mídia on)</a:t>
-            </a:r>
-          </a:p>
-        </p:txBody>
-      </p:sp>
-      <p:sp>
-        <p:nvSpPr>
-          <p:cNvPr id="1140" name="Sub alcance digital (mídia on)"/>
+              <a:t>repercussão digital orgânica</a:t>
+            </a:r>
+          </a:p>
+        </p:txBody>
+      </p:sp>
+      <p:sp>
+        <p:nvSpPr>
+          <p:cNvPr id="1140" name="Sub repercussão digital orgânica"/>
           <p:cNvSpPr txBox="1"/>
           <p:nvPr/>
         </p:nvSpPr>
@@ -4590,14 +4590,14 @@
                 </a:solidFill>
                 <a:latin typeface="Manrope"/>
               </a:rPr>
-              <a:t>+15% vs projetado</a:t>
-            </a:r>
-          </a:p>
-        </p:txBody>
-      </p:sp>
-      <p:sp>
-        <p:nvSpPr>
-          <p:cNvPr id="1141" name="Tile cliques"/>
+              <a:t>alcance potencial em redes</a:t>
+            </a:r>
+          </a:p>
+        </p:txBody>
+      </p:sp>
+      <p:sp>
+        <p:nvSpPr>
+          <p:cNvPr id="1141" name="Tile alcance da mídia on"/>
           <p:cNvSpPr/>
           <p:nvPr/>
         </p:nvSpPr>
@@ -4645,7 +4645,7 @@
       </p:sp>
       <p:sp>
         <p:nvSpPr>
-          <p:cNvPr id="1142" name="Big cliques"/>
+          <p:cNvPr id="1142" name="Big alcance da mídia on"/>
           <p:cNvSpPr txBox="1"/>
           <p:nvPr/>
         </p:nvSpPr>
@@ -4673,14 +4673,14 @@
                 </a:solidFill>
                 <a:latin typeface="Manrope"/>
               </a:rPr>
-              <a:t>29.233</a:t>
-            </a:r>
-          </a:p>
-        </p:txBody>
-      </p:sp>
-      <p:sp>
-        <p:nvSpPr>
-          <p:cNvPr id="1143" name="Rótulo cliques"/>
+              <a:t>1,36 mi</a:t>
+            </a:r>
+          </a:p>
+        </p:txBody>
+      </p:sp>
+      <p:sp>
+        <p:nvSpPr>
+          <p:cNvPr id="1143" name="Rótulo alcance da mídia on"/>
           <p:cNvSpPr txBox="1"/>
           <p:nvPr/>
         </p:nvSpPr>
@@ -4708,14 +4708,14 @@
                 </a:solidFill>
                 <a:latin typeface="Manrope"/>
               </a:rPr>
-              <a:t>cliques</a:t>
-            </a:r>
-          </a:p>
-        </p:txBody>
-      </p:sp>
-      <p:sp>
-        <p:nvSpPr>
-          <p:cNvPr id="1144" name="Sub cliques"/>
+              <a:t>alcance da mídia on</a:t>
+            </a:r>
+          </a:p>
+        </p:txBody>
+      </p:sp>
+      <p:sp>
+        <p:nvSpPr>
+          <p:cNvPr id="1144" name="Sub alcance da mídia on"/>
           <p:cNvSpPr txBox="1"/>
           <p:nvPr/>
         </p:nvSpPr>
@@ -4743,7 +4743,7 @@
                 </a:solidFill>
                 <a:latin typeface="Manrope"/>
               </a:rPr>
-              <a:t>+26% vs projetado</a:t>
+              <a:t>+15% vs projetado</a:t>
             </a:r>
           </a:p>
         </p:txBody>
@@ -4903,7 +4903,7 @@
       </p:sp>
       <p:sp>
         <p:nvSpPr>
-          <p:cNvPr id="1149" name="Tile custo vs orçado"/>
+          <p:cNvPr id="1149" name="Tile custo vs orçado de R$ 60 mil"/>
           <p:cNvSpPr/>
           <p:nvPr/>
         </p:nvSpPr>
@@ -4951,7 +4951,7 @@
       </p:sp>
       <p:sp>
         <p:nvSpPr>
-          <p:cNvPr id="1150" name="Big custo vs orçado"/>
+          <p:cNvPr id="1150" name="Big custo vs orçado de R$ 60 mil"/>
           <p:cNvSpPr txBox="1"/>
           <p:nvPr/>
         </p:nvSpPr>
@@ -4986,7 +4986,7 @@
       </p:sp>
       <p:sp>
         <p:nvSpPr>
-          <p:cNvPr id="1151" name="Rótulo custo vs orçado"/>
+          <p:cNvPr id="1151" name="Rótulo custo vs orçado de R$ 60 mil"/>
           <p:cNvSpPr txBox="1"/>
           <p:nvPr/>
         </p:nvSpPr>
@@ -5014,14 +5014,14 @@
                 </a:solidFill>
                 <a:latin typeface="Manrope"/>
               </a:rPr>
-              <a:t>custo vs orçado</a:t>
-            </a:r>
-          </a:p>
-        </p:txBody>
-      </p:sp>
-      <p:sp>
-        <p:nvSpPr>
-          <p:cNvPr id="1152" name="Sub custo vs orçado"/>
+              <a:t>custo vs orçado de R$ 60 mil</a:t>
+            </a:r>
+          </a:p>
+        </p:txBody>
+      </p:sp>
+      <p:sp>
+        <p:nvSpPr>
+          <p:cNvPr id="1152" name="Sub custo vs orçado de R$ 60 mil"/>
           <p:cNvSpPr txBox="1"/>
           <p:nvPr/>
         </p:nvSpPr>
@@ -5049,7 +5049,7 @@
                 </a:solidFill>
                 <a:latin typeface="Manrope"/>
               </a:rPr>
-              <a:t>R$ ~35 mil de R$ 60 mil</a:t>
+              <a:t>−70% vs última (R$ 115 mil)</a:t>
             </a:r>
           </a:p>
         </p:txBody>
@@ -6769,7 +6769,7 @@
       </p:pic>
       <p:sp>
         <p:nvSpPr>
-          <p:cNvPr id="1188" name="Seção IMPRENSA"/>
+          <p:cNvPr id="1188" name="Seção DIGITAL  |  REPERCUSSÃO ORGÂNICA"/>
           <p:cNvSpPr/>
           <p:nvPr/>
         </p:nvSpPr>
@@ -6784,7 +6784,7 @@
             </a:avLst>
           </a:prstGeom>
           <a:solidFill>
-            <a:srgbClr val="F37919"/>
+            <a:srgbClr val="1971BA"/>
           </a:solidFill>
           <a:ln>
             <a:noFill/>
@@ -6815,7 +6815,7 @@
       </p:sp>
       <p:sp>
         <p:nvSpPr>
-          <p:cNvPr id="1189" name="Seção texto IMPRENSA"/>
+          <p:cNvPr id="1189" name="Seção texto DIGITAL  |  REPERCUSSÃO ORGÂNICA"/>
           <p:cNvSpPr txBox="1"/>
           <p:nvPr/>
         </p:nvSpPr>
@@ -6843,21 +6843,21 @@
                 </a:solidFill>
                 <a:latin typeface="Manrope"/>
               </a:rPr>
-              <a:t>IMPRENSA</a:t>
-            </a:r>
-          </a:p>
-        </p:txBody>
-      </p:sp>
-      <p:sp>
-        <p:nvSpPr>
-          <p:cNvPr id="1190" name="Card imprensa"/>
+              <a:t>DIGITAL  |  REPERCUSSÃO ORGÂNICA</a:t>
+            </a:r>
+          </a:p>
+        </p:txBody>
+      </p:sp>
+      <p:sp>
+        <p:nvSpPr>
+          <p:cNvPr id="1190" name="Card orgânico"/>
           <p:cNvSpPr/>
           <p:nvPr/>
         </p:nvSpPr>
         <p:spPr>
           <a:xfrm>
             <a:off x="7863840" y="2212848"/>
-            <a:ext cx="4023360" cy="3227832"/>
+            <a:ext cx="4023360" cy="2130552"/>
           </a:xfrm>
           <a:prstGeom prst="roundRect">
             <a:avLst>
@@ -6869,7 +6869,7 @@
           </a:solidFill>
           <a:ln w="9525">
             <a:solidFill>
-              <a:srgbClr val="F37919"/>
+              <a:srgbClr val="1971BA"/>
             </a:solidFill>
           </a:ln>
           <a:effectLst/>
@@ -6898,14 +6898,14 @@
       </p:sp>
       <p:sp>
         <p:nvSpPr>
-          <p:cNvPr id="1191" name="Imprensa alcance"/>
+          <p:cNvPr id="1191" name="Orgânico alcance"/>
           <p:cNvSpPr txBox="1"/>
           <p:nvPr/>
         </p:nvSpPr>
         <p:spPr>
           <a:xfrm>
             <a:off x="8001000" y="2249424"/>
-            <a:ext cx="1737360" cy="548640"/>
+            <a:ext cx="1737360" cy="457200"/>
           </a:xfrm>
           <a:prstGeom prst="rect">
             <a:avLst/>
@@ -6920,27 +6920,27 @@
           <a:p>
             <a:pPr algn="l"/>
             <a:r>
-              <a:rPr sz="3200" b="1">
-                <a:solidFill>
-                  <a:srgbClr val="F37919"/>
+              <a:rPr sz="2800" b="1">
+                <a:solidFill>
+                  <a:srgbClr val="1971BA"/>
                 </a:solidFill>
                 <a:latin typeface="Manrope"/>
               </a:rPr>
-              <a:t>6,3 mi</a:t>
-            </a:r>
-          </a:p>
-        </p:txBody>
-      </p:sp>
-      <p:sp>
-        <p:nvSpPr>
-          <p:cNvPr id="1192" name="Rótulo alcance imprensa"/>
+              <a:t>10,8 mi</a:t>
+            </a:r>
+          </a:p>
+        </p:txBody>
+      </p:sp>
+      <p:sp>
+        <p:nvSpPr>
+          <p:cNvPr id="1192" name="Rótulo orgânico"/>
           <p:cNvSpPr txBox="1"/>
           <p:nvPr/>
         </p:nvSpPr>
         <p:spPr>
           <a:xfrm>
-            <a:off x="8001000" y="2770632"/>
-            <a:ext cx="1737360" cy="137160"/>
+            <a:off x="8001000" y="2724912"/>
+            <a:ext cx="1828800" cy="274320"/>
           </a:xfrm>
           <a:prstGeom prst="rect">
             <a:avLst/>
@@ -6955,38 +6955,163 @@
           <a:p>
             <a:pPr algn="l"/>
             <a:r>
-              <a:rPr sz="850" b="0">
+              <a:rPr sz="800" b="0">
                 <a:solidFill>
                   <a:srgbClr val="6B7894"/>
                 </a:solidFill>
                 <a:latin typeface="Manrope"/>
               </a:rPr>
-              <a:t>de alcance</a:t>
-            </a:r>
-          </a:p>
-        </p:txBody>
-      </p:sp>
-      <p:sp>
-        <p:nvSpPr>
-          <p:cNvPr id="1193" name="Selo recorde"/>
+              <a:t>de alcance potencial nas redes públicas</a:t>
+            </a:r>
+          </a:p>
+        </p:txBody>
+      </p:sp>
+      <p:sp>
+        <p:nvSpPr>
+          <p:cNvPr id="1193" name="Título repercussão"/>
+          <p:cNvSpPr txBox="1"/>
+          <p:nvPr/>
+        </p:nvSpPr>
+        <p:spPr>
+          <a:xfrm>
+            <a:off x="8001000" y="3017520"/>
+            <a:ext cx="2103120" cy="128016"/>
+          </a:xfrm>
+          <a:prstGeom prst="rect">
+            <a:avLst/>
+          </a:prstGeom>
+          <a:noFill/>
+        </p:spPr>
+        <p:txBody>
+          <a:bodyPr wrap="square" anchor="t" lIns="0" rIns="0" tIns="0" bIns="0">
+            <a:spAutoFit/>
+          </a:bodyPr>
+          <a:lstStyle/>
+          <a:p>
+            <a:pPr algn="l"/>
+            <a:r>
+              <a:rPr sz="750" b="1">
+                <a:solidFill>
+                  <a:srgbClr val="1971BA"/>
+                </a:solidFill>
+                <a:latin typeface="Manrope"/>
+              </a:rPr>
+              <a:t>O CUIDADO ECOOU EM MAR ABERTO</a:t>
+            </a:r>
+          </a:p>
+        </p:txBody>
+      </p:sp>
+      <p:pic>
+        <p:nvPicPr>
+          <p:cNvPr id="1194" name="Repercussão foto 1" descr="image.png"/>
+          <p:cNvPicPr>
+            <a:picLocks noChangeAspect="1"/>
+          </p:cNvPicPr>
+          <p:nvPr/>
+        </p:nvPicPr>
+        <p:blipFill>
+          <a:blip r:embed="rId12"/>
+          <a:stretch>
+            <a:fillRect/>
+          </a:stretch>
+        </p:blipFill>
+        <p:spPr>
+          <a:xfrm>
+            <a:off x="10561320" y="2286000"/>
+            <a:ext cx="690118" cy="868680"/>
+          </a:xfrm>
+          <a:prstGeom prst="rect">
+            <a:avLst/>
+          </a:prstGeom>
+        </p:spPr>
+      </p:pic>
+      <p:pic>
+        <p:nvPicPr>
+          <p:cNvPr id="1195" name="Repercussão foto 2" descr="image.png"/>
+          <p:cNvPicPr>
+            <a:picLocks noChangeAspect="1"/>
+          </p:cNvPicPr>
+          <p:nvPr/>
+        </p:nvPicPr>
+        <p:blipFill>
+          <a:blip r:embed="rId13"/>
+          <a:stretch>
+            <a:fillRect/>
+          </a:stretch>
+        </p:blipFill>
+        <p:spPr>
+          <a:xfrm>
+            <a:off x="11292840" y="2331720"/>
+            <a:ext cx="543143" cy="868680"/>
+          </a:xfrm>
+          <a:prstGeom prst="rect">
+            <a:avLst/>
+          </a:prstGeom>
+        </p:spPr>
+      </p:pic>
+      <p:sp>
+        <p:nvSpPr>
+          <p:cNvPr id="1196" name="Texto repercussão"/>
+          <p:cNvSpPr txBox="1"/>
+          <p:nvPr/>
+        </p:nvSpPr>
+        <p:spPr>
+          <a:xfrm>
+            <a:off x="8001000" y="3200400"/>
+            <a:ext cx="3749040" cy="457200"/>
+          </a:xfrm>
+          <a:prstGeom prst="rect">
+            <a:avLst/>
+          </a:prstGeom>
+          <a:noFill/>
+        </p:spPr>
+        <p:txBody>
+          <a:bodyPr wrap="square" anchor="t" lIns="0" rIns="0" tIns="0" bIns="0">
+            <a:spAutoFit/>
+          </a:bodyPr>
+          <a:lstStyle/>
+          <a:p>
+            <a:pPr algn="l"/>
+            <a:r>
+              <a:rPr sz="800" b="0">
+                <a:solidFill>
+                  <a:srgbClr val="142B52"/>
+                </a:solidFill>
+                <a:latin typeface="Manrope"/>
+              </a:rPr>
+              <a:t>Imprensa e comunidades locais compartilharam imagens e comentários sobre o simulado da VLI e os dados de segurança, </a:t>
+            </a:r>
+            <a:r>
+              <a:rPr sz="800" b="1">
+                <a:solidFill>
+                  <a:srgbClr val="142B52"/>
+                </a:solidFill>
+                <a:latin typeface="Manrope"/>
+              </a:rPr>
+              <a:t>fortalecendo diretamente o IR da VLI em setembro.</a:t>
+            </a:r>
+          </a:p>
+        </p:txBody>
+      </p:sp>
+      <p:sp>
+        <p:nvSpPr>
+          <p:cNvPr id="1197" name="Divisor orgânico"/>
           <p:cNvSpPr/>
           <p:nvPr/>
         </p:nvSpPr>
         <p:spPr>
           <a:xfrm>
-            <a:off x="8001000" y="2962656"/>
-            <a:ext cx="1463040" cy="182880"/>
-          </a:xfrm>
-          <a:prstGeom prst="roundRect">
-            <a:avLst>
-              <a:gd name="adj" fmla="val 50000"/>
-            </a:avLst>
-          </a:prstGeom>
-          <a:solidFill>
-            <a:srgbClr val="F37919"/>
-          </a:solidFill>
-          <a:ln>
-            <a:noFill/>
+            <a:off x="8001000" y="3703320"/>
+            <a:ext cx="3749040" cy="0"/>
+          </a:xfrm>
+          <a:prstGeom prst="rect">
+            <a:avLst/>
+          </a:prstGeom>
+          <a:noFill/>
+          <a:ln w="9525">
+            <a:solidFill>
+              <a:srgbClr val="DDE2ED"/>
+            </a:solidFill>
           </a:ln>
           <a:effectLst/>
         </p:spPr>
@@ -7014,49 +7139,14 @@
       </p:sp>
       <p:sp>
         <p:nvSpPr>
-          <p:cNvPr id="1194" name="Selo texto"/>
+          <p:cNvPr id="1198" name="Collab KPI"/>
           <p:cNvSpPr txBox="1"/>
           <p:nvPr/>
         </p:nvSpPr>
         <p:spPr>
           <a:xfrm>
-            <a:off x="8001000" y="2962656"/>
-            <a:ext cx="1463040" cy="182880"/>
-          </a:xfrm>
-          <a:prstGeom prst="rect">
-            <a:avLst/>
-          </a:prstGeom>
-          <a:noFill/>
-        </p:spPr>
-        <p:txBody>
-          <a:bodyPr wrap="square" anchor="ctr" lIns="0" rIns="0" tIns="0" bIns="0">
-            <a:spAutoFit/>
-          </a:bodyPr>
-          <a:lstStyle/>
-          <a:p>
-            <a:pPr algn="ctr"/>
-            <a:r>
-              <a:rPr sz="700" b="1">
-                <a:solidFill>
-                  <a:srgbClr val="FFFFFF"/>
-                </a:solidFill>
-                <a:latin typeface="Manrope"/>
-              </a:rPr>
-              <a:t>MAIOR JÁ REGISTRADO</a:t>
-            </a:r>
-          </a:p>
-        </p:txBody>
-      </p:sp>
-      <p:sp>
-        <p:nvSpPr>
-          <p:cNvPr id="1195" name="Imprensa inserções"/>
-          <p:cNvSpPr txBox="1"/>
-          <p:nvPr/>
-        </p:nvSpPr>
-        <p:spPr>
-          <a:xfrm>
-            <a:off x="9738359" y="2267712"/>
-            <a:ext cx="868680" cy="274320"/>
+            <a:off x="8001000" y="3749039"/>
+            <a:ext cx="1005840" cy="365760"/>
           </a:xfrm>
           <a:prstGeom prst="rect">
             <a:avLst/>
@@ -7071,27 +7161,27 @@
           <a:p>
             <a:pPr algn="l"/>
             <a:r>
-              <a:rPr sz="2200" b="1">
-                <a:solidFill>
-                  <a:srgbClr val="142B52"/>
+              <a:rPr sz="1900" b="1">
+                <a:solidFill>
+                  <a:srgbClr val="1971BA"/>
                 </a:solidFill>
                 <a:latin typeface="Manrope"/>
               </a:rPr>
-              <a:t>69</a:t>
-            </a:r>
-          </a:p>
-        </p:txBody>
-      </p:sp>
-      <p:sp>
-        <p:nvSpPr>
-          <p:cNvPr id="1196" name="Rótulo inserções"/>
+              <a:t>155 mil</a:t>
+            </a:r>
+          </a:p>
+        </p:txBody>
+      </p:sp>
+      <p:sp>
+        <p:nvSpPr>
+          <p:cNvPr id="1199" name="Collab texto"/>
           <p:cNvSpPr txBox="1"/>
           <p:nvPr/>
         </p:nvSpPr>
         <p:spPr>
           <a:xfrm>
-            <a:off x="9738359" y="2596896"/>
-            <a:ext cx="868680" cy="137160"/>
+            <a:off x="9052560" y="3749039"/>
+            <a:ext cx="1371600" cy="548640"/>
           </a:xfrm>
           <a:prstGeom prst="rect">
             <a:avLst/>
@@ -7106,35 +7196,35 @@
           <a:p>
             <a:pPr algn="l"/>
             <a:r>
-              <a:rPr sz="850" b="0">
-                <a:solidFill>
-                  <a:srgbClr val="6B7894"/>
+              <a:rPr sz="750" b="0">
+                <a:solidFill>
+                  <a:srgbClr val="43597E"/>
                 </a:solidFill>
                 <a:latin typeface="Manrope"/>
               </a:rPr>
-              <a:t>inserções</a:t>
+              <a:t>views orgânicas nos posts Collab: VLI, ANTF, Rumo, MRS, Brado e FIPS</a:t>
             </a:r>
           </a:p>
         </p:txBody>
       </p:sp>
       <p:pic>
         <p:nvPicPr>
-          <p:cNvPr id="1197" name="Imprensa foto 1" descr="image.png"/>
+          <p:cNvPr id="1200" name="Collab 1" descr="image.png"/>
           <p:cNvPicPr>
             <a:picLocks noChangeAspect="1"/>
           </p:cNvPicPr>
           <p:nvPr/>
         </p:nvPicPr>
         <p:blipFill>
-          <a:blip r:embed="rId12"/>
+          <a:blip r:embed="rId14"/>
           <a:stretch>
             <a:fillRect/>
           </a:stretch>
         </p:blipFill>
         <p:spPr>
           <a:xfrm>
-            <a:off x="10561320" y="2286000"/>
-            <a:ext cx="690118" cy="868680"/>
+            <a:off x="10561320" y="3749039"/>
+            <a:ext cx="376057" cy="502920"/>
           </a:xfrm>
           <a:prstGeom prst="rect">
             <a:avLst/>
@@ -7143,22 +7233,22 @@
       </p:pic>
       <p:pic>
         <p:nvPicPr>
-          <p:cNvPr id="1198" name="Imprensa foto 2" descr="image.png"/>
+          <p:cNvPr id="1201" name="Collab 2" descr="image.png"/>
           <p:cNvPicPr>
             <a:picLocks noChangeAspect="1"/>
           </p:cNvPicPr>
           <p:nvPr/>
         </p:nvPicPr>
         <p:blipFill>
-          <a:blip r:embed="rId13"/>
+          <a:blip r:embed="rId15"/>
           <a:stretch>
             <a:fillRect/>
           </a:stretch>
         </p:blipFill>
         <p:spPr>
           <a:xfrm>
-            <a:off x="11292840" y="2331720"/>
-            <a:ext cx="543143" cy="868680"/>
+            <a:off x="11064240" y="3749039"/>
+            <a:ext cx="373037" cy="502920"/>
           </a:xfrm>
           <a:prstGeom prst="rect">
             <a:avLst/>
@@ -7167,120 +7257,25 @@
       </p:pic>
       <p:sp>
         <p:nvSpPr>
-          <p:cNvPr id="1199" name="Título repercussão"/>
-          <p:cNvSpPr txBox="1"/>
-          <p:nvPr/>
-        </p:nvSpPr>
-        <p:spPr>
-          <a:xfrm>
-            <a:off x="8001000" y="3246120"/>
-            <a:ext cx="3749040" cy="137160"/>
-          </a:xfrm>
-          <a:prstGeom prst="rect">
-            <a:avLst/>
-          </a:prstGeom>
-          <a:noFill/>
-        </p:spPr>
-        <p:txBody>
-          <a:bodyPr wrap="square" anchor="t" lIns="0" rIns="0" tIns="0" bIns="0">
-            <a:spAutoFit/>
-          </a:bodyPr>
-          <a:lstStyle/>
-          <a:p>
-            <a:pPr algn="l"/>
-            <a:r>
-              <a:rPr sz="800" b="1">
-                <a:solidFill>
-                  <a:srgbClr val="F37919"/>
-                </a:solidFill>
-                <a:latin typeface="Manrope"/>
-              </a:rPr>
-              <a:t>O CUIDADO ECOOU EM MAR ABERTO</a:t>
-            </a:r>
-          </a:p>
-        </p:txBody>
-      </p:sp>
-      <p:sp>
-        <p:nvSpPr>
-          <p:cNvPr id="1200" name="Texto repercussão"/>
-          <p:cNvSpPr txBox="1"/>
-          <p:nvPr/>
-        </p:nvSpPr>
-        <p:spPr>
-          <a:xfrm>
-            <a:off x="8001000" y="3401568"/>
-            <a:ext cx="3749040" cy="777240"/>
-          </a:xfrm>
-          <a:prstGeom prst="rect">
-            <a:avLst/>
-          </a:prstGeom>
-          <a:noFill/>
-        </p:spPr>
-        <p:txBody>
-          <a:bodyPr wrap="square" anchor="t" lIns="0" rIns="0" tIns="0" bIns="0">
-            <a:spAutoFit/>
-          </a:bodyPr>
-          <a:lstStyle/>
-          <a:p>
-            <a:pPr algn="l"/>
-            <a:r>
-              <a:rPr sz="800" b="0">
-                <a:solidFill>
-                  <a:srgbClr val="142B52"/>
-                </a:solidFill>
-                <a:latin typeface="Manrope"/>
-              </a:rPr>
-              <a:t>A repercussão positiva mobilizou imprensa e comunidades locais, que compartilharam imagens e comentários sobre o simulado da VLI e dados de segurança, gerando um alcance potencial de </a:t>
-            </a:r>
-            <a:r>
-              <a:rPr sz="800" b="1">
-                <a:solidFill>
-                  <a:srgbClr val="142B52"/>
-                </a:solidFill>
-                <a:latin typeface="Manrope"/>
-              </a:rPr>
-              <a:t>10,8 milhões</a:t>
-            </a:r>
-            <a:r>
-              <a:rPr sz="800" b="0">
-                <a:solidFill>
-                  <a:srgbClr val="142B52"/>
-                </a:solidFill>
-                <a:latin typeface="Manrope"/>
-              </a:rPr>
-              <a:t> nas redes públicas. </a:t>
-            </a:r>
-            <a:r>
-              <a:rPr sz="800" b="1">
-                <a:solidFill>
-                  <a:srgbClr val="142B52"/>
-                </a:solidFill>
-                <a:latin typeface="Manrope"/>
-              </a:rPr>
-              <a:t>Fortaleceu diretamente o IR da VLI em setembro.</a:t>
-            </a:r>
-          </a:p>
-        </p:txBody>
-      </p:sp>
-      <p:sp>
-        <p:nvSpPr>
-          <p:cNvPr id="1201" name="Divisor imprensa"/>
+          <p:cNvPr id="1202" name="Seção IMPRENSA"/>
           <p:cNvSpPr/>
           <p:nvPr/>
         </p:nvSpPr>
         <p:spPr>
           <a:xfrm>
-            <a:off x="8001000" y="4224528"/>
-            <a:ext cx="3749040" cy="0"/>
-          </a:xfrm>
-          <a:prstGeom prst="rect">
-            <a:avLst/>
-          </a:prstGeom>
-          <a:noFill/>
-          <a:ln w="9525">
-            <a:solidFill>
-              <a:srgbClr val="DDE2ED"/>
-            </a:solidFill>
+            <a:off x="7863840" y="4434840"/>
+            <a:ext cx="4023360" cy="237744"/>
+          </a:xfrm>
+          <a:prstGeom prst="roundRect">
+            <a:avLst>
+              <a:gd name="adj" fmla="val 30000"/>
+            </a:avLst>
+          </a:prstGeom>
+          <a:solidFill>
+            <a:srgbClr val="F37919"/>
+          </a:solidFill>
+          <a:ln>
+            <a:noFill/>
           </a:ln>
           <a:effectLst/>
         </p:spPr>
@@ -7308,14 +7303,14 @@
       </p:sp>
       <p:sp>
         <p:nvSpPr>
-          <p:cNvPr id="1202" name="Título operadoras"/>
+          <p:cNvPr id="1203" name="Seção texto IMPRENSA"/>
           <p:cNvSpPr txBox="1"/>
           <p:nvPr/>
         </p:nvSpPr>
         <p:spPr>
           <a:xfrm>
-            <a:off x="8001000" y="4297680"/>
-            <a:ext cx="2743200" cy="256032"/>
+            <a:off x="7973567" y="4434840"/>
+            <a:ext cx="3840480" cy="237744"/>
           </a:xfrm>
           <a:prstGeom prst="rect">
             <a:avLst/>
@@ -7323,146 +7318,47 @@
           <a:noFill/>
         </p:spPr>
         <p:txBody>
-          <a:bodyPr wrap="square" anchor="t" lIns="0" rIns="0" tIns="0" bIns="0">
+          <a:bodyPr wrap="square" anchor="ctr" lIns="0" rIns="0" tIns="0" bIns="0">
             <a:spAutoFit/>
           </a:bodyPr>
           <a:lstStyle/>
           <a:p>
             <a:pPr algn="l"/>
             <a:r>
-              <a:rPr sz="800" b="1">
-                <a:solidFill>
-                  <a:srgbClr val="43597E"/>
+              <a:rPr sz="900" b="1">
+                <a:solidFill>
+                  <a:srgbClr val="FFFFFF"/>
                 </a:solidFill>
                 <a:latin typeface="Manrope"/>
               </a:rPr>
-              <a:t>O QUE AS OPERADORAS LOGÍSTICAS TÊM EM COMUM?</a:t>
-            </a:r>
-          </a:p>
-        </p:txBody>
-      </p:sp>
-      <p:sp>
-        <p:nvSpPr>
-          <p:cNvPr id="1203" name="Texto operadoras"/>
-          <p:cNvSpPr txBox="1"/>
-          <p:nvPr/>
-        </p:nvSpPr>
-        <p:spPr>
-          <a:xfrm>
-            <a:off x="8001000" y="4572000"/>
-            <a:ext cx="2468880" cy="822960"/>
-          </a:xfrm>
-          <a:prstGeom prst="rect">
-            <a:avLst/>
-          </a:prstGeom>
-          <a:noFill/>
-        </p:spPr>
-        <p:txBody>
-          <a:bodyPr wrap="square" anchor="t" lIns="0" rIns="0" tIns="0" bIns="0">
-            <a:spAutoFit/>
-          </a:bodyPr>
-          <a:lstStyle/>
-          <a:p>
-            <a:pPr algn="l"/>
-            <a:r>
-              <a:rPr sz="800" b="0">
-                <a:solidFill>
-                  <a:srgbClr val="142B52"/>
-                </a:solidFill>
-                <a:latin typeface="Manrope"/>
-              </a:rPr>
-              <a:t>VLI, ANTF, Rumo, MRS, Brado e FIPS falaram a mesma língua: os posts Collab do Movimento ultrapassaram </a:t>
-            </a:r>
-            <a:r>
-              <a:rPr sz="800" b="1">
-                <a:solidFill>
-                  <a:srgbClr val="142B52"/>
-                </a:solidFill>
-                <a:latin typeface="Manrope"/>
-              </a:rPr>
-              <a:t>155 mil visualizações orgânicas</a:t>
-            </a:r>
-            <a:r>
-              <a:rPr sz="800" b="0">
-                <a:solidFill>
-                  <a:srgbClr val="142B52"/>
-                </a:solidFill>
-                <a:latin typeface="Manrope"/>
-              </a:rPr>
-              <a:t>, prova de que o cuidado com a vida nos trilhos é um propósito de todo o setor.</a:t>
-            </a:r>
-          </a:p>
-        </p:txBody>
-      </p:sp>
-      <p:pic>
-        <p:nvPicPr>
-          <p:cNvPr id="1204" name="Collab 1" descr="image.png"/>
-          <p:cNvPicPr>
-            <a:picLocks noChangeAspect="1"/>
-          </p:cNvPicPr>
-          <p:nvPr/>
-        </p:nvPicPr>
-        <p:blipFill>
-          <a:blip r:embed="rId14"/>
-          <a:stretch>
-            <a:fillRect/>
-          </a:stretch>
-        </p:blipFill>
-        <p:spPr>
-          <a:xfrm>
-            <a:off x="10469880" y="4343400"/>
-            <a:ext cx="649554" cy="868680"/>
-          </a:xfrm>
-          <a:prstGeom prst="rect">
-            <a:avLst/>
-          </a:prstGeom>
-        </p:spPr>
-      </p:pic>
-      <p:pic>
-        <p:nvPicPr>
-          <p:cNvPr id="1205" name="Collab 2" descr="image.png"/>
-          <p:cNvPicPr>
-            <a:picLocks noChangeAspect="1"/>
-          </p:cNvPicPr>
-          <p:nvPr/>
-        </p:nvPicPr>
-        <p:blipFill>
-          <a:blip r:embed="rId15"/>
-          <a:stretch>
-            <a:fillRect/>
-          </a:stretch>
-        </p:blipFill>
-        <p:spPr>
-          <a:xfrm>
-            <a:off x="11155680" y="4343400"/>
-            <a:ext cx="644336" cy="868680"/>
-          </a:xfrm>
-          <a:prstGeom prst="rect">
-            <a:avLst/>
-          </a:prstGeom>
-        </p:spPr>
-      </p:pic>
-      <p:sp>
-        <p:nvSpPr>
-          <p:cNvPr id="1206" name="Seção COMUNICAÇÃO INTERNA  |  Jornada integrada: E-mail MKT + ZAP + Intranet"/>
+              <a:t>IMPRENSA</a:t>
+            </a:r>
+          </a:p>
+        </p:txBody>
+      </p:sp>
+      <p:sp>
+        <p:nvSpPr>
+          <p:cNvPr id="1204" name="Card imprensa"/>
           <p:cNvSpPr/>
           <p:nvPr/>
         </p:nvSpPr>
         <p:spPr>
           <a:xfrm>
-            <a:off x="301752" y="5559552"/>
-            <a:ext cx="11585448" cy="237744"/>
+            <a:off x="7863840" y="4754880"/>
+            <a:ext cx="4023360" cy="685800"/>
           </a:xfrm>
           <a:prstGeom prst="roundRect">
             <a:avLst>
-              <a:gd name="adj" fmla="val 30000"/>
+              <a:gd name="adj" fmla="val 5000"/>
             </a:avLst>
           </a:prstGeom>
           <a:solidFill>
-            <a:srgbClr val="43597E"/>
+            <a:srgbClr val="FFFFFF"/>
           </a:solidFill>
-          <a:ln>
-            <a:noFill/>
+          <a:ln w="9525">
+            <a:solidFill>
+              <a:srgbClr val="F37919"/>
+            </a:solidFill>
           </a:ln>
           <a:effectLst/>
         </p:spPr>
@@ -7490,14 +7386,14 @@
       </p:sp>
       <p:sp>
         <p:nvSpPr>
-          <p:cNvPr id="1207" name="Seção texto COMUNICAÇÃO INTERNA  |  Jornada integrada: E-mail MKT + ZAP + Intranet"/>
+          <p:cNvPr id="1205" name="Imprensa alcance"/>
           <p:cNvSpPr txBox="1"/>
           <p:nvPr/>
         </p:nvSpPr>
         <p:spPr>
           <a:xfrm>
-            <a:off x="411480" y="5559552"/>
-            <a:ext cx="11402568" cy="237744"/>
+            <a:off x="8001000" y="4773168"/>
+            <a:ext cx="1463040" cy="457200"/>
           </a:xfrm>
           <a:prstGeom prst="rect">
             <a:avLst/>
@@ -7505,47 +7401,150 @@
           <a:noFill/>
         </p:spPr>
         <p:txBody>
-          <a:bodyPr wrap="square" anchor="ctr" lIns="0" rIns="0" tIns="0" bIns="0">
+          <a:bodyPr wrap="square" anchor="t" lIns="0" rIns="0" tIns="0" bIns="0">
             <a:spAutoFit/>
           </a:bodyPr>
           <a:lstStyle/>
           <a:p>
             <a:pPr algn="l"/>
             <a:r>
-              <a:rPr sz="900" b="1">
-                <a:solidFill>
-                  <a:srgbClr val="FFFFFF"/>
+              <a:rPr sz="2600" b="1">
+                <a:solidFill>
+                  <a:srgbClr val="F37919"/>
                 </a:solidFill>
                 <a:latin typeface="Manrope"/>
               </a:rPr>
-              <a:t>COMUNICAÇÃO INTERNA  |  Jornada integrada: E-mail MKT + ZAP + Intranet</a:t>
-            </a:r>
-          </a:p>
-        </p:txBody>
-      </p:sp>
-      <p:sp>
-        <p:nvSpPr>
-          <p:cNvPr id="1208" name="Canal E-MAIL MKT"/>
+              <a:t>6,3 mi</a:t>
+            </a:r>
+          </a:p>
+        </p:txBody>
+      </p:sp>
+      <p:sp>
+        <p:nvSpPr>
+          <p:cNvPr id="1206" name="Rótulo alcance imprensa"/>
+          <p:cNvSpPr txBox="1"/>
+          <p:nvPr/>
+        </p:nvSpPr>
+        <p:spPr>
+          <a:xfrm>
+            <a:off x="8001000" y="5230368"/>
+            <a:ext cx="1463040" cy="137160"/>
+          </a:xfrm>
+          <a:prstGeom prst="rect">
+            <a:avLst/>
+          </a:prstGeom>
+          <a:noFill/>
+        </p:spPr>
+        <p:txBody>
+          <a:bodyPr wrap="square" anchor="t" lIns="0" rIns="0" tIns="0" bIns="0">
+            <a:spAutoFit/>
+          </a:bodyPr>
+          <a:lstStyle/>
+          <a:p>
+            <a:pPr algn="l"/>
+            <a:r>
+              <a:rPr sz="800" b="0">
+                <a:solidFill>
+                  <a:srgbClr val="6B7894"/>
+                </a:solidFill>
+                <a:latin typeface="Manrope"/>
+              </a:rPr>
+              <a:t>de alcance</a:t>
+            </a:r>
+          </a:p>
+        </p:txBody>
+      </p:sp>
+      <p:sp>
+        <p:nvSpPr>
+          <p:cNvPr id="1207" name="Imprensa inserções"/>
+          <p:cNvSpPr txBox="1"/>
+          <p:nvPr/>
+        </p:nvSpPr>
+        <p:spPr>
+          <a:xfrm>
+            <a:off x="9601200" y="4800600"/>
+            <a:ext cx="914400" cy="365760"/>
+          </a:xfrm>
+          <a:prstGeom prst="rect">
+            <a:avLst/>
+          </a:prstGeom>
+          <a:noFill/>
+        </p:spPr>
+        <p:txBody>
+          <a:bodyPr wrap="square" anchor="t" lIns="0" rIns="0" tIns="0" bIns="0">
+            <a:spAutoFit/>
+          </a:bodyPr>
+          <a:lstStyle/>
+          <a:p>
+            <a:pPr algn="l"/>
+            <a:r>
+              <a:rPr sz="2200" b="1">
+                <a:solidFill>
+                  <a:srgbClr val="142B52"/>
+                </a:solidFill>
+                <a:latin typeface="Manrope"/>
+              </a:rPr>
+              <a:t>69</a:t>
+            </a:r>
+          </a:p>
+        </p:txBody>
+      </p:sp>
+      <p:sp>
+        <p:nvSpPr>
+          <p:cNvPr id="1208" name="Rótulo inserções"/>
+          <p:cNvSpPr txBox="1"/>
+          <p:nvPr/>
+        </p:nvSpPr>
+        <p:spPr>
+          <a:xfrm>
+            <a:off x="9601200" y="5138928"/>
+            <a:ext cx="914400" cy="137160"/>
+          </a:xfrm>
+          <a:prstGeom prst="rect">
+            <a:avLst/>
+          </a:prstGeom>
+          <a:noFill/>
+        </p:spPr>
+        <p:txBody>
+          <a:bodyPr wrap="square" anchor="t" lIns="0" rIns="0" tIns="0" bIns="0">
+            <a:spAutoFit/>
+          </a:bodyPr>
+          <a:lstStyle/>
+          <a:p>
+            <a:pPr algn="l"/>
+            <a:r>
+              <a:rPr sz="800" b="0">
+                <a:solidFill>
+                  <a:srgbClr val="6B7894"/>
+                </a:solidFill>
+                <a:latin typeface="Manrope"/>
+              </a:rPr>
+              <a:t>inserções</a:t>
+            </a:r>
+          </a:p>
+        </p:txBody>
+      </p:sp>
+      <p:sp>
+        <p:nvSpPr>
+          <p:cNvPr id="1209" name="Selo recorde"/>
           <p:cNvSpPr/>
           <p:nvPr/>
         </p:nvSpPr>
         <p:spPr>
           <a:xfrm>
-            <a:off x="301752" y="5852160"/>
-            <a:ext cx="2258568" cy="822960"/>
+            <a:off x="10561320" y="4919472"/>
+            <a:ext cx="1188720" cy="329184"/>
           </a:xfrm>
           <a:prstGeom prst="roundRect">
             <a:avLst>
-              <a:gd name="adj" fmla="val 5000"/>
+              <a:gd name="adj" fmla="val 40000"/>
             </a:avLst>
           </a:prstGeom>
           <a:solidFill>
-            <a:srgbClr val="FFFFFF"/>
+            <a:srgbClr val="F37919"/>
           </a:solidFill>
-          <a:ln w="9525">
-            <a:solidFill>
-              <a:srgbClr val="DDE2ED"/>
-            </a:solidFill>
+          <a:ln>
+            <a:noFill/>
           </a:ln>
           <a:effectLst/>
         </p:spPr>
@@ -7573,14 +7572,14 @@
       </p:sp>
       <p:sp>
         <p:nvSpPr>
-          <p:cNvPr id="1209" name="Canal rótulo E-MAIL MKT"/>
+          <p:cNvPr id="1210" name="Selo texto"/>
           <p:cNvSpPr txBox="1"/>
           <p:nvPr/>
         </p:nvSpPr>
         <p:spPr>
           <a:xfrm>
-            <a:off x="393192" y="5897880"/>
-            <a:ext cx="2103120" cy="128016"/>
+            <a:off x="10561320" y="4919472"/>
+            <a:ext cx="1188720" cy="329184"/>
           </a:xfrm>
           <a:prstGeom prst="rect">
             <a:avLst/>
@@ -7588,126 +7587,45 @@
           <a:noFill/>
         </p:spPr>
         <p:txBody>
-          <a:bodyPr wrap="square" anchor="t" lIns="0" rIns="0" tIns="0" bIns="0">
+          <a:bodyPr wrap="square" anchor="ctr" lIns="0" rIns="0" tIns="0" bIns="0">
             <a:spAutoFit/>
           </a:bodyPr>
           <a:lstStyle/>
           <a:p>
-            <a:pPr algn="l"/>
-            <a:r>
-              <a:rPr sz="750" b="1">
-                <a:solidFill>
-                  <a:srgbClr val="43597E"/>
+            <a:pPr algn="ctr"/>
+            <a:r>
+              <a:rPr sz="700" b="1">
+                <a:solidFill>
+                  <a:srgbClr val="FFFFFF"/>
                 </a:solidFill>
                 <a:latin typeface="Manrope"/>
               </a:rPr>
-              <a:t>E-MAIL MKT</a:t>
-            </a:r>
-          </a:p>
-        </p:txBody>
-      </p:sp>
-      <p:sp>
-        <p:nvSpPr>
-          <p:cNvPr id="1210" name="Canal KPI E-MAIL MKT"/>
-          <p:cNvSpPr txBox="1"/>
-          <p:nvPr/>
-        </p:nvSpPr>
-        <p:spPr>
-          <a:xfrm>
-            <a:off x="393192" y="6035040"/>
-            <a:ext cx="2103120" cy="274320"/>
-          </a:xfrm>
-          <a:prstGeom prst="rect">
-            <a:avLst/>
-          </a:prstGeom>
-          <a:noFill/>
-        </p:spPr>
-        <p:txBody>
-          <a:bodyPr wrap="square" anchor="t" lIns="0" rIns="0" tIns="0" bIns="0">
-            <a:spAutoFit/>
-          </a:bodyPr>
-          <a:lstStyle/>
-          <a:p>
-            <a:pPr algn="l"/>
-            <a:r>
-              <a:rPr sz="1700" b="1">
-                <a:solidFill>
-                  <a:srgbClr val="142B52"/>
-                </a:solidFill>
-                <a:latin typeface="Manrope"/>
-              </a:rPr>
-              <a:t>16,7%</a:t>
-            </a:r>
-            <a:r>
-              <a:rPr sz="850" b="0">
-                <a:solidFill>
-                  <a:srgbClr val="6B7894"/>
-                </a:solidFill>
-                <a:latin typeface="Manrope"/>
-              </a:rPr>
-              <a:t>  abertura</a:t>
-            </a:r>
-          </a:p>
-        </p:txBody>
-      </p:sp>
-      <p:sp>
-        <p:nvSpPr>
-          <p:cNvPr id="1211" name="Canal detalhe E-MAIL MKT"/>
-          <p:cNvSpPr txBox="1"/>
-          <p:nvPr/>
-        </p:nvSpPr>
-        <p:spPr>
-          <a:xfrm>
-            <a:off x="393192" y="6345936"/>
-            <a:ext cx="2103120" cy="310896"/>
-          </a:xfrm>
-          <a:prstGeom prst="rect">
-            <a:avLst/>
-          </a:prstGeom>
-          <a:noFill/>
-        </p:spPr>
-        <p:txBody>
-          <a:bodyPr wrap="square" anchor="t" lIns="0" rIns="0" tIns="0" bIns="0">
-            <a:spAutoFit/>
-          </a:bodyPr>
-          <a:lstStyle/>
-          <a:p>
-            <a:pPr algn="l"/>
-            <a:r>
-              <a:rPr sz="750" b="0">
-                <a:solidFill>
-                  <a:srgbClr val="6B7894"/>
-                </a:solidFill>
-                <a:latin typeface="Manrope"/>
-              </a:rPr>
-              <a:t>4.794 enviados · 4.345 entregues · 727 aberturas únicas · 50 cliques</a:t>
-            </a:r>
-          </a:p>
-        </p:txBody>
-      </p:sp>
-      <p:sp>
-        <p:nvSpPr>
-          <p:cNvPr id="1212" name="Canal ZAP VLI"/>
+              <a:t>MAIOR ALCANCE JÁ REGISTRADO</a:t>
+            </a:r>
+          </a:p>
+        </p:txBody>
+      </p:sp>
+      <p:sp>
+        <p:nvSpPr>
+          <p:cNvPr id="1211" name="Seção COMUNICAÇÃO INTERNA  |  Jornada integrada: E-mail MKT + ZAP + Intranet"/>
           <p:cNvSpPr/>
           <p:nvPr/>
         </p:nvSpPr>
         <p:spPr>
           <a:xfrm>
-            <a:off x="2633472" y="5852160"/>
-            <a:ext cx="2258568" cy="822960"/>
+            <a:off x="301752" y="5559552"/>
+            <a:ext cx="11585448" cy="237744"/>
           </a:xfrm>
           <a:prstGeom prst="roundRect">
             <a:avLst>
-              <a:gd name="adj" fmla="val 5000"/>
+              <a:gd name="adj" fmla="val 30000"/>
             </a:avLst>
           </a:prstGeom>
           <a:solidFill>
-            <a:srgbClr val="FFFFFF"/>
+            <a:srgbClr val="43597E"/>
           </a:solidFill>
-          <a:ln w="9525">
-            <a:solidFill>
-              <a:srgbClr val="DDE2ED"/>
-            </a:solidFill>
+          <a:ln>
+            <a:noFill/>
           </a:ln>
           <a:effectLst/>
         </p:spPr>
@@ -7735,14 +7653,14 @@
       </p:sp>
       <p:sp>
         <p:nvSpPr>
-          <p:cNvPr id="1213" name="Canal rótulo ZAP VLI"/>
+          <p:cNvPr id="1212" name="Seção texto COMUNICAÇÃO INTERNA  |  Jornada integrada: E-mail MKT + ZAP + Intranet"/>
           <p:cNvSpPr txBox="1"/>
           <p:nvPr/>
         </p:nvSpPr>
         <p:spPr>
           <a:xfrm>
-            <a:off x="2724912" y="5897880"/>
-            <a:ext cx="2103120" cy="128016"/>
+            <a:off x="411480" y="5559552"/>
+            <a:ext cx="11402568" cy="237744"/>
           </a:xfrm>
           <a:prstGeom prst="rect">
             <a:avLst/>
@@ -7750,112 +7668,33 @@
           <a:noFill/>
         </p:spPr>
         <p:txBody>
-          <a:bodyPr wrap="square" anchor="t" lIns="0" rIns="0" tIns="0" bIns="0">
+          <a:bodyPr wrap="square" anchor="ctr" lIns="0" rIns="0" tIns="0" bIns="0">
             <a:spAutoFit/>
           </a:bodyPr>
           <a:lstStyle/>
           <a:p>
             <a:pPr algn="l"/>
             <a:r>
-              <a:rPr sz="750" b="1">
-                <a:solidFill>
-                  <a:srgbClr val="43597E"/>
+              <a:rPr sz="900" b="1">
+                <a:solidFill>
+                  <a:srgbClr val="FFFFFF"/>
                 </a:solidFill>
                 <a:latin typeface="Manrope"/>
               </a:rPr>
-              <a:t>ZAP VLI</a:t>
-            </a:r>
-          </a:p>
-        </p:txBody>
-      </p:sp>
-      <p:sp>
-        <p:nvSpPr>
-          <p:cNvPr id="1214" name="Canal KPI ZAP VLI"/>
-          <p:cNvSpPr txBox="1"/>
-          <p:nvPr/>
-        </p:nvSpPr>
-        <p:spPr>
-          <a:xfrm>
-            <a:off x="2724912" y="6035040"/>
-            <a:ext cx="2103120" cy="274320"/>
-          </a:xfrm>
-          <a:prstGeom prst="rect">
-            <a:avLst/>
-          </a:prstGeom>
-          <a:noFill/>
-        </p:spPr>
-        <p:txBody>
-          <a:bodyPr wrap="square" anchor="t" lIns="0" rIns="0" tIns="0" bIns="0">
-            <a:spAutoFit/>
-          </a:bodyPr>
-          <a:lstStyle/>
-          <a:p>
-            <a:pPr algn="l"/>
-            <a:r>
-              <a:rPr sz="1700" b="1">
-                <a:solidFill>
-                  <a:srgbClr val="142B52"/>
-                </a:solidFill>
-                <a:latin typeface="Manrope"/>
-              </a:rPr>
-              <a:t>56,5%</a:t>
-            </a:r>
-            <a:r>
-              <a:rPr sz="850" b="0">
-                <a:solidFill>
-                  <a:srgbClr val="6B7894"/>
-                </a:solidFill>
-                <a:latin typeface="Manrope"/>
-              </a:rPr>
-              <a:t>  leitura</a:t>
-            </a:r>
-          </a:p>
-        </p:txBody>
-      </p:sp>
-      <p:sp>
-        <p:nvSpPr>
-          <p:cNvPr id="1215" name="Canal detalhe ZAP VLI"/>
-          <p:cNvSpPr txBox="1"/>
-          <p:nvPr/>
-        </p:nvSpPr>
-        <p:spPr>
-          <a:xfrm>
-            <a:off x="2724912" y="6345936"/>
-            <a:ext cx="2103120" cy="310896"/>
-          </a:xfrm>
-          <a:prstGeom prst="rect">
-            <a:avLst/>
-          </a:prstGeom>
-          <a:noFill/>
-        </p:spPr>
-        <p:txBody>
-          <a:bodyPr wrap="square" anchor="t" lIns="0" rIns="0" tIns="0" bIns="0">
-            <a:spAutoFit/>
-          </a:bodyPr>
-          <a:lstStyle/>
-          <a:p>
-            <a:pPr algn="l"/>
-            <a:r>
-              <a:rPr sz="750" b="0">
-                <a:solidFill>
-                  <a:srgbClr val="6B7894"/>
-                </a:solidFill>
-                <a:latin typeface="Manrope"/>
-              </a:rPr>
-              <a:t>3.516 recebidas · 1.985 leituras · 181 interações (9,1%)</a:t>
-            </a:r>
-          </a:p>
-        </p:txBody>
-      </p:sp>
-      <p:sp>
-        <p:nvSpPr>
-          <p:cNvPr id="1216" name="Canal INTRANET VLI@"/>
+              <a:t>COMUNICAÇÃO INTERNA  |  Jornada integrada: E-mail MKT + ZAP + Intranet</a:t>
+            </a:r>
+          </a:p>
+        </p:txBody>
+      </p:sp>
+      <p:sp>
+        <p:nvSpPr>
+          <p:cNvPr id="1213" name="Canal E-MAIL MKT"/>
           <p:cNvSpPr/>
           <p:nvPr/>
         </p:nvSpPr>
         <p:spPr>
           <a:xfrm>
-            <a:off x="4965192" y="5852160"/>
+            <a:off x="301752" y="5852160"/>
             <a:ext cx="2258568" cy="822960"/>
           </a:xfrm>
           <a:prstGeom prst="roundRect">
@@ -7897,13 +7736,13 @@
       </p:sp>
       <p:sp>
         <p:nvSpPr>
-          <p:cNvPr id="1217" name="Canal rótulo INTRANET VLI@"/>
+          <p:cNvPr id="1214" name="Canal rótulo E-MAIL MKT"/>
           <p:cNvSpPr txBox="1"/>
           <p:nvPr/>
         </p:nvSpPr>
         <p:spPr>
           <a:xfrm>
-            <a:off x="5056631" y="5897880"/>
+            <a:off x="393192" y="5897880"/>
             <a:ext cx="2103120" cy="128016"/>
           </a:xfrm>
           <a:prstGeom prst="rect">
@@ -7925,20 +7764,20 @@
                 </a:solidFill>
                 <a:latin typeface="Manrope"/>
               </a:rPr>
-              <a:t>INTRANET VLI@</a:t>
-            </a:r>
-          </a:p>
-        </p:txBody>
-      </p:sp>
-      <p:sp>
-        <p:nvSpPr>
-          <p:cNvPr id="1218" name="Canal KPI INTRANET VLI@"/>
+              <a:t>E-MAIL MKT</a:t>
+            </a:r>
+          </a:p>
+        </p:txBody>
+      </p:sp>
+      <p:sp>
+        <p:nvSpPr>
+          <p:cNvPr id="1215" name="Canal KPI E-MAIL MKT"/>
           <p:cNvSpPr txBox="1"/>
           <p:nvPr/>
         </p:nvSpPr>
         <p:spPr>
           <a:xfrm>
-            <a:off x="5056631" y="6035040"/>
+            <a:off x="393192" y="6035040"/>
             <a:ext cx="2103120" cy="274320"/>
           </a:xfrm>
           <a:prstGeom prst="rect">
@@ -7960,7 +7799,7 @@
                 </a:solidFill>
                 <a:latin typeface="Manrope"/>
               </a:rPr>
-              <a:t>114</a:t>
+              <a:t>16,7%</a:t>
             </a:r>
             <a:r>
               <a:rPr sz="850" b="0">
@@ -7969,20 +7808,20 @@
                 </a:solidFill>
                 <a:latin typeface="Manrope"/>
               </a:rPr>
-              <a:t>  exibições</a:t>
-            </a:r>
-          </a:p>
-        </p:txBody>
-      </p:sp>
-      <p:sp>
-        <p:nvSpPr>
-          <p:cNvPr id="1219" name="Canal detalhe INTRANET VLI@"/>
+              <a:t>  abertura</a:t>
+            </a:r>
+          </a:p>
+        </p:txBody>
+      </p:sp>
+      <p:sp>
+        <p:nvSpPr>
+          <p:cNvPr id="1216" name="Canal detalhe E-MAIL MKT"/>
           <p:cNvSpPr txBox="1"/>
           <p:nvPr/>
         </p:nvSpPr>
         <p:spPr>
           <a:xfrm>
-            <a:off x="5056631" y="6345936"/>
+            <a:off x="393192" y="6345936"/>
             <a:ext cx="2103120" cy="310896"/>
           </a:xfrm>
           <a:prstGeom prst="rect">
@@ -8004,21 +7843,21 @@
                 </a:solidFill>
                 <a:latin typeface="Manrope"/>
               </a:rPr>
-              <a:t>Matéria com ações educativas e dicas para o trânsito</a:t>
-            </a:r>
-          </a:p>
-        </p:txBody>
-      </p:sp>
-      <p:sp>
-        <p:nvSpPr>
-          <p:cNvPr id="1220" name="Leitura interna"/>
+              <a:t>4.794 enviados · 4.345 entregues · 727 aberturas únicas · 50 cliques</a:t>
+            </a:r>
+          </a:p>
+        </p:txBody>
+      </p:sp>
+      <p:sp>
+        <p:nvSpPr>
+          <p:cNvPr id="1217" name="Canal ZAP VLI"/>
           <p:cNvSpPr/>
           <p:nvPr/>
         </p:nvSpPr>
         <p:spPr>
           <a:xfrm>
-            <a:off x="7296912" y="5852160"/>
-            <a:ext cx="4590288" cy="822960"/>
+            <a:off x="2633472" y="5852160"/>
+            <a:ext cx="2258568" cy="822960"/>
           </a:xfrm>
           <a:prstGeom prst="roundRect">
             <a:avLst>
@@ -8026,10 +7865,12 @@
             </a:avLst>
           </a:prstGeom>
           <a:solidFill>
-            <a:srgbClr val="E6EBF3"/>
+            <a:srgbClr val="FFFFFF"/>
           </a:solidFill>
-          <a:ln>
-            <a:noFill/>
+          <a:ln w="9525">
+            <a:solidFill>
+              <a:srgbClr val="DDE2ED"/>
+            </a:solidFill>
           </a:ln>
           <a:effectLst/>
         </p:spPr>
@@ -8057,7 +7898,329 @@
       </p:sp>
       <p:sp>
         <p:nvSpPr>
-          <p:cNvPr id="1221" name="Leitura interna texto"/>
+          <p:cNvPr id="1218" name="Canal rótulo ZAP VLI"/>
+          <p:cNvSpPr txBox="1"/>
+          <p:nvPr/>
+        </p:nvSpPr>
+        <p:spPr>
+          <a:xfrm>
+            <a:off x="2724912" y="5897880"/>
+            <a:ext cx="2103120" cy="128016"/>
+          </a:xfrm>
+          <a:prstGeom prst="rect">
+            <a:avLst/>
+          </a:prstGeom>
+          <a:noFill/>
+        </p:spPr>
+        <p:txBody>
+          <a:bodyPr wrap="square" anchor="t" lIns="0" rIns="0" tIns="0" bIns="0">
+            <a:spAutoFit/>
+          </a:bodyPr>
+          <a:lstStyle/>
+          <a:p>
+            <a:pPr algn="l"/>
+            <a:r>
+              <a:rPr sz="750" b="1">
+                <a:solidFill>
+                  <a:srgbClr val="43597E"/>
+                </a:solidFill>
+                <a:latin typeface="Manrope"/>
+              </a:rPr>
+              <a:t>ZAP VLI</a:t>
+            </a:r>
+          </a:p>
+        </p:txBody>
+      </p:sp>
+      <p:sp>
+        <p:nvSpPr>
+          <p:cNvPr id="1219" name="Canal KPI ZAP VLI"/>
+          <p:cNvSpPr txBox="1"/>
+          <p:nvPr/>
+        </p:nvSpPr>
+        <p:spPr>
+          <a:xfrm>
+            <a:off x="2724912" y="6035040"/>
+            <a:ext cx="2103120" cy="274320"/>
+          </a:xfrm>
+          <a:prstGeom prst="rect">
+            <a:avLst/>
+          </a:prstGeom>
+          <a:noFill/>
+        </p:spPr>
+        <p:txBody>
+          <a:bodyPr wrap="square" anchor="t" lIns="0" rIns="0" tIns="0" bIns="0">
+            <a:spAutoFit/>
+          </a:bodyPr>
+          <a:lstStyle/>
+          <a:p>
+            <a:pPr algn="l"/>
+            <a:r>
+              <a:rPr sz="1700" b="1">
+                <a:solidFill>
+                  <a:srgbClr val="142B52"/>
+                </a:solidFill>
+                <a:latin typeface="Manrope"/>
+              </a:rPr>
+              <a:t>56,5%</a:t>
+            </a:r>
+            <a:r>
+              <a:rPr sz="850" b="0">
+                <a:solidFill>
+                  <a:srgbClr val="6B7894"/>
+                </a:solidFill>
+                <a:latin typeface="Manrope"/>
+              </a:rPr>
+              <a:t>  leitura</a:t>
+            </a:r>
+          </a:p>
+        </p:txBody>
+      </p:sp>
+      <p:sp>
+        <p:nvSpPr>
+          <p:cNvPr id="1220" name="Canal detalhe ZAP VLI"/>
+          <p:cNvSpPr txBox="1"/>
+          <p:nvPr/>
+        </p:nvSpPr>
+        <p:spPr>
+          <a:xfrm>
+            <a:off x="2724912" y="6345936"/>
+            <a:ext cx="2103120" cy="310896"/>
+          </a:xfrm>
+          <a:prstGeom prst="rect">
+            <a:avLst/>
+          </a:prstGeom>
+          <a:noFill/>
+        </p:spPr>
+        <p:txBody>
+          <a:bodyPr wrap="square" anchor="t" lIns="0" rIns="0" tIns="0" bIns="0">
+            <a:spAutoFit/>
+          </a:bodyPr>
+          <a:lstStyle/>
+          <a:p>
+            <a:pPr algn="l"/>
+            <a:r>
+              <a:rPr sz="750" b="0">
+                <a:solidFill>
+                  <a:srgbClr val="6B7894"/>
+                </a:solidFill>
+                <a:latin typeface="Manrope"/>
+              </a:rPr>
+              <a:t>3.516 recebidas · 1.985 leituras · 181 interações (9,1%)</a:t>
+            </a:r>
+          </a:p>
+        </p:txBody>
+      </p:sp>
+      <p:sp>
+        <p:nvSpPr>
+          <p:cNvPr id="1221" name="Canal INTRANET VLI@"/>
+          <p:cNvSpPr/>
+          <p:nvPr/>
+        </p:nvSpPr>
+        <p:spPr>
+          <a:xfrm>
+            <a:off x="4965192" y="5852160"/>
+            <a:ext cx="2258568" cy="822960"/>
+          </a:xfrm>
+          <a:prstGeom prst="roundRect">
+            <a:avLst>
+              <a:gd name="adj" fmla="val 5000"/>
+            </a:avLst>
+          </a:prstGeom>
+          <a:solidFill>
+            <a:srgbClr val="FFFFFF"/>
+          </a:solidFill>
+          <a:ln w="9525">
+            <a:solidFill>
+              <a:srgbClr val="DDE2ED"/>
+            </a:solidFill>
+          </a:ln>
+          <a:effectLst/>
+        </p:spPr>
+        <p:style>
+          <a:lnRef idx="1">
+            <a:schemeClr val="accent1"/>
+          </a:lnRef>
+          <a:fillRef idx="3">
+            <a:schemeClr val="accent1"/>
+          </a:fillRef>
+          <a:effectRef idx="2">
+            <a:schemeClr val="accent1"/>
+          </a:effectRef>
+          <a:fontRef idx="minor">
+            <a:schemeClr val="lt1"/>
+          </a:fontRef>
+        </p:style>
+        <p:txBody>
+          <a:bodyPr rtlCol="0" anchor="ctr"/>
+          <a:lstStyle/>
+          <a:p>
+            <a:pPr algn="ctr"/>
+          </a:p>
+        </p:txBody>
+      </p:sp>
+      <p:sp>
+        <p:nvSpPr>
+          <p:cNvPr id="1222" name="Canal rótulo INTRANET VLI@"/>
+          <p:cNvSpPr txBox="1"/>
+          <p:nvPr/>
+        </p:nvSpPr>
+        <p:spPr>
+          <a:xfrm>
+            <a:off x="5056631" y="5897880"/>
+            <a:ext cx="2103120" cy="128016"/>
+          </a:xfrm>
+          <a:prstGeom prst="rect">
+            <a:avLst/>
+          </a:prstGeom>
+          <a:noFill/>
+        </p:spPr>
+        <p:txBody>
+          <a:bodyPr wrap="square" anchor="t" lIns="0" rIns="0" tIns="0" bIns="0">
+            <a:spAutoFit/>
+          </a:bodyPr>
+          <a:lstStyle/>
+          <a:p>
+            <a:pPr algn="l"/>
+            <a:r>
+              <a:rPr sz="750" b="1">
+                <a:solidFill>
+                  <a:srgbClr val="43597E"/>
+                </a:solidFill>
+                <a:latin typeface="Manrope"/>
+              </a:rPr>
+              <a:t>INTRANET VLI@</a:t>
+            </a:r>
+          </a:p>
+        </p:txBody>
+      </p:sp>
+      <p:sp>
+        <p:nvSpPr>
+          <p:cNvPr id="1223" name="Canal KPI INTRANET VLI@"/>
+          <p:cNvSpPr txBox="1"/>
+          <p:nvPr/>
+        </p:nvSpPr>
+        <p:spPr>
+          <a:xfrm>
+            <a:off x="5056631" y="6035040"/>
+            <a:ext cx="2103120" cy="274320"/>
+          </a:xfrm>
+          <a:prstGeom prst="rect">
+            <a:avLst/>
+          </a:prstGeom>
+          <a:noFill/>
+        </p:spPr>
+        <p:txBody>
+          <a:bodyPr wrap="square" anchor="t" lIns="0" rIns="0" tIns="0" bIns="0">
+            <a:spAutoFit/>
+          </a:bodyPr>
+          <a:lstStyle/>
+          <a:p>
+            <a:pPr algn="l"/>
+            <a:r>
+              <a:rPr sz="1700" b="1">
+                <a:solidFill>
+                  <a:srgbClr val="142B52"/>
+                </a:solidFill>
+                <a:latin typeface="Manrope"/>
+              </a:rPr>
+              <a:t>114</a:t>
+            </a:r>
+            <a:r>
+              <a:rPr sz="850" b="0">
+                <a:solidFill>
+                  <a:srgbClr val="6B7894"/>
+                </a:solidFill>
+                <a:latin typeface="Manrope"/>
+              </a:rPr>
+              <a:t>  exibições</a:t>
+            </a:r>
+          </a:p>
+        </p:txBody>
+      </p:sp>
+      <p:sp>
+        <p:nvSpPr>
+          <p:cNvPr id="1224" name="Canal detalhe INTRANET VLI@"/>
+          <p:cNvSpPr txBox="1"/>
+          <p:nvPr/>
+        </p:nvSpPr>
+        <p:spPr>
+          <a:xfrm>
+            <a:off x="5056631" y="6345936"/>
+            <a:ext cx="2103120" cy="310896"/>
+          </a:xfrm>
+          <a:prstGeom prst="rect">
+            <a:avLst/>
+          </a:prstGeom>
+          <a:noFill/>
+        </p:spPr>
+        <p:txBody>
+          <a:bodyPr wrap="square" anchor="t" lIns="0" rIns="0" tIns="0" bIns="0">
+            <a:spAutoFit/>
+          </a:bodyPr>
+          <a:lstStyle/>
+          <a:p>
+            <a:pPr algn="l"/>
+            <a:r>
+              <a:rPr sz="750" b="0">
+                <a:solidFill>
+                  <a:srgbClr val="6B7894"/>
+                </a:solidFill>
+                <a:latin typeface="Manrope"/>
+              </a:rPr>
+              <a:t>Matéria com ações educativas e dicas para o trânsito</a:t>
+            </a:r>
+          </a:p>
+        </p:txBody>
+      </p:sp>
+      <p:sp>
+        <p:nvSpPr>
+          <p:cNvPr id="1225" name="Leitura interna"/>
+          <p:cNvSpPr/>
+          <p:nvPr/>
+        </p:nvSpPr>
+        <p:spPr>
+          <a:xfrm>
+            <a:off x="7296912" y="5852160"/>
+            <a:ext cx="4590288" cy="822960"/>
+          </a:xfrm>
+          <a:prstGeom prst="roundRect">
+            <a:avLst>
+              <a:gd name="adj" fmla="val 5000"/>
+            </a:avLst>
+          </a:prstGeom>
+          <a:solidFill>
+            <a:srgbClr val="E6EBF3"/>
+          </a:solidFill>
+          <a:ln>
+            <a:noFill/>
+          </a:ln>
+          <a:effectLst/>
+        </p:spPr>
+        <p:style>
+          <a:lnRef idx="1">
+            <a:schemeClr val="accent1"/>
+          </a:lnRef>
+          <a:fillRef idx="3">
+            <a:schemeClr val="accent1"/>
+          </a:fillRef>
+          <a:effectRef idx="2">
+            <a:schemeClr val="accent1"/>
+          </a:effectRef>
+          <a:fontRef idx="minor">
+            <a:schemeClr val="lt1"/>
+          </a:fontRef>
+        </p:style>
+        <p:txBody>
+          <a:bodyPr rtlCol="0" anchor="ctr"/>
+          <a:lstStyle/>
+          <a:p>
+            <a:pPr algn="ctr"/>
+          </a:p>
+        </p:txBody>
+      </p:sp>
+      <p:sp>
+        <p:nvSpPr>
+          <p:cNvPr id="1226" name="Leitura interna texto"/>
           <p:cNvSpPr txBox="1"/>
           <p:nvPr/>
         </p:nvSpPr>
@@ -8130,7 +8293,7 @@
       </p:sp>
       <p:sp>
         <p:nvSpPr>
-          <p:cNvPr id="1222" name="Rodapé"/>
+          <p:cNvPr id="1227" name="Rodapé"/>
           <p:cNvSpPr txBox="1"/>
           <p:nvPr/>
         </p:nvSpPr>
@@ -8158,7 +8321,7 @@
                 </a:solidFill>
                 <a:latin typeface="Manrope"/>
               </a:rPr>
-              <a:t>Custo: orçamento inicial de R$ 60 mil; realizado em torno de R$ 35 mil (economia ≈ R$ 25 mil). Mídia líquida: on R$ 10.539,60 + off R$ 5.738,01. Fontes: ANR SNT e Relatório de Comunicação Interna, setembro.</a:t>
+              <a:t>Custo: orçado R$ 60 mil, realizado ~R$ 35 mil (−42%); última campanha: R$ 115 mil (−70%). Alcances de frentes diferentes não são somáveis. Fontes: ANR SNT e Relatório de Comunicação Interna, setembro.</a:t>
             </a:r>
           </a:p>
         </p:txBody>

</xml_diff>

<commit_message>
SNT summary slide: larger text, more synthetic copy
Co-Authored-By: Claude Sonnet 5.5 <noreply@anthropic.com>
Claude-Session: https://claude.ai/code/session_01Y8xeok1NgQ689Ht8iSN8YH
</commit_message>
<xml_diff>
--- a/ANR_SNT_executivo.pptx
+++ b/ANR_SNT_executivo.pptx
@@ -557,7 +557,7 @@
           <a:lstStyle/>
           <a:p>
             <a:r>
-              <a:t>Quadro resumo SNT: Digital (mídia on/off), Imprensa (69 inserções, 6,3 mi de alcance, recorde), Comunicação Interna e contenção de custo (R$ 60 mil orçados, ~R$ 35 mil realizados; −70% vs última campanha de R$ 115 mil).</a:t>
+              <a:t>Quadro resumo SNT: Digital (mídia on/off e repercussão orgânica), Imprensa (69 inserções, 6,3 mi de alcance, recorde), Comunicação Interna e contenção de custo (R$ 60 mil orçados, ~R$ 35 mil realizados; −70% vs última campanha de R$ 115 mil).</a:t>
             </a:r>
           </a:p>
         </p:txBody>
@@ -4145,7 +4145,7 @@
         <p:spPr>
           <a:xfrm>
             <a:off x="301752" y="1051560"/>
-            <a:ext cx="1819656" cy="749808"/>
+            <a:ext cx="1819656" cy="777240"/>
           </a:xfrm>
           <a:prstGeom prst="roundRect">
             <a:avLst>
@@ -4192,8 +4192,8 @@
         </p:nvSpPr>
         <p:spPr>
           <a:xfrm>
-            <a:off x="411480" y="1088136"/>
-            <a:ext cx="1636776" cy="347472"/>
+            <a:off x="411480" y="1069848"/>
+            <a:ext cx="1636776" cy="384048"/>
           </a:xfrm>
           <a:prstGeom prst="rect">
             <a:avLst/>
@@ -4208,7 +4208,7 @@
           <a:p>
             <a:pPr algn="l"/>
             <a:r>
-              <a:rPr sz="2100" b="1">
+              <a:rPr sz="2400" b="1">
                 <a:solidFill>
                   <a:srgbClr val="F37919"/>
                 </a:solidFill>
@@ -4227,8 +4227,8 @@
         </p:nvSpPr>
         <p:spPr>
           <a:xfrm>
-            <a:off x="411480" y="1463040"/>
-            <a:ext cx="1636776" cy="137160"/>
+            <a:off x="411480" y="1444752"/>
+            <a:ext cx="1636776" cy="155448"/>
           </a:xfrm>
           <a:prstGeom prst="rect">
             <a:avLst/>
@@ -4243,7 +4243,7 @@
           <a:p>
             <a:pPr algn="l"/>
             <a:r>
-              <a:rPr sz="800" b="1">
+              <a:rPr sz="1000" b="1">
                 <a:solidFill>
                   <a:srgbClr val="142B52"/>
                 </a:solidFill>
@@ -4262,8 +4262,8 @@
         </p:nvSpPr>
         <p:spPr>
           <a:xfrm>
-            <a:off x="411480" y="1609344"/>
-            <a:ext cx="1636776" cy="137160"/>
+            <a:off x="411480" y="1618488"/>
+            <a:ext cx="1636776" cy="155448"/>
           </a:xfrm>
           <a:prstGeom prst="rect">
             <a:avLst/>
@@ -4278,7 +4278,7 @@
           <a:p>
             <a:pPr algn="l"/>
             <a:r>
-              <a:rPr sz="800" b="0">
+              <a:rPr sz="900" b="0">
                 <a:solidFill>
                   <a:srgbClr val="6B7894"/>
                 </a:solidFill>
@@ -4298,7 +4298,7 @@
         <p:spPr>
           <a:xfrm>
             <a:off x="2254910" y="1051560"/>
-            <a:ext cx="1819656" cy="749808"/>
+            <a:ext cx="1819656" cy="777240"/>
           </a:xfrm>
           <a:prstGeom prst="roundRect">
             <a:avLst>
@@ -4345,8 +4345,8 @@
         </p:nvSpPr>
         <p:spPr>
           <a:xfrm>
-            <a:off x="2364638" y="1088136"/>
-            <a:ext cx="1636776" cy="347472"/>
+            <a:off x="2364638" y="1069848"/>
+            <a:ext cx="1636776" cy="384048"/>
           </a:xfrm>
           <a:prstGeom prst="rect">
             <a:avLst/>
@@ -4361,7 +4361,7 @@
           <a:p>
             <a:pPr algn="l"/>
             <a:r>
-              <a:rPr sz="2100" b="1">
+              <a:rPr sz="2400" b="1">
                 <a:solidFill>
                   <a:srgbClr val="F37919"/>
                 </a:solidFill>
@@ -4380,8 +4380,8 @@
         </p:nvSpPr>
         <p:spPr>
           <a:xfrm>
-            <a:off x="2364638" y="1463040"/>
-            <a:ext cx="1636776" cy="137160"/>
+            <a:off x="2364638" y="1444752"/>
+            <a:ext cx="1636776" cy="155448"/>
           </a:xfrm>
           <a:prstGeom prst="rect">
             <a:avLst/>
@@ -4396,7 +4396,7 @@
           <a:p>
             <a:pPr algn="l"/>
             <a:r>
-              <a:rPr sz="800" b="1">
+              <a:rPr sz="1000" b="1">
                 <a:solidFill>
                   <a:srgbClr val="142B52"/>
                 </a:solidFill>
@@ -4415,8 +4415,8 @@
         </p:nvSpPr>
         <p:spPr>
           <a:xfrm>
-            <a:off x="2364638" y="1609344"/>
-            <a:ext cx="1636776" cy="137160"/>
+            <a:off x="2364638" y="1618488"/>
+            <a:ext cx="1636776" cy="155448"/>
           </a:xfrm>
           <a:prstGeom prst="rect">
             <a:avLst/>
@@ -4431,7 +4431,7 @@
           <a:p>
             <a:pPr algn="l"/>
             <a:r>
-              <a:rPr sz="800" b="0">
+              <a:rPr sz="900" b="0">
                 <a:solidFill>
                   <a:srgbClr val="6B7894"/>
                 </a:solidFill>
@@ -4444,14 +4444,14 @@
       </p:sp>
       <p:sp>
         <p:nvSpPr>
-          <p:cNvPr id="1137" name="Tile repercussão digital orgânica"/>
+          <p:cNvPr id="1137" name="Tile repercussão orgânica"/>
           <p:cNvSpPr/>
           <p:nvPr/>
         </p:nvSpPr>
         <p:spPr>
           <a:xfrm>
             <a:off x="4208068" y="1051560"/>
-            <a:ext cx="1819656" cy="749808"/>
+            <a:ext cx="1819656" cy="777240"/>
           </a:xfrm>
           <a:prstGeom prst="roundRect">
             <a:avLst>
@@ -4492,14 +4492,14 @@
       </p:sp>
       <p:sp>
         <p:nvSpPr>
-          <p:cNvPr id="1138" name="Big repercussão digital orgânica"/>
+          <p:cNvPr id="1138" name="Big repercussão orgânica"/>
           <p:cNvSpPr txBox="1"/>
           <p:nvPr/>
         </p:nvSpPr>
         <p:spPr>
           <a:xfrm>
-            <a:off x="4317796" y="1088136"/>
-            <a:ext cx="1636776" cy="347472"/>
+            <a:off x="4317796" y="1069848"/>
+            <a:ext cx="1636776" cy="384048"/>
           </a:xfrm>
           <a:prstGeom prst="rect">
             <a:avLst/>
@@ -4514,7 +4514,7 @@
           <a:p>
             <a:pPr algn="l"/>
             <a:r>
-              <a:rPr sz="2100" b="1">
+              <a:rPr sz="2400" b="1">
                 <a:solidFill>
                   <a:srgbClr val="1971BA"/>
                 </a:solidFill>
@@ -4527,14 +4527,14 @@
       </p:sp>
       <p:sp>
         <p:nvSpPr>
-          <p:cNvPr id="1139" name="Rótulo repercussão digital orgânica"/>
+          <p:cNvPr id="1139" name="Rótulo repercussão orgânica"/>
           <p:cNvSpPr txBox="1"/>
           <p:nvPr/>
         </p:nvSpPr>
         <p:spPr>
           <a:xfrm>
-            <a:off x="4317796" y="1463040"/>
-            <a:ext cx="1636776" cy="137160"/>
+            <a:off x="4317796" y="1444752"/>
+            <a:ext cx="1636776" cy="155448"/>
           </a:xfrm>
           <a:prstGeom prst="rect">
             <a:avLst/>
@@ -4549,27 +4549,27 @@
           <a:p>
             <a:pPr algn="l"/>
             <a:r>
-              <a:rPr sz="800" b="1">
+              <a:rPr sz="1000" b="1">
                 <a:solidFill>
                   <a:srgbClr val="142B52"/>
                 </a:solidFill>
                 <a:latin typeface="Manrope"/>
               </a:rPr>
-              <a:t>repercussão digital orgânica</a:t>
-            </a:r>
-          </a:p>
-        </p:txBody>
-      </p:sp>
-      <p:sp>
-        <p:nvSpPr>
-          <p:cNvPr id="1140" name="Sub repercussão digital orgânica"/>
+              <a:t>repercussão orgânica</a:t>
+            </a:r>
+          </a:p>
+        </p:txBody>
+      </p:sp>
+      <p:sp>
+        <p:nvSpPr>
+          <p:cNvPr id="1140" name="Sub repercussão orgânica"/>
           <p:cNvSpPr txBox="1"/>
           <p:nvPr/>
         </p:nvSpPr>
         <p:spPr>
           <a:xfrm>
-            <a:off x="4317796" y="1609344"/>
-            <a:ext cx="1636776" cy="137160"/>
+            <a:off x="4317796" y="1618488"/>
+            <a:ext cx="1636776" cy="155448"/>
           </a:xfrm>
           <a:prstGeom prst="rect">
             <a:avLst/>
@@ -4584,13 +4584,13 @@
           <a:p>
             <a:pPr algn="l"/>
             <a:r>
-              <a:rPr sz="800" b="0">
+              <a:rPr sz="900" b="0">
                 <a:solidFill>
                   <a:srgbClr val="6B7894"/>
                 </a:solidFill>
                 <a:latin typeface="Manrope"/>
               </a:rPr>
-              <a:t>alcance potencial em redes</a:t>
+              <a:t>potencial nas redes</a:t>
             </a:r>
           </a:p>
         </p:txBody>
@@ -4604,7 +4604,7 @@
         <p:spPr>
           <a:xfrm>
             <a:off x="6161227" y="1051560"/>
-            <a:ext cx="1819656" cy="749808"/>
+            <a:ext cx="1819656" cy="777240"/>
           </a:xfrm>
           <a:prstGeom prst="roundRect">
             <a:avLst>
@@ -4651,8 +4651,8 @@
         </p:nvSpPr>
         <p:spPr>
           <a:xfrm>
-            <a:off x="6270955" y="1088136"/>
-            <a:ext cx="1636776" cy="347472"/>
+            <a:off x="6270955" y="1069848"/>
+            <a:ext cx="1636776" cy="384048"/>
           </a:xfrm>
           <a:prstGeom prst="rect">
             <a:avLst/>
@@ -4667,7 +4667,7 @@
           <a:p>
             <a:pPr algn="l"/>
             <a:r>
-              <a:rPr sz="2100" b="1">
+              <a:rPr sz="2400" b="1">
                 <a:solidFill>
                   <a:srgbClr val="1971BA"/>
                 </a:solidFill>
@@ -4686,8 +4686,8 @@
         </p:nvSpPr>
         <p:spPr>
           <a:xfrm>
-            <a:off x="6270955" y="1463040"/>
-            <a:ext cx="1636776" cy="137160"/>
+            <a:off x="6270955" y="1444752"/>
+            <a:ext cx="1636776" cy="155448"/>
           </a:xfrm>
           <a:prstGeom prst="rect">
             <a:avLst/>
@@ -4702,7 +4702,7 @@
           <a:p>
             <a:pPr algn="l"/>
             <a:r>
-              <a:rPr sz="800" b="1">
+              <a:rPr sz="1000" b="1">
                 <a:solidFill>
                   <a:srgbClr val="142B52"/>
                 </a:solidFill>
@@ -4721,8 +4721,8 @@
         </p:nvSpPr>
         <p:spPr>
           <a:xfrm>
-            <a:off x="6270955" y="1609344"/>
-            <a:ext cx="1636776" cy="137160"/>
+            <a:off x="6270955" y="1618488"/>
+            <a:ext cx="1636776" cy="155448"/>
           </a:xfrm>
           <a:prstGeom prst="rect">
             <a:avLst/>
@@ -4737,7 +4737,7 @@
           <a:p>
             <a:pPr algn="l"/>
             <a:r>
-              <a:rPr sz="800" b="0">
+              <a:rPr sz="900" b="0">
                 <a:solidFill>
                   <a:srgbClr val="6B7894"/>
                 </a:solidFill>
@@ -4750,14 +4750,14 @@
       </p:sp>
       <p:sp>
         <p:nvSpPr>
-          <p:cNvPr id="1145" name="Tile leitura no ZAP (interno)"/>
+          <p:cNvPr id="1145" name="Tile leitura no ZAP"/>
           <p:cNvSpPr/>
           <p:nvPr/>
         </p:nvSpPr>
         <p:spPr>
           <a:xfrm>
             <a:off x="8114385" y="1051560"/>
-            <a:ext cx="1819656" cy="749808"/>
+            <a:ext cx="1819656" cy="777240"/>
           </a:xfrm>
           <a:prstGeom prst="roundRect">
             <a:avLst>
@@ -4798,14 +4798,14 @@
       </p:sp>
       <p:sp>
         <p:nvSpPr>
-          <p:cNvPr id="1146" name="Big leitura no ZAP (interno)"/>
+          <p:cNvPr id="1146" name="Big leitura no ZAP"/>
           <p:cNvSpPr txBox="1"/>
           <p:nvPr/>
         </p:nvSpPr>
         <p:spPr>
           <a:xfrm>
-            <a:off x="8224113" y="1088136"/>
-            <a:ext cx="1636776" cy="347472"/>
+            <a:off x="8224113" y="1069848"/>
+            <a:ext cx="1636776" cy="384048"/>
           </a:xfrm>
           <a:prstGeom prst="rect">
             <a:avLst/>
@@ -4820,7 +4820,7 @@
           <a:p>
             <a:pPr algn="l"/>
             <a:r>
-              <a:rPr sz="2100" b="1">
+              <a:rPr sz="2400" b="1">
                 <a:solidFill>
                   <a:srgbClr val="43597E"/>
                 </a:solidFill>
@@ -4833,14 +4833,14 @@
       </p:sp>
       <p:sp>
         <p:nvSpPr>
-          <p:cNvPr id="1147" name="Rótulo leitura no ZAP (interno)"/>
+          <p:cNvPr id="1147" name="Rótulo leitura no ZAP"/>
           <p:cNvSpPr txBox="1"/>
           <p:nvPr/>
         </p:nvSpPr>
         <p:spPr>
           <a:xfrm>
-            <a:off x="8224113" y="1463040"/>
-            <a:ext cx="1636776" cy="137160"/>
+            <a:off x="8224113" y="1444752"/>
+            <a:ext cx="1636776" cy="155448"/>
           </a:xfrm>
           <a:prstGeom prst="rect">
             <a:avLst/>
@@ -4855,27 +4855,27 @@
           <a:p>
             <a:pPr algn="l"/>
             <a:r>
-              <a:rPr sz="800" b="1">
+              <a:rPr sz="1000" b="1">
                 <a:solidFill>
                   <a:srgbClr val="142B52"/>
                 </a:solidFill>
                 <a:latin typeface="Manrope"/>
               </a:rPr>
-              <a:t>leitura no ZAP (interno)</a:t>
-            </a:r>
-          </a:p>
-        </p:txBody>
-      </p:sp>
-      <p:sp>
-        <p:nvSpPr>
-          <p:cNvPr id="1148" name="Sub leitura no ZAP (interno)"/>
+              <a:t>leitura no ZAP</a:t>
+            </a:r>
+          </a:p>
+        </p:txBody>
+      </p:sp>
+      <p:sp>
+        <p:nvSpPr>
+          <p:cNvPr id="1148" name="Sub leitura no ZAP"/>
           <p:cNvSpPr txBox="1"/>
           <p:nvPr/>
         </p:nvSpPr>
         <p:spPr>
           <a:xfrm>
-            <a:off x="8224113" y="1609344"/>
-            <a:ext cx="1636776" cy="137160"/>
+            <a:off x="8224113" y="1618488"/>
+            <a:ext cx="1636776" cy="155448"/>
           </a:xfrm>
           <a:prstGeom prst="rect">
             <a:avLst/>
@@ -4890,7 +4890,7 @@
           <a:p>
             <a:pPr algn="l"/>
             <a:r>
-              <a:rPr sz="800" b="0">
+              <a:rPr sz="900" b="0">
                 <a:solidFill>
                   <a:srgbClr val="6B7894"/>
                 </a:solidFill>
@@ -4903,14 +4903,14 @@
       </p:sp>
       <p:sp>
         <p:nvSpPr>
-          <p:cNvPr id="1149" name="Tile custo vs orçado de R$ 60 mil"/>
+          <p:cNvPr id="1149" name="Tile custo vs orçado"/>
           <p:cNvSpPr/>
           <p:nvPr/>
         </p:nvSpPr>
         <p:spPr>
           <a:xfrm>
             <a:off x="10067544" y="1051560"/>
-            <a:ext cx="1819656" cy="749808"/>
+            <a:ext cx="1819656" cy="777240"/>
           </a:xfrm>
           <a:prstGeom prst="roundRect">
             <a:avLst>
@@ -4951,14 +4951,14 @@
       </p:sp>
       <p:sp>
         <p:nvSpPr>
-          <p:cNvPr id="1150" name="Big custo vs orçado de R$ 60 mil"/>
+          <p:cNvPr id="1150" name="Big custo vs orçado"/>
           <p:cNvSpPr txBox="1"/>
           <p:nvPr/>
         </p:nvSpPr>
         <p:spPr>
           <a:xfrm>
-            <a:off x="10177272" y="1088136"/>
-            <a:ext cx="1636776" cy="347472"/>
+            <a:off x="10177272" y="1069848"/>
+            <a:ext cx="1636776" cy="384048"/>
           </a:xfrm>
           <a:prstGeom prst="rect">
             <a:avLst/>
@@ -4973,7 +4973,7 @@
           <a:p>
             <a:pPr algn="l"/>
             <a:r>
-              <a:rPr sz="2100" b="1">
+              <a:rPr sz="2400" b="1">
                 <a:solidFill>
                   <a:srgbClr val="1B7F4E"/>
                 </a:solidFill>
@@ -4986,14 +4986,14 @@
       </p:sp>
       <p:sp>
         <p:nvSpPr>
-          <p:cNvPr id="1151" name="Rótulo custo vs orçado de R$ 60 mil"/>
+          <p:cNvPr id="1151" name="Rótulo custo vs orçado"/>
           <p:cNvSpPr txBox="1"/>
           <p:nvPr/>
         </p:nvSpPr>
         <p:spPr>
           <a:xfrm>
-            <a:off x="10177272" y="1463040"/>
-            <a:ext cx="1636776" cy="137160"/>
+            <a:off x="10177272" y="1444752"/>
+            <a:ext cx="1636776" cy="155448"/>
           </a:xfrm>
           <a:prstGeom prst="rect">
             <a:avLst/>
@@ -5008,27 +5008,27 @@
           <a:p>
             <a:pPr algn="l"/>
             <a:r>
-              <a:rPr sz="800" b="1">
+              <a:rPr sz="1000" b="1">
                 <a:solidFill>
                   <a:srgbClr val="142B52"/>
                 </a:solidFill>
                 <a:latin typeface="Manrope"/>
               </a:rPr>
-              <a:t>custo vs orçado de R$ 60 mil</a:t>
-            </a:r>
-          </a:p>
-        </p:txBody>
-      </p:sp>
-      <p:sp>
-        <p:nvSpPr>
-          <p:cNvPr id="1152" name="Sub custo vs orçado de R$ 60 mil"/>
+              <a:t>custo vs orçado</a:t>
+            </a:r>
+          </a:p>
+        </p:txBody>
+      </p:sp>
+      <p:sp>
+        <p:nvSpPr>
+          <p:cNvPr id="1152" name="Sub custo vs orçado"/>
           <p:cNvSpPr txBox="1"/>
           <p:nvPr/>
         </p:nvSpPr>
         <p:spPr>
           <a:xfrm>
-            <a:off x="10177272" y="1609344"/>
-            <a:ext cx="1636776" cy="137160"/>
+            <a:off x="10177272" y="1618488"/>
+            <a:ext cx="1636776" cy="155448"/>
           </a:xfrm>
           <a:prstGeom prst="rect">
             <a:avLst/>
@@ -5043,13 +5043,13 @@
           <a:p>
             <a:pPr algn="l"/>
             <a:r>
-              <a:rPr sz="800" b="0">
+              <a:rPr sz="900" b="0">
                 <a:solidFill>
                   <a:srgbClr val="6B7894"/>
                 </a:solidFill>
                 <a:latin typeface="Manrope"/>
               </a:rPr>
-              <a:t>−70% vs última (R$ 115 mil)</a:t>
+              <a:t>−70% vs última (R$115 mil)</a:t>
             </a:r>
           </a:p>
         </p:txBody>
@@ -5062,7 +5062,7 @@
         </p:nvSpPr>
         <p:spPr>
           <a:xfrm>
-            <a:off x="301752" y="1892807"/>
+            <a:off x="301752" y="1920240"/>
             <a:ext cx="7424927" cy="237744"/>
           </a:xfrm>
           <a:prstGeom prst="roundRect">
@@ -5108,7 +5108,7 @@
         </p:nvSpPr>
         <p:spPr>
           <a:xfrm>
-            <a:off x="411480" y="1892807"/>
+            <a:off x="411480" y="1920240"/>
             <a:ext cx="7242047" cy="237744"/>
           </a:xfrm>
           <a:prstGeom prst="rect">
@@ -5143,8 +5143,8 @@
         </p:nvSpPr>
         <p:spPr>
           <a:xfrm>
-            <a:off x="301752" y="2212848"/>
-            <a:ext cx="1234440" cy="694944"/>
+            <a:off x="301752" y="2240280"/>
+            <a:ext cx="1234440" cy="713232"/>
           </a:xfrm>
           <a:prstGeom prst="roundRect">
             <a:avLst>
@@ -5191,8 +5191,8 @@
         </p:nvSpPr>
         <p:spPr>
           <a:xfrm>
-            <a:off x="393192" y="2276856"/>
-            <a:ext cx="1097280" cy="109728"/>
+            <a:off x="393192" y="2295144"/>
+            <a:ext cx="1097280" cy="128016"/>
           </a:xfrm>
           <a:prstGeom prst="rect">
             <a:avLst/>
@@ -5207,7 +5207,7 @@
           <a:p>
             <a:pPr algn="l"/>
             <a:r>
-              <a:rPr sz="700" b="1">
+              <a:rPr sz="800" b="1">
                 <a:solidFill>
                   <a:srgbClr val="6B7894"/>
                 </a:solidFill>
@@ -5226,8 +5226,8 @@
         </p:nvSpPr>
         <p:spPr>
           <a:xfrm>
-            <a:off x="393192" y="2414016"/>
-            <a:ext cx="1097280" cy="228600"/>
+            <a:off x="393192" y="2441448"/>
+            <a:ext cx="1097280" cy="237744"/>
           </a:xfrm>
           <a:prstGeom prst="rect">
             <a:avLst/>
@@ -5242,7 +5242,7 @@
           <a:p>
             <a:pPr algn="l"/>
             <a:r>
-              <a:rPr sz="1300" b="1">
+              <a:rPr sz="1400" b="1">
                 <a:solidFill>
                   <a:srgbClr val="142B52"/>
                 </a:solidFill>
@@ -5261,8 +5261,8 @@
         </p:nvSpPr>
         <p:spPr>
           <a:xfrm>
-            <a:off x="393192" y="2688336"/>
-            <a:ext cx="1097280" cy="128016"/>
+            <a:off x="393192" y="2734056"/>
+            <a:ext cx="1097280" cy="146304"/>
           </a:xfrm>
           <a:prstGeom prst="rect">
             <a:avLst/>
@@ -5277,7 +5277,7 @@
           <a:p>
             <a:pPr algn="l"/>
             <a:r>
-              <a:rPr sz="800" b="1">
+              <a:rPr sz="950" b="1">
                 <a:solidFill>
                   <a:srgbClr val="1B7F4E"/>
                 </a:solidFill>
@@ -5296,8 +5296,8 @@
         </p:nvSpPr>
         <p:spPr>
           <a:xfrm>
-            <a:off x="1581912" y="2212848"/>
-            <a:ext cx="1234440" cy="694944"/>
+            <a:off x="1581912" y="2240280"/>
+            <a:ext cx="1234440" cy="713232"/>
           </a:xfrm>
           <a:prstGeom prst="roundRect">
             <a:avLst>
@@ -5344,8 +5344,8 @@
         </p:nvSpPr>
         <p:spPr>
           <a:xfrm>
-            <a:off x="1673352" y="2276856"/>
-            <a:ext cx="1097280" cy="109728"/>
+            <a:off x="1673352" y="2295144"/>
+            <a:ext cx="1097280" cy="128016"/>
           </a:xfrm>
           <a:prstGeom prst="rect">
             <a:avLst/>
@@ -5360,7 +5360,7 @@
           <a:p>
             <a:pPr algn="l"/>
             <a:r>
-              <a:rPr sz="700" b="1">
+              <a:rPr sz="800" b="1">
                 <a:solidFill>
                   <a:srgbClr val="6B7894"/>
                 </a:solidFill>
@@ -5379,8 +5379,8 @@
         </p:nvSpPr>
         <p:spPr>
           <a:xfrm>
-            <a:off x="1673352" y="2414016"/>
-            <a:ext cx="1097280" cy="228600"/>
+            <a:off x="1673352" y="2441448"/>
+            <a:ext cx="1097280" cy="237744"/>
           </a:xfrm>
           <a:prstGeom prst="rect">
             <a:avLst/>
@@ -5395,7 +5395,7 @@
           <a:p>
             <a:pPr algn="l"/>
             <a:r>
-              <a:rPr sz="1300" b="1">
+              <a:rPr sz="1400" b="1">
                 <a:solidFill>
                   <a:srgbClr val="142B52"/>
                 </a:solidFill>
@@ -5414,8 +5414,8 @@
         </p:nvSpPr>
         <p:spPr>
           <a:xfrm>
-            <a:off x="1673352" y="2688336"/>
-            <a:ext cx="1097280" cy="128016"/>
+            <a:off x="1673352" y="2734056"/>
+            <a:ext cx="1097280" cy="146304"/>
           </a:xfrm>
           <a:prstGeom prst="rect">
             <a:avLst/>
@@ -5430,7 +5430,7 @@
           <a:p>
             <a:pPr algn="l"/>
             <a:r>
-              <a:rPr sz="800" b="1">
+              <a:rPr sz="950" b="1">
                 <a:solidFill>
                   <a:srgbClr val="F37919"/>
                 </a:solidFill>
@@ -5449,8 +5449,8 @@
         </p:nvSpPr>
         <p:spPr>
           <a:xfrm>
-            <a:off x="301752" y="2971800"/>
-            <a:ext cx="1234440" cy="694944"/>
+            <a:off x="301752" y="3017520"/>
+            <a:ext cx="1234440" cy="713232"/>
           </a:xfrm>
           <a:prstGeom prst="roundRect">
             <a:avLst>
@@ -5497,8 +5497,8 @@
         </p:nvSpPr>
         <p:spPr>
           <a:xfrm>
-            <a:off x="393192" y="3035808"/>
-            <a:ext cx="1097280" cy="109728"/>
+            <a:off x="393192" y="3072384"/>
+            <a:ext cx="1097280" cy="128016"/>
           </a:xfrm>
           <a:prstGeom prst="rect">
             <a:avLst/>
@@ -5513,7 +5513,7 @@
           <a:p>
             <a:pPr algn="l"/>
             <a:r>
-              <a:rPr sz="700" b="1">
+              <a:rPr sz="800" b="1">
                 <a:solidFill>
                   <a:srgbClr val="6B7894"/>
                 </a:solidFill>
@@ -5532,8 +5532,8 @@
         </p:nvSpPr>
         <p:spPr>
           <a:xfrm>
-            <a:off x="393192" y="3172968"/>
-            <a:ext cx="1097280" cy="228600"/>
+            <a:off x="393192" y="3218688"/>
+            <a:ext cx="1097280" cy="237744"/>
           </a:xfrm>
           <a:prstGeom prst="rect">
             <a:avLst/>
@@ -5548,7 +5548,7 @@
           <a:p>
             <a:pPr algn="l"/>
             <a:r>
-              <a:rPr sz="1300" b="1">
+              <a:rPr sz="1400" b="1">
                 <a:solidFill>
                   <a:srgbClr val="142B52"/>
                 </a:solidFill>
@@ -5567,8 +5567,8 @@
         </p:nvSpPr>
         <p:spPr>
           <a:xfrm>
-            <a:off x="393192" y="3447288"/>
-            <a:ext cx="1097280" cy="128016"/>
+            <a:off x="393192" y="3511296"/>
+            <a:ext cx="1097280" cy="146304"/>
           </a:xfrm>
           <a:prstGeom prst="rect">
             <a:avLst/>
@@ -5583,7 +5583,7 @@
           <a:p>
             <a:pPr algn="l"/>
             <a:r>
-              <a:rPr sz="800" b="1">
+              <a:rPr sz="950" b="1">
                 <a:solidFill>
                   <a:srgbClr val="1B7F4E"/>
                 </a:solidFill>
@@ -5602,8 +5602,8 @@
         </p:nvSpPr>
         <p:spPr>
           <a:xfrm>
-            <a:off x="1581912" y="2971800"/>
-            <a:ext cx="1234440" cy="694944"/>
+            <a:off x="1581912" y="3017520"/>
+            <a:ext cx="1234440" cy="713232"/>
           </a:xfrm>
           <a:prstGeom prst="roundRect">
             <a:avLst>
@@ -5650,8 +5650,8 @@
         </p:nvSpPr>
         <p:spPr>
           <a:xfrm>
-            <a:off x="1673352" y="3035808"/>
-            <a:ext cx="1097280" cy="109728"/>
+            <a:off x="1673352" y="3072384"/>
+            <a:ext cx="1097280" cy="128016"/>
           </a:xfrm>
           <a:prstGeom prst="rect">
             <a:avLst/>
@@ -5666,7 +5666,7 @@
           <a:p>
             <a:pPr algn="l"/>
             <a:r>
-              <a:rPr sz="700" b="1">
+              <a:rPr sz="800" b="1">
                 <a:solidFill>
                   <a:srgbClr val="6B7894"/>
                 </a:solidFill>
@@ -5685,8 +5685,8 @@
         </p:nvSpPr>
         <p:spPr>
           <a:xfrm>
-            <a:off x="1673352" y="3172968"/>
-            <a:ext cx="1097280" cy="228600"/>
+            <a:off x="1673352" y="3218688"/>
+            <a:ext cx="1097280" cy="237744"/>
           </a:xfrm>
           <a:prstGeom prst="rect">
             <a:avLst/>
@@ -5701,7 +5701,7 @@
           <a:p>
             <a:pPr algn="l"/>
             <a:r>
-              <a:rPr sz="1300" b="1">
+              <a:rPr sz="1400" b="1">
                 <a:solidFill>
                   <a:srgbClr val="142B52"/>
                 </a:solidFill>
@@ -5720,8 +5720,8 @@
         </p:nvSpPr>
         <p:spPr>
           <a:xfrm>
-            <a:off x="1673352" y="3447288"/>
-            <a:ext cx="1097280" cy="128016"/>
+            <a:off x="1673352" y="3511296"/>
+            <a:ext cx="1097280" cy="146304"/>
           </a:xfrm>
           <a:prstGeom prst="rect">
             <a:avLst/>
@@ -5736,7 +5736,7 @@
           <a:p>
             <a:pPr algn="l"/>
             <a:r>
-              <a:rPr sz="800" b="1">
+              <a:rPr sz="950" b="1">
                 <a:solidFill>
                   <a:srgbClr val="1B7F4E"/>
                 </a:solidFill>
@@ -5755,8 +5755,8 @@
         </p:nvSpPr>
         <p:spPr>
           <a:xfrm>
-            <a:off x="301752" y="3749039"/>
-            <a:ext cx="2514600" cy="146304"/>
+            <a:off x="301752" y="3813048"/>
+            <a:ext cx="2514600" cy="164592"/>
           </a:xfrm>
           <a:prstGeom prst="rect">
             <a:avLst/>
@@ -5771,16 +5771,16 @@
           <a:p>
             <a:pPr algn="l"/>
             <a:r>
-              <a:rPr sz="850" b="0">
+              <a:rPr sz="1000" b="0">
                 <a:solidFill>
                   <a:srgbClr val="6B7894"/>
                 </a:solidFill>
                 <a:latin typeface="Manrope"/>
               </a:rPr>
-              <a:t>Investimento líquido on  </a:t>
-            </a:r>
-            <a:r>
-              <a:rPr sz="850" b="1">
+              <a:t>Investimento on  </a:t>
+            </a:r>
+            <a:r>
+              <a:rPr sz="1000" b="1">
                 <a:solidFill>
                   <a:srgbClr val="142B52"/>
                 </a:solidFill>
@@ -5799,7 +5799,7 @@
         </p:nvSpPr>
         <p:spPr>
           <a:xfrm>
-            <a:off x="301752" y="4041648"/>
+            <a:off x="301752" y="4114800"/>
             <a:ext cx="2514600" cy="164592"/>
           </a:xfrm>
           <a:prstGeom prst="rect">
@@ -5815,7 +5815,7 @@
           <a:p>
             <a:pPr algn="l"/>
             <a:r>
-              <a:rPr sz="900" b="1">
+              <a:rPr sz="1000" b="1">
                 <a:solidFill>
                   <a:srgbClr val="43597E"/>
                 </a:solidFill>
@@ -5842,7 +5842,7 @@
         </p:blipFill>
         <p:spPr>
           <a:xfrm>
-            <a:off x="301752" y="4261104"/>
+            <a:off x="301752" y="4343400"/>
             <a:ext cx="1097280" cy="734684"/>
           </a:xfrm>
           <a:prstGeom prst="rect">
@@ -5858,7 +5858,7 @@
         </p:nvSpPr>
         <p:spPr>
           <a:xfrm>
-            <a:off x="1481328" y="4261104"/>
+            <a:off x="1481328" y="4343400"/>
             <a:ext cx="1371600" cy="822960"/>
           </a:xfrm>
           <a:prstGeom prst="rect">
@@ -5878,22 +5878,13 @@
               </a:spcAft>
             </a:pPr>
             <a:r>
-              <a:rPr sz="800" b="1">
+              <a:rPr sz="950" b="1">
                 <a:solidFill>
                   <a:srgbClr val="142B52"/>
                 </a:solidFill>
                 <a:latin typeface="Manrope"/>
               </a:rPr>
-              <a:t>OOH: </a:t>
-            </a:r>
-            <a:r>
-              <a:rPr sz="800" b="0">
-                <a:solidFill>
-                  <a:srgbClr val="142B52"/>
-                </a:solidFill>
-                <a:latin typeface="Manrope"/>
-              </a:rPr>
-              <a:t>Painel de LED, Banca de Led e Outdoor</a:t>
+              <a:t>OOH Betim (MG)</a:t>
             </a:r>
           </a:p>
           <a:p>
@@ -5903,16 +5894,7 @@
               </a:spcAft>
             </a:pPr>
             <a:r>
-              <a:rPr sz="800" b="1">
-                <a:solidFill>
-                  <a:srgbClr val="142B52"/>
-                </a:solidFill>
-                <a:latin typeface="Manrope"/>
-              </a:rPr>
-              <a:t>Veiculação: </a:t>
-            </a:r>
-            <a:r>
-              <a:rPr sz="800" b="0">
+              <a:rPr sz="950" b="0">
                 <a:solidFill>
                   <a:srgbClr val="142B52"/>
                 </a:solidFill>
@@ -5928,22 +5910,13 @@
               </a:spcAft>
             </a:pPr>
             <a:r>
-              <a:rPr sz="800" b="1">
+              <a:rPr sz="950" b="0">
                 <a:solidFill>
                   <a:srgbClr val="142B52"/>
                 </a:solidFill>
                 <a:latin typeface="Manrope"/>
               </a:rPr>
-              <a:t>Local: </a:t>
-            </a:r>
-            <a:r>
-              <a:rPr sz="800" b="0">
-                <a:solidFill>
-                  <a:srgbClr val="142B52"/>
-                </a:solidFill>
-                <a:latin typeface="Manrope"/>
-              </a:rPr>
-              <a:t>Betim (MG) – 4 pontos próximos a passagem em nível</a:t>
+              <a:t>4 pontos em passagens em nível</a:t>
             </a:r>
           </a:p>
         </p:txBody>
@@ -5956,8 +5929,8 @@
         </p:nvSpPr>
         <p:spPr>
           <a:xfrm>
-            <a:off x="301752" y="5230368"/>
-            <a:ext cx="2514600" cy="146304"/>
+            <a:off x="301752" y="5212080"/>
+            <a:ext cx="2514600" cy="164592"/>
           </a:xfrm>
           <a:prstGeom prst="rect">
             <a:avLst/>
@@ -5972,16 +5945,16 @@
           <a:p>
             <a:pPr algn="l"/>
             <a:r>
-              <a:rPr sz="850" b="0">
+              <a:rPr sz="1000" b="0">
                 <a:solidFill>
                   <a:srgbClr val="6B7894"/>
                 </a:solidFill>
                 <a:latin typeface="Manrope"/>
               </a:rPr>
-              <a:t>Investimento líquido off  </a:t>
-            </a:r>
-            <a:r>
-              <a:rPr sz="850" b="1">
+              <a:t>Investimento off  </a:t>
+            </a:r>
+            <a:r>
+              <a:rPr sz="1000" b="1">
                 <a:solidFill>
                   <a:srgbClr val="142B52"/>
                 </a:solidFill>
@@ -6000,7 +5973,7 @@
         </p:nvSpPr>
         <p:spPr>
           <a:xfrm>
-            <a:off x="2926080" y="2212848"/>
+            <a:off x="2926080" y="2240280"/>
             <a:ext cx="4800600" cy="1097280"/>
           </a:xfrm>
           <a:prstGeom prst="roundRect">
@@ -6048,8 +6021,8 @@
         </p:nvSpPr>
         <p:spPr>
           <a:xfrm>
-            <a:off x="3035808" y="2267712"/>
-            <a:ext cx="4581144" cy="128016"/>
+            <a:off x="3035808" y="2286000"/>
+            <a:ext cx="4581144" cy="146304"/>
           </a:xfrm>
           <a:prstGeom prst="rect">
             <a:avLst/>
@@ -6064,7 +6037,7 @@
           <a:p>
             <a:pPr algn="l"/>
             <a:r>
-              <a:rPr sz="800" b="1">
+              <a:rPr sz="900" b="1">
                 <a:solidFill>
                   <a:srgbClr val="43597E"/>
                 </a:solidFill>
@@ -6083,8 +6056,8 @@
         </p:nvSpPr>
         <p:spPr>
           <a:xfrm>
-            <a:off x="3035808" y="2423160"/>
-            <a:ext cx="4581144" cy="1024128"/>
+            <a:off x="3035808" y="2468880"/>
+            <a:ext cx="4581144" cy="841248"/>
           </a:xfrm>
           <a:prstGeom prst="rect">
             <a:avLst/>
@@ -6099,11 +6072,11 @@
           <a:p>
             <a:pPr algn="l">
               <a:spcAft>
-                <a:spcPts val="300"/>
+                <a:spcPts val="400"/>
               </a:spcAft>
             </a:pPr>
             <a:r>
-              <a:rPr sz="800" b="1">
+              <a:rPr sz="1100" b="1">
                 <a:solidFill>
                   <a:srgbClr val="142B52"/>
                 </a:solidFill>
@@ -6112,63 +6085,63 @@
               <a:t>Criativo: </a:t>
             </a:r>
             <a:r>
-              <a:rPr sz="800" b="0">
+              <a:rPr sz="1100" b="0">
                 <a:solidFill>
                   <a:srgbClr val="142B52"/>
                 </a:solidFill>
                 <a:latin typeface="Manrope"/>
               </a:rPr>
-              <a:t>identidade unificada do Movimento Nacional pela Segurança Ferroviária, com as demais concessionárias, e a ID de Maio Amarelo adaptada, garantindo visibilidade à VLI.</a:t>
+              <a:t>identidade unificada do Movimento + ID Maio Amarelo.</a:t>
             </a:r>
           </a:p>
           <a:p>
             <a:pPr algn="l">
               <a:spcAft>
-                <a:spcPts val="300"/>
+                <a:spcPts val="400"/>
               </a:spcAft>
             </a:pPr>
             <a:r>
-              <a:rPr sz="800" b="1">
+              <a:rPr sz="1100" b="1">
                 <a:solidFill>
                   <a:srgbClr val="142B52"/>
                 </a:solidFill>
                 <a:latin typeface="Manrope"/>
               </a:rPr>
-              <a:t>Mídia on e off: </a:t>
-            </a:r>
-            <a:r>
-              <a:rPr sz="800" b="0">
+              <a:t>Mídia: </a:t>
+            </a:r>
+            <a:r>
+              <a:rPr sz="1100" b="0">
                 <a:solidFill>
                   <a:srgbClr val="142B52"/>
                 </a:solidFill>
                 <a:latin typeface="Manrope"/>
               </a:rPr>
-              <a:t>convite para o Dia D + segurança no trânsito. Público 45+ concentrou quase metade do alcance; OOH com cobertura pré, durante e pós evento em Betim.</a:t>
+              <a:t>Dia D + trânsito; público 45+ foi quase metade do alcance.</a:t>
             </a:r>
           </a:p>
           <a:p>
             <a:pPr algn="l">
               <a:spcAft>
-                <a:spcPts val="300"/>
+                <a:spcPts val="400"/>
               </a:spcAft>
             </a:pPr>
             <a:r>
-              <a:rPr sz="800" b="1">
+              <a:rPr sz="1100" b="1">
                 <a:solidFill>
                   <a:srgbClr val="142B52"/>
                 </a:solidFill>
                 <a:latin typeface="Manrope"/>
               </a:rPr>
-              <a:t>Conteúdos: </a:t>
-            </a:r>
-            <a:r>
-              <a:rPr sz="800" b="0">
+              <a:t>Conteúdo: </a:t>
+            </a:r>
+            <a:r>
+              <a:rPr sz="1100" b="0">
                 <a:solidFill>
                   <a:srgbClr val="142B52"/>
                 </a:solidFill>
                 <a:latin typeface="Manrope"/>
               </a:rPr>
-              <a:t>tom próximo e acessível gerou altíssima visibilidade e elevou a média de alcance do mês.</a:t>
+              <a:t>tom próximo e acessível elevou o alcance médio.</a:t>
             </a:r>
           </a:p>
         </p:txBody>
@@ -6181,8 +6154,8 @@
         </p:nvSpPr>
         <p:spPr>
           <a:xfrm>
-            <a:off x="2926080" y="3383280"/>
-            <a:ext cx="4800600" cy="128016"/>
+            <a:off x="2926080" y="3401568"/>
+            <a:ext cx="4800600" cy="146304"/>
           </a:xfrm>
           <a:prstGeom prst="rect">
             <a:avLst/>
@@ -6197,7 +6170,7 @@
           <a:p>
             <a:pPr algn="l"/>
             <a:r>
-              <a:rPr sz="800" b="1">
+              <a:rPr sz="900" b="1">
                 <a:solidFill>
                   <a:srgbClr val="43597E"/>
                 </a:solidFill>
@@ -6217,8 +6190,8 @@
           <p:nvPr/>
         </p:nvGraphicFramePr>
         <p:xfrm>
-          <a:off x="2926080" y="3547872"/>
-          <a:ext cx="4800600" cy="603504"/>
+          <a:off x="2926080" y="3584448"/>
+          <a:ext cx="4800600" cy="713232"/>
         </p:xfrm>
         <a:graphic>
           <a:graphicData uri="http://schemas.openxmlformats.org/drawingml/2006/table">
@@ -6227,13 +6200,13 @@
                 <a:tableStyleId>{5C22544A-7EE6-4342-B048-85BDC9FD1C3A}</a:tableStyleId>
               </a:tblPr>
               <a:tblGrid>
-                <a:gridCol w="1691640"/>
+                <a:gridCol w="1737360"/>
                 <a:gridCol w="502920"/>
                 <a:gridCol w="822960"/>
                 <a:gridCol w="457200"/>
-                <a:gridCol w="1325880"/>
+                <a:gridCol w="1280160"/>
               </a:tblGrid>
-              <a:tr h="201168">
+              <a:tr h="237744">
                 <a:tc>
                   <a:txBody>
                     <a:bodyPr/>
@@ -6241,7 +6214,7 @@
                     <a:p>
                       <a:pPr algn="l"/>
                       <a:r>
-                        <a:rPr sz="750" b="1">
+                        <a:rPr sz="850" b="1">
                           <a:solidFill>
                             <a:srgbClr val="FFFFFF"/>
                           </a:solidFill>
@@ -6251,7 +6224,7 @@
                       </a:r>
                     </a:p>
                   </a:txBody>
-                  <a:tcPr marL="54864" marR="54864" marT="18288" marB="18288" anchor="ctr">
+                  <a:tcPr marL="45720" marR="45720" marT="18288" marB="18288" anchor="ctr">
                     <a:solidFill>
                       <a:srgbClr val="1971BA"/>
                     </a:solidFill>
@@ -6264,7 +6237,7 @@
                     <a:p>
                       <a:pPr algn="ctr"/>
                       <a:r>
-                        <a:rPr sz="750" b="1">
+                        <a:rPr sz="850" b="1">
                           <a:solidFill>
                             <a:srgbClr val="FFFFFF"/>
                           </a:solidFill>
@@ -6274,7 +6247,7 @@
                       </a:r>
                     </a:p>
                   </a:txBody>
-                  <a:tcPr marL="54864" marR="54864" marT="18288" marB="18288" anchor="ctr">
+                  <a:tcPr marL="45720" marR="45720" marT="18288" marB="18288" anchor="ctr">
                     <a:solidFill>
                       <a:srgbClr val="1971BA"/>
                     </a:solidFill>
@@ -6287,7 +6260,7 @@
                     <a:p>
                       <a:pPr algn="ctr"/>
                       <a:r>
-                        <a:rPr sz="750" b="1">
+                        <a:rPr sz="850" b="1">
                           <a:solidFill>
                             <a:srgbClr val="FFFFFF"/>
                           </a:solidFill>
@@ -6297,7 +6270,7 @@
                       </a:r>
                     </a:p>
                   </a:txBody>
-                  <a:tcPr marL="54864" marR="54864" marT="18288" marB="18288" anchor="ctr">
+                  <a:tcPr marL="45720" marR="45720" marT="18288" marB="18288" anchor="ctr">
                     <a:solidFill>
                       <a:srgbClr val="1971BA"/>
                     </a:solidFill>
@@ -6310,7 +6283,7 @@
                     <a:p>
                       <a:pPr algn="ctr"/>
                       <a:r>
-                        <a:rPr sz="750" b="1">
+                        <a:rPr sz="850" b="1">
                           <a:solidFill>
                             <a:srgbClr val="FFFFFF"/>
                           </a:solidFill>
@@ -6320,7 +6293,7 @@
                       </a:r>
                     </a:p>
                   </a:txBody>
-                  <a:tcPr marL="54864" marR="54864" marT="18288" marB="18288" anchor="ctr">
+                  <a:tcPr marL="45720" marR="45720" marT="18288" marB="18288" anchor="ctr">
                     <a:solidFill>
                       <a:srgbClr val="1971BA"/>
                     </a:solidFill>
@@ -6333,7 +6306,7 @@
                     <a:p>
                       <a:pPr algn="ctr"/>
                       <a:r>
-                        <a:rPr sz="750" b="1">
+                        <a:rPr sz="850" b="1">
                           <a:solidFill>
                             <a:srgbClr val="FFFFFF"/>
                           </a:solidFill>
@@ -6343,14 +6316,14 @@
                       </a:r>
                     </a:p>
                   </a:txBody>
-                  <a:tcPr marL="54864" marR="54864" marT="18288" marB="18288" anchor="ctr">
+                  <a:tcPr marL="45720" marR="45720" marT="18288" marB="18288" anchor="ctr">
                     <a:solidFill>
                       <a:srgbClr val="1971BA"/>
                     </a:solidFill>
                   </a:tcPr>
                 </a:tc>
               </a:tr>
-              <a:tr h="201168">
+              <a:tr h="237744">
                 <a:tc>
                   <a:txBody>
                     <a:bodyPr/>
@@ -6358,7 +6331,7 @@
                     <a:p>
                       <a:pPr algn="l"/>
                       <a:r>
-                        <a:rPr sz="750" b="0">
+                        <a:rPr sz="850" b="0">
                           <a:solidFill>
                             <a:srgbClr val="142B52"/>
                           </a:solidFill>
@@ -6368,7 +6341,7 @@
                       </a:r>
                     </a:p>
                   </a:txBody>
-                  <a:tcPr marL="54864" marR="54864" marT="18288" marB="18288" anchor="ctr">
+                  <a:tcPr marL="45720" marR="45720" marT="18288" marB="18288" anchor="ctr">
                     <a:solidFill>
                       <a:srgbClr val="FFFFFF"/>
                     </a:solidFill>
@@ -6381,7 +6354,7 @@
                     <a:p>
                       <a:pPr algn="ctr"/>
                       <a:r>
-                        <a:rPr sz="750" b="0">
+                        <a:rPr sz="850" b="0">
                           <a:solidFill>
                             <a:srgbClr val="142B52"/>
                           </a:solidFill>
@@ -6391,7 +6364,7 @@
                       </a:r>
                     </a:p>
                   </a:txBody>
-                  <a:tcPr marL="54864" marR="54864" marT="18288" marB="18288" anchor="ctr">
+                  <a:tcPr marL="45720" marR="45720" marT="18288" marB="18288" anchor="ctr">
                     <a:solidFill>
                       <a:srgbClr val="FFFFFF"/>
                     </a:solidFill>
@@ -6404,7 +6377,7 @@
                     <a:p>
                       <a:pPr algn="ctr"/>
                       <a:r>
-                        <a:rPr sz="750" b="1">
+                        <a:rPr sz="850" b="1">
                           <a:solidFill>
                             <a:srgbClr val="142B52"/>
                           </a:solidFill>
@@ -6414,7 +6387,7 @@
                       </a:r>
                     </a:p>
                   </a:txBody>
-                  <a:tcPr marL="54864" marR="54864" marT="18288" marB="18288" anchor="ctr">
+                  <a:tcPr marL="45720" marR="45720" marT="18288" marB="18288" anchor="ctr">
                     <a:solidFill>
                       <a:srgbClr val="FFFFFF"/>
                     </a:solidFill>
@@ -6427,7 +6400,7 @@
                     <a:p>
                       <a:pPr algn="ctr"/>
                       <a:r>
-                        <a:rPr sz="750" b="0">
+                        <a:rPr sz="850" b="0">
                           <a:solidFill>
                             <a:srgbClr val="142B52"/>
                           </a:solidFill>
@@ -6437,7 +6410,7 @@
                       </a:r>
                     </a:p>
                   </a:txBody>
-                  <a:tcPr marL="54864" marR="54864" marT="18288" marB="18288" anchor="ctr">
+                  <a:tcPr marL="45720" marR="45720" marT="18288" marB="18288" anchor="ctr">
                     <a:solidFill>
                       <a:srgbClr val="FFFFFF"/>
                     </a:solidFill>
@@ -6450,7 +6423,7 @@
                     <a:p>
                       <a:pPr algn="ctr"/>
                       <a:r>
-                        <a:rPr sz="750" b="0">
+                        <a:rPr sz="850" b="0">
                           <a:solidFill>
                             <a:srgbClr val="142B52"/>
                           </a:solidFill>
@@ -6460,14 +6433,14 @@
                       </a:r>
                     </a:p>
                   </a:txBody>
-                  <a:tcPr marL="54864" marR="54864" marT="18288" marB="18288" anchor="ctr">
+                  <a:tcPr marL="45720" marR="45720" marT="18288" marB="18288" anchor="ctr">
                     <a:solidFill>
                       <a:srgbClr val="FFFFFF"/>
                     </a:solidFill>
                   </a:tcPr>
                 </a:tc>
               </a:tr>
-              <a:tr h="201168">
+              <a:tr h="237744">
                 <a:tc>
                   <a:txBody>
                     <a:bodyPr/>
@@ -6475,7 +6448,7 @@
                     <a:p>
                       <a:pPr algn="l"/>
                       <a:r>
-                        <a:rPr sz="750" b="0">
+                        <a:rPr sz="850" b="0">
                           <a:solidFill>
                             <a:srgbClr val="142B52"/>
                           </a:solidFill>
@@ -6485,7 +6458,7 @@
                       </a:r>
                     </a:p>
                   </a:txBody>
-                  <a:tcPr marL="54864" marR="54864" marT="18288" marB="18288" anchor="ctr">
+                  <a:tcPr marL="45720" marR="45720" marT="18288" marB="18288" anchor="ctr">
                     <a:solidFill>
                       <a:srgbClr val="E6EBF3"/>
                     </a:solidFill>
@@ -6498,7 +6471,7 @@
                     <a:p>
                       <a:pPr algn="ctr"/>
                       <a:r>
-                        <a:rPr sz="750" b="0">
+                        <a:rPr sz="850" b="0">
                           <a:solidFill>
                             <a:srgbClr val="142B52"/>
                           </a:solidFill>
@@ -6508,7 +6481,7 @@
                       </a:r>
                     </a:p>
                   </a:txBody>
-                  <a:tcPr marL="54864" marR="54864" marT="18288" marB="18288" anchor="ctr">
+                  <a:tcPr marL="45720" marR="45720" marT="18288" marB="18288" anchor="ctr">
                     <a:solidFill>
                       <a:srgbClr val="E6EBF3"/>
                     </a:solidFill>
@@ -6521,7 +6494,7 @@
                     <a:p>
                       <a:pPr algn="ctr"/>
                       <a:r>
-                        <a:rPr sz="750" b="1">
+                        <a:rPr sz="850" b="1">
                           <a:solidFill>
                             <a:srgbClr val="142B52"/>
                           </a:solidFill>
@@ -6531,7 +6504,7 @@
                       </a:r>
                     </a:p>
                   </a:txBody>
-                  <a:tcPr marL="54864" marR="54864" marT="18288" marB="18288" anchor="ctr">
+                  <a:tcPr marL="45720" marR="45720" marT="18288" marB="18288" anchor="ctr">
                     <a:solidFill>
                       <a:srgbClr val="E6EBF3"/>
                     </a:solidFill>
@@ -6544,7 +6517,7 @@
                     <a:p>
                       <a:pPr algn="ctr"/>
                       <a:r>
-                        <a:rPr sz="750" b="0">
+                        <a:rPr sz="850" b="0">
                           <a:solidFill>
                             <a:srgbClr val="142B52"/>
                           </a:solidFill>
@@ -6554,7 +6527,7 @@
                       </a:r>
                     </a:p>
                   </a:txBody>
-                  <a:tcPr marL="54864" marR="54864" marT="18288" marB="18288" anchor="ctr">
+                  <a:tcPr marL="45720" marR="45720" marT="18288" marB="18288" anchor="ctr">
                     <a:solidFill>
                       <a:srgbClr val="E6EBF3"/>
                     </a:solidFill>
@@ -6567,7 +6540,7 @@
                     <a:p>
                       <a:pPr algn="ctr"/>
                       <a:r>
-                        <a:rPr sz="750" b="0">
+                        <a:rPr sz="850" b="0">
                           <a:solidFill>
                             <a:srgbClr val="142B52"/>
                           </a:solidFill>
@@ -6577,7 +6550,7 @@
                       </a:r>
                     </a:p>
                   </a:txBody>
-                  <a:tcPr marL="54864" marR="54864" marT="18288" marB="18288" anchor="ctr">
+                  <a:tcPr marL="45720" marR="45720" marT="18288" marB="18288" anchor="ctr">
                     <a:solidFill>
                       <a:srgbClr val="E6EBF3"/>
                     </a:solidFill>
@@ -6604,8 +6577,8 @@
         </p:blipFill>
         <p:spPr>
           <a:xfrm>
-            <a:off x="2926080" y="4251960"/>
-            <a:ext cx="758692" cy="1188720"/>
+            <a:off x="2926080" y="4389120"/>
+            <a:ext cx="671151" cy="1051560"/>
           </a:xfrm>
           <a:prstGeom prst="rect">
             <a:avLst/>
@@ -6628,8 +6601,8 @@
         </p:blipFill>
         <p:spPr>
           <a:xfrm>
-            <a:off x="3749040" y="4251960"/>
-            <a:ext cx="759800" cy="1188720"/>
+            <a:off x="3749040" y="4389120"/>
+            <a:ext cx="672131" cy="1051560"/>
           </a:xfrm>
           <a:prstGeom prst="rect">
             <a:avLst/>
@@ -6652,8 +6625,8 @@
         </p:blipFill>
         <p:spPr>
           <a:xfrm>
-            <a:off x="4572000" y="4251960"/>
-            <a:ext cx="719797" cy="1188720"/>
+            <a:off x="4572000" y="4389120"/>
+            <a:ext cx="636743" cy="1051560"/>
           </a:xfrm>
           <a:prstGeom prst="rect">
             <a:avLst/>
@@ -6676,8 +6649,8 @@
         </p:blipFill>
         <p:spPr>
           <a:xfrm>
-            <a:off x="5394960" y="4251960"/>
-            <a:ext cx="713232" cy="1188720"/>
+            <a:off x="5394960" y="4389120"/>
+            <a:ext cx="630936" cy="1051560"/>
           </a:xfrm>
           <a:prstGeom prst="rect">
             <a:avLst/>
@@ -6692,8 +6665,8 @@
         </p:nvSpPr>
         <p:spPr>
           <a:xfrm>
-            <a:off x="6446520" y="4251960"/>
-            <a:ext cx="1188720" cy="118872"/>
+            <a:off x="6446520" y="4389120"/>
+            <a:ext cx="1280160" cy="137160"/>
           </a:xfrm>
           <a:prstGeom prst="rect">
             <a:avLst/>
@@ -6708,7 +6681,7 @@
           <a:p>
             <a:pPr algn="l"/>
             <a:r>
-              <a:rPr sz="650" b="1">
+              <a:rPr sz="800" b="1">
                 <a:solidFill>
                   <a:srgbClr val="6B7894"/>
                 </a:solidFill>
@@ -6735,47 +6708,23 @@
         </p:blipFill>
         <p:spPr>
           <a:xfrm>
-            <a:off x="6446520" y="4407408"/>
-            <a:ext cx="1188720" cy="388335"/>
+            <a:off x="6446520" y="4572000"/>
+            <a:ext cx="1280160" cy="418207"/>
           </a:xfrm>
           <a:prstGeom prst="rect">
             <a:avLst/>
           </a:prstGeom>
         </p:spPr>
       </p:pic>
-      <p:pic>
-        <p:nvPicPr>
-          <p:cNvPr id="1187" name="Banner movimento" descr="image.png"/>
-          <p:cNvPicPr>
-            <a:picLocks noChangeAspect="1"/>
-          </p:cNvPicPr>
-          <p:nvPr/>
-        </p:nvPicPr>
-        <p:blipFill>
-          <a:blip r:embed="rId11"/>
-          <a:stretch>
-            <a:fillRect/>
-          </a:stretch>
-        </p:blipFill>
-        <p:spPr>
-          <a:xfrm>
-            <a:off x="6446520" y="4800600"/>
-            <a:ext cx="1188720" cy="241622"/>
-          </a:xfrm>
-          <a:prstGeom prst="rect">
-            <a:avLst/>
-          </a:prstGeom>
-        </p:spPr>
-      </p:pic>
-      <p:sp>
-        <p:nvSpPr>
-          <p:cNvPr id="1188" name="Seção DIGITAL  |  REPERCUSSÃO ORGÂNICA"/>
+      <p:sp>
+        <p:nvSpPr>
+          <p:cNvPr id="1187" name="Seção DIGITAL  |  REPERCUSSÃO ORGÂNICA"/>
           <p:cNvSpPr/>
           <p:nvPr/>
         </p:nvSpPr>
         <p:spPr>
           <a:xfrm>
-            <a:off x="7863840" y="1892807"/>
+            <a:off x="7863840" y="1920240"/>
             <a:ext cx="4023360" cy="237744"/>
           </a:xfrm>
           <a:prstGeom prst="roundRect">
@@ -6815,13 +6764,13 @@
       </p:sp>
       <p:sp>
         <p:nvSpPr>
-          <p:cNvPr id="1189" name="Seção texto DIGITAL  |  REPERCUSSÃO ORGÂNICA"/>
+          <p:cNvPr id="1188" name="Seção texto DIGITAL  |  REPERCUSSÃO ORGÂNICA"/>
           <p:cNvSpPr txBox="1"/>
           <p:nvPr/>
         </p:nvSpPr>
         <p:spPr>
           <a:xfrm>
-            <a:off x="7973567" y="1892807"/>
+            <a:off x="7973567" y="1920240"/>
             <a:ext cx="3840480" cy="237744"/>
           </a:xfrm>
           <a:prstGeom prst="rect">
@@ -6850,14 +6799,14 @@
       </p:sp>
       <p:sp>
         <p:nvSpPr>
-          <p:cNvPr id="1190" name="Card orgânico"/>
+          <p:cNvPr id="1189" name="Card orgânico"/>
           <p:cNvSpPr/>
           <p:nvPr/>
         </p:nvSpPr>
         <p:spPr>
           <a:xfrm>
-            <a:off x="7863840" y="2212848"/>
-            <a:ext cx="4023360" cy="2130552"/>
+            <a:off x="7863840" y="2240280"/>
+            <a:ext cx="4023360" cy="2103120"/>
           </a:xfrm>
           <a:prstGeom prst="roundRect">
             <a:avLst>
@@ -6898,14 +6847,14 @@
       </p:sp>
       <p:sp>
         <p:nvSpPr>
-          <p:cNvPr id="1191" name="Orgânico alcance"/>
+          <p:cNvPr id="1190" name="Orgânico alcance"/>
           <p:cNvSpPr txBox="1"/>
           <p:nvPr/>
         </p:nvSpPr>
         <p:spPr>
           <a:xfrm>
-            <a:off x="8001000" y="2249424"/>
-            <a:ext cx="1737360" cy="457200"/>
+            <a:off x="8001000" y="2267712"/>
+            <a:ext cx="2194560" cy="502920"/>
           </a:xfrm>
           <a:prstGeom prst="rect">
             <a:avLst/>
@@ -6920,7 +6869,7 @@
           <a:p>
             <a:pPr algn="l"/>
             <a:r>
-              <a:rPr sz="2800" b="1">
+              <a:rPr sz="3000" b="1">
                 <a:solidFill>
                   <a:srgbClr val="1971BA"/>
                 </a:solidFill>
@@ -6933,14 +6882,14 @@
       </p:sp>
       <p:sp>
         <p:nvSpPr>
-          <p:cNvPr id="1192" name="Rótulo orgânico"/>
+          <p:cNvPr id="1191" name="Rótulo orgânico"/>
           <p:cNvSpPr txBox="1"/>
           <p:nvPr/>
         </p:nvSpPr>
         <p:spPr>
           <a:xfrm>
-            <a:off x="8001000" y="2724912"/>
-            <a:ext cx="1828800" cy="274320"/>
+            <a:off x="8001000" y="2770632"/>
+            <a:ext cx="2011680" cy="310896"/>
           </a:xfrm>
           <a:prstGeom prst="rect">
             <a:avLst/>
@@ -6955,55 +6904,44 @@
           <a:p>
             <a:pPr algn="l"/>
             <a:r>
-              <a:rPr sz="800" b="0">
+              <a:rPr sz="1000" b="0">
                 <a:solidFill>
                   <a:srgbClr val="6B7894"/>
                 </a:solidFill>
                 <a:latin typeface="Manrope"/>
               </a:rPr>
-              <a:t>de alcance potencial nas redes públicas</a:t>
-            </a:r>
-          </a:p>
-        </p:txBody>
-      </p:sp>
-      <p:sp>
-        <p:nvSpPr>
-          <p:cNvPr id="1193" name="Título repercussão"/>
-          <p:cNvSpPr txBox="1"/>
-          <p:nvPr/>
-        </p:nvSpPr>
-        <p:spPr>
-          <a:xfrm>
-            <a:off x="8001000" y="3017520"/>
-            <a:ext cx="2103120" cy="128016"/>
-          </a:xfrm>
-          <a:prstGeom prst="rect">
-            <a:avLst/>
-          </a:prstGeom>
-          <a:noFill/>
-        </p:spPr>
-        <p:txBody>
-          <a:bodyPr wrap="square" anchor="t" lIns="0" rIns="0" tIns="0" bIns="0">
-            <a:spAutoFit/>
-          </a:bodyPr>
-          <a:lstStyle/>
-          <a:p>
-            <a:pPr algn="l"/>
-            <a:r>
-              <a:rPr sz="750" b="1">
-                <a:solidFill>
-                  <a:srgbClr val="1971BA"/>
-                </a:solidFill>
-                <a:latin typeface="Manrope"/>
-              </a:rPr>
-              <a:t>O CUIDADO ECOOU EM MAR ABERTO</a:t>
+              <a:t>alcance potencial nas redes públicas</a:t>
             </a:r>
           </a:p>
         </p:txBody>
       </p:sp>
       <p:pic>
         <p:nvPicPr>
-          <p:cNvPr id="1194" name="Repercussão foto 1" descr="image.png"/>
+          <p:cNvPr id="1192" name="Repercussão foto 1" descr="image.png"/>
+          <p:cNvPicPr>
+            <a:picLocks noChangeAspect="1"/>
+          </p:cNvPicPr>
+          <p:nvPr/>
+        </p:nvPicPr>
+        <p:blipFill>
+          <a:blip r:embed="rId11"/>
+          <a:stretch>
+            <a:fillRect/>
+          </a:stretch>
+        </p:blipFill>
+        <p:spPr>
+          <a:xfrm>
+            <a:off x="10561320" y="2304288"/>
+            <a:ext cx="690118" cy="868680"/>
+          </a:xfrm>
+          <a:prstGeom prst="rect">
+            <a:avLst/>
+          </a:prstGeom>
+        </p:spPr>
+      </p:pic>
+      <p:pic>
+        <p:nvPicPr>
+          <p:cNvPr id="1193" name="Repercussão foto 2" descr="image.png"/>
           <p:cNvPicPr>
             <a:picLocks noChangeAspect="1"/>
           </p:cNvPicPr>
@@ -7017,48 +6955,24 @@
         </p:blipFill>
         <p:spPr>
           <a:xfrm>
-            <a:off x="10561320" y="2286000"/>
-            <a:ext cx="690118" cy="868680"/>
+            <a:off x="11292840" y="2350008"/>
+            <a:ext cx="543143" cy="868680"/>
           </a:xfrm>
           <a:prstGeom prst="rect">
             <a:avLst/>
           </a:prstGeom>
         </p:spPr>
       </p:pic>
-      <p:pic>
-        <p:nvPicPr>
-          <p:cNvPr id="1195" name="Repercussão foto 2" descr="image.png"/>
-          <p:cNvPicPr>
-            <a:picLocks noChangeAspect="1"/>
-          </p:cNvPicPr>
-          <p:nvPr/>
-        </p:nvPicPr>
-        <p:blipFill>
-          <a:blip r:embed="rId13"/>
-          <a:stretch>
-            <a:fillRect/>
-          </a:stretch>
-        </p:blipFill>
-        <p:spPr>
-          <a:xfrm>
-            <a:off x="11292840" y="2331720"/>
-            <a:ext cx="543143" cy="868680"/>
-          </a:xfrm>
-          <a:prstGeom prst="rect">
-            <a:avLst/>
-          </a:prstGeom>
-        </p:spPr>
-      </p:pic>
-      <p:sp>
-        <p:nvSpPr>
-          <p:cNvPr id="1196" name="Texto repercussão"/>
+      <p:sp>
+        <p:nvSpPr>
+          <p:cNvPr id="1194" name="Título repercussão"/>
           <p:cNvSpPr txBox="1"/>
           <p:nvPr/>
         </p:nvSpPr>
         <p:spPr>
           <a:xfrm>
-            <a:off x="8001000" y="3200400"/>
-            <a:ext cx="3749040" cy="457200"/>
+            <a:off x="8001000" y="3218688"/>
+            <a:ext cx="3749040" cy="128016"/>
           </a:xfrm>
           <a:prstGeom prst="rect">
             <a:avLst/>
@@ -7073,35 +6987,70 @@
           <a:p>
             <a:pPr algn="l"/>
             <a:r>
-              <a:rPr sz="800" b="0">
-                <a:solidFill>
-                  <a:srgbClr val="142B52"/>
+              <a:rPr sz="850" b="1">
+                <a:solidFill>
+                  <a:srgbClr val="1971BA"/>
                 </a:solidFill>
                 <a:latin typeface="Manrope"/>
               </a:rPr>
-              <a:t>Imprensa e comunidades locais compartilharam imagens e comentários sobre o simulado da VLI e os dados de segurança, </a:t>
-            </a:r>
-            <a:r>
-              <a:rPr sz="800" b="1">
+              <a:t>O CUIDADO ECOOU EM MAR ABERTO</a:t>
+            </a:r>
+          </a:p>
+        </p:txBody>
+      </p:sp>
+      <p:sp>
+        <p:nvSpPr>
+          <p:cNvPr id="1195" name="Texto repercussão"/>
+          <p:cNvSpPr txBox="1"/>
+          <p:nvPr/>
+        </p:nvSpPr>
+        <p:spPr>
+          <a:xfrm>
+            <a:off x="8001000" y="3383280"/>
+            <a:ext cx="3749040" cy="365760"/>
+          </a:xfrm>
+          <a:prstGeom prst="rect">
+            <a:avLst/>
+          </a:prstGeom>
+          <a:noFill/>
+        </p:spPr>
+        <p:txBody>
+          <a:bodyPr wrap="square" anchor="t" lIns="0" rIns="0" tIns="0" bIns="0">
+            <a:spAutoFit/>
+          </a:bodyPr>
+          <a:lstStyle/>
+          <a:p>
+            <a:pPr algn="l"/>
+            <a:r>
+              <a:rPr sz="1000" b="0">
                 <a:solidFill>
                   <a:srgbClr val="142B52"/>
                 </a:solidFill>
                 <a:latin typeface="Manrope"/>
               </a:rPr>
-              <a:t>fortalecendo diretamente o IR da VLI em setembro.</a:t>
-            </a:r>
-          </a:p>
-        </p:txBody>
-      </p:sp>
-      <p:sp>
-        <p:nvSpPr>
-          <p:cNvPr id="1197" name="Divisor orgânico"/>
+              <a:t>Imprensa e comunidades locais compartilharam o simulado, </a:t>
+            </a:r>
+            <a:r>
+              <a:rPr sz="1000" b="1">
+                <a:solidFill>
+                  <a:srgbClr val="142B52"/>
+                </a:solidFill>
+                <a:latin typeface="Manrope"/>
+              </a:rPr>
+              <a:t>fortalecendo o IR da VLI.</a:t>
+            </a:r>
+          </a:p>
+        </p:txBody>
+      </p:sp>
+      <p:sp>
+        <p:nvSpPr>
+          <p:cNvPr id="1196" name="Divisor orgânico"/>
           <p:cNvSpPr/>
           <p:nvPr/>
         </p:nvSpPr>
         <p:spPr>
           <a:xfrm>
-            <a:off x="8001000" y="3703320"/>
+            <a:off x="8001000" y="3794760"/>
             <a:ext cx="3749040" cy="0"/>
           </a:xfrm>
           <a:prstGeom prst="rect">
@@ -7139,14 +7088,14 @@
       </p:sp>
       <p:sp>
         <p:nvSpPr>
-          <p:cNvPr id="1198" name="Collab KPI"/>
+          <p:cNvPr id="1197" name="Collab KPI"/>
           <p:cNvSpPr txBox="1"/>
           <p:nvPr/>
         </p:nvSpPr>
         <p:spPr>
           <a:xfrm>
-            <a:off x="8001000" y="3749039"/>
-            <a:ext cx="1005840" cy="365760"/>
+            <a:off x="8001000" y="3858768"/>
+            <a:ext cx="1188720" cy="384048"/>
           </a:xfrm>
           <a:prstGeom prst="rect">
             <a:avLst/>
@@ -7161,7 +7110,7 @@
           <a:p>
             <a:pPr algn="l"/>
             <a:r>
-              <a:rPr sz="1900" b="1">
+              <a:rPr sz="2200" b="1">
                 <a:solidFill>
                   <a:srgbClr val="1971BA"/>
                 </a:solidFill>
@@ -7174,14 +7123,14 @@
       </p:sp>
       <p:sp>
         <p:nvSpPr>
-          <p:cNvPr id="1199" name="Collab texto"/>
+          <p:cNvPr id="1198" name="Collab texto"/>
           <p:cNvSpPr txBox="1"/>
           <p:nvPr/>
         </p:nvSpPr>
         <p:spPr>
           <a:xfrm>
-            <a:off x="9052560" y="3749039"/>
-            <a:ext cx="1371600" cy="548640"/>
+            <a:off x="9235440" y="3858768"/>
+            <a:ext cx="1280160" cy="457200"/>
           </a:xfrm>
           <a:prstGeom prst="rect">
             <a:avLst/>
@@ -7196,20 +7145,44 @@
           <a:p>
             <a:pPr algn="l"/>
             <a:r>
-              <a:rPr sz="750" b="0">
+              <a:rPr sz="950" b="0">
                 <a:solidFill>
                   <a:srgbClr val="43597E"/>
                 </a:solidFill>
                 <a:latin typeface="Manrope"/>
               </a:rPr>
-              <a:t>views orgânicas nos posts Collab: VLI, ANTF, Rumo, MRS, Brado e FIPS</a:t>
+              <a:t>views orgânicas nos posts Collab</a:t>
             </a:r>
           </a:p>
         </p:txBody>
       </p:sp>
       <p:pic>
         <p:nvPicPr>
-          <p:cNvPr id="1200" name="Collab 1" descr="image.png"/>
+          <p:cNvPr id="1199" name="Collab 1" descr="image.png"/>
+          <p:cNvPicPr>
+            <a:picLocks noChangeAspect="1"/>
+          </p:cNvPicPr>
+          <p:nvPr/>
+        </p:nvPicPr>
+        <p:blipFill>
+          <a:blip r:embed="rId13"/>
+          <a:stretch>
+            <a:fillRect/>
+          </a:stretch>
+        </p:blipFill>
+        <p:spPr>
+          <a:xfrm>
+            <a:off x="10607040" y="3858768"/>
+            <a:ext cx="307683" cy="411480"/>
+          </a:xfrm>
+          <a:prstGeom prst="rect">
+            <a:avLst/>
+          </a:prstGeom>
+        </p:spPr>
+      </p:pic>
+      <p:pic>
+        <p:nvPicPr>
+          <p:cNvPr id="1200" name="Collab 2" descr="image.png"/>
           <p:cNvPicPr>
             <a:picLocks noChangeAspect="1"/>
           </p:cNvPicPr>
@@ -7223,47 +7196,23 @@
         </p:blipFill>
         <p:spPr>
           <a:xfrm>
-            <a:off x="10561320" y="3749039"/>
-            <a:ext cx="376057" cy="502920"/>
+            <a:off x="11064240" y="3858768"/>
+            <a:ext cx="305212" cy="411480"/>
           </a:xfrm>
           <a:prstGeom prst="rect">
             <a:avLst/>
           </a:prstGeom>
         </p:spPr>
       </p:pic>
-      <p:pic>
-        <p:nvPicPr>
-          <p:cNvPr id="1201" name="Collab 2" descr="image.png"/>
-          <p:cNvPicPr>
-            <a:picLocks noChangeAspect="1"/>
-          </p:cNvPicPr>
-          <p:nvPr/>
-        </p:nvPicPr>
-        <p:blipFill>
-          <a:blip r:embed="rId15"/>
-          <a:stretch>
-            <a:fillRect/>
-          </a:stretch>
-        </p:blipFill>
-        <p:spPr>
-          <a:xfrm>
-            <a:off x="11064240" y="3749039"/>
-            <a:ext cx="373037" cy="502920"/>
-          </a:xfrm>
-          <a:prstGeom prst="rect">
-            <a:avLst/>
-          </a:prstGeom>
-        </p:spPr>
-      </p:pic>
-      <p:sp>
-        <p:nvSpPr>
-          <p:cNvPr id="1202" name="Seção IMPRENSA"/>
+      <p:sp>
+        <p:nvSpPr>
+          <p:cNvPr id="1201" name="Seção IMPRENSA"/>
           <p:cNvSpPr/>
           <p:nvPr/>
         </p:nvSpPr>
         <p:spPr>
           <a:xfrm>
-            <a:off x="7863840" y="4434840"/>
+            <a:off x="7863840" y="4462272"/>
             <a:ext cx="4023360" cy="237744"/>
           </a:xfrm>
           <a:prstGeom prst="roundRect">
@@ -7303,13 +7252,13 @@
       </p:sp>
       <p:sp>
         <p:nvSpPr>
-          <p:cNvPr id="1203" name="Seção texto IMPRENSA"/>
+          <p:cNvPr id="1202" name="Seção texto IMPRENSA"/>
           <p:cNvSpPr txBox="1"/>
           <p:nvPr/>
         </p:nvSpPr>
         <p:spPr>
           <a:xfrm>
-            <a:off x="7973567" y="4434840"/>
+            <a:off x="7973567" y="4462272"/>
             <a:ext cx="3840480" cy="237744"/>
           </a:xfrm>
           <a:prstGeom prst="rect">
@@ -7338,14 +7287,14 @@
       </p:sp>
       <p:sp>
         <p:nvSpPr>
-          <p:cNvPr id="1204" name="Card imprensa"/>
+          <p:cNvPr id="1203" name="Card imprensa"/>
           <p:cNvSpPr/>
           <p:nvPr/>
         </p:nvSpPr>
         <p:spPr>
           <a:xfrm>
-            <a:off x="7863840" y="4754880"/>
-            <a:ext cx="4023360" cy="685800"/>
+            <a:off x="7863840" y="4782312"/>
+            <a:ext cx="4023360" cy="658368"/>
           </a:xfrm>
           <a:prstGeom prst="roundRect">
             <a:avLst>
@@ -7386,7 +7335,7 @@
       </p:sp>
       <p:sp>
         <p:nvSpPr>
-          <p:cNvPr id="1205" name="Imprensa alcance"/>
+          <p:cNvPr id="1204" name="Imprensa alcance"/>
           <p:cNvSpPr txBox="1"/>
           <p:nvPr/>
         </p:nvSpPr>
@@ -7408,7 +7357,7 @@
           <a:p>
             <a:pPr algn="l"/>
             <a:r>
-              <a:rPr sz="2600" b="1">
+              <a:rPr sz="2800" b="1">
                 <a:solidFill>
                   <a:srgbClr val="F37919"/>
                 </a:solidFill>
@@ -7421,14 +7370,14 @@
       </p:sp>
       <p:sp>
         <p:nvSpPr>
-          <p:cNvPr id="1206" name="Rótulo alcance imprensa"/>
+          <p:cNvPr id="1205" name="Rótulo alcance imprensa"/>
           <p:cNvSpPr txBox="1"/>
           <p:nvPr/>
         </p:nvSpPr>
         <p:spPr>
           <a:xfrm>
             <a:off x="8001000" y="5230368"/>
-            <a:ext cx="1463040" cy="137160"/>
+            <a:ext cx="1463040" cy="155448"/>
           </a:xfrm>
           <a:prstGeom prst="rect">
             <a:avLst/>
@@ -7443,7 +7392,7 @@
           <a:p>
             <a:pPr algn="l"/>
             <a:r>
-              <a:rPr sz="800" b="0">
+              <a:rPr sz="950" b="0">
                 <a:solidFill>
                   <a:srgbClr val="6B7894"/>
                 </a:solidFill>
@@ -7456,13 +7405,13 @@
       </p:sp>
       <p:sp>
         <p:nvSpPr>
-          <p:cNvPr id="1207" name="Imprensa inserções"/>
+          <p:cNvPr id="1206" name="Imprensa inserções"/>
           <p:cNvSpPr txBox="1"/>
           <p:nvPr/>
         </p:nvSpPr>
         <p:spPr>
           <a:xfrm>
-            <a:off x="9601200" y="4800600"/>
+            <a:off x="9509760" y="4800600"/>
             <a:ext cx="914400" cy="365760"/>
           </a:xfrm>
           <a:prstGeom prst="rect">
@@ -7478,7 +7427,7 @@
           <a:p>
             <a:pPr algn="l"/>
             <a:r>
-              <a:rPr sz="2200" b="1">
+              <a:rPr sz="2400" b="1">
                 <a:solidFill>
                   <a:srgbClr val="142B52"/>
                 </a:solidFill>
@@ -7491,14 +7440,14 @@
       </p:sp>
       <p:sp>
         <p:nvSpPr>
-          <p:cNvPr id="1208" name="Rótulo inserções"/>
+          <p:cNvPr id="1207" name="Rótulo inserções"/>
           <p:cNvSpPr txBox="1"/>
           <p:nvPr/>
         </p:nvSpPr>
         <p:spPr>
           <a:xfrm>
-            <a:off x="9601200" y="5138928"/>
-            <a:ext cx="914400" cy="137160"/>
+            <a:off x="9509760" y="5193792"/>
+            <a:ext cx="914400" cy="155448"/>
           </a:xfrm>
           <a:prstGeom prst="rect">
             <a:avLst/>
@@ -7513,7 +7462,7 @@
           <a:p>
             <a:pPr algn="l"/>
             <a:r>
-              <a:rPr sz="800" b="0">
+              <a:rPr sz="950" b="0">
                 <a:solidFill>
                   <a:srgbClr val="6B7894"/>
                 </a:solidFill>
@@ -7526,14 +7475,14 @@
       </p:sp>
       <p:sp>
         <p:nvSpPr>
-          <p:cNvPr id="1209" name="Selo recorde"/>
+          <p:cNvPr id="1208" name="Selo recorde"/>
           <p:cNvSpPr/>
           <p:nvPr/>
         </p:nvSpPr>
         <p:spPr>
           <a:xfrm>
-            <a:off x="10561320" y="4919472"/>
-            <a:ext cx="1188720" cy="329184"/>
+            <a:off x="10469880" y="4910328"/>
+            <a:ext cx="1280160" cy="384048"/>
           </a:xfrm>
           <a:prstGeom prst="roundRect">
             <a:avLst>
@@ -7572,14 +7521,14 @@
       </p:sp>
       <p:sp>
         <p:nvSpPr>
-          <p:cNvPr id="1210" name="Selo texto"/>
+          <p:cNvPr id="1209" name="Selo texto"/>
           <p:cNvSpPr txBox="1"/>
           <p:nvPr/>
         </p:nvSpPr>
         <p:spPr>
           <a:xfrm>
-            <a:off x="10561320" y="4919472"/>
-            <a:ext cx="1188720" cy="329184"/>
+            <a:off x="10469880" y="4910328"/>
+            <a:ext cx="1280160" cy="384048"/>
           </a:xfrm>
           <a:prstGeom prst="rect">
             <a:avLst/>
@@ -7594,7 +7543,7 @@
           <a:p>
             <a:pPr algn="ctr"/>
             <a:r>
-              <a:rPr sz="700" b="1">
+              <a:rPr sz="800" b="1">
                 <a:solidFill>
                   <a:srgbClr val="FFFFFF"/>
                 </a:solidFill>
@@ -7607,13 +7556,13 @@
       </p:sp>
       <p:sp>
         <p:nvSpPr>
-          <p:cNvPr id="1211" name="Seção COMUNICAÇÃO INTERNA  |  Jornada integrada: E-mail MKT + ZAP + Intranet"/>
+          <p:cNvPr id="1210" name="Seção COMUNICAÇÃO INTERNA  |  Jornada integrada: E-mail MKT + ZAP + Intranet"/>
           <p:cNvSpPr/>
           <p:nvPr/>
         </p:nvSpPr>
         <p:spPr>
           <a:xfrm>
-            <a:off x="301752" y="5559552"/>
+            <a:off x="301752" y="5577840"/>
             <a:ext cx="11585448" cy="237744"/>
           </a:xfrm>
           <a:prstGeom prst="roundRect">
@@ -7653,13 +7602,13 @@
       </p:sp>
       <p:sp>
         <p:nvSpPr>
-          <p:cNvPr id="1212" name="Seção texto COMUNICAÇÃO INTERNA  |  Jornada integrada: E-mail MKT + ZAP + Intranet"/>
+          <p:cNvPr id="1211" name="Seção texto COMUNICAÇÃO INTERNA  |  Jornada integrada: E-mail MKT + ZAP + Intranet"/>
           <p:cNvSpPr txBox="1"/>
           <p:nvPr/>
         </p:nvSpPr>
         <p:spPr>
           <a:xfrm>
-            <a:off x="411480" y="5559552"/>
+            <a:off x="411480" y="5577840"/>
             <a:ext cx="11402568" cy="237744"/>
           </a:xfrm>
           <a:prstGeom prst="rect">
@@ -7688,13 +7637,13 @@
       </p:sp>
       <p:sp>
         <p:nvSpPr>
-          <p:cNvPr id="1213" name="Canal E-MAIL MKT"/>
+          <p:cNvPr id="1212" name="Canal E-MAIL MKT"/>
           <p:cNvSpPr/>
           <p:nvPr/>
         </p:nvSpPr>
         <p:spPr>
           <a:xfrm>
-            <a:off x="301752" y="5852160"/>
+            <a:off x="301752" y="5870448"/>
             <a:ext cx="2258568" cy="822960"/>
           </a:xfrm>
           <a:prstGeom prst="roundRect">
@@ -7736,14 +7685,14 @@
       </p:sp>
       <p:sp>
         <p:nvSpPr>
-          <p:cNvPr id="1214" name="Canal rótulo E-MAIL MKT"/>
+          <p:cNvPr id="1213" name="Canal rótulo E-MAIL MKT"/>
           <p:cNvSpPr txBox="1"/>
           <p:nvPr/>
         </p:nvSpPr>
         <p:spPr>
           <a:xfrm>
-            <a:off x="393192" y="5897880"/>
-            <a:ext cx="2103120" cy="128016"/>
+            <a:off x="393192" y="5916168"/>
+            <a:ext cx="2103120" cy="137160"/>
           </a:xfrm>
           <a:prstGeom prst="rect">
             <a:avLst/>
@@ -7758,7 +7707,7 @@
           <a:p>
             <a:pPr algn="l"/>
             <a:r>
-              <a:rPr sz="750" b="1">
+              <a:rPr sz="850" b="1">
                 <a:solidFill>
                   <a:srgbClr val="43597E"/>
                 </a:solidFill>
@@ -7771,14 +7720,14 @@
       </p:sp>
       <p:sp>
         <p:nvSpPr>
-          <p:cNvPr id="1215" name="Canal KPI E-MAIL MKT"/>
+          <p:cNvPr id="1214" name="Canal KPI E-MAIL MKT"/>
           <p:cNvSpPr txBox="1"/>
           <p:nvPr/>
         </p:nvSpPr>
         <p:spPr>
           <a:xfrm>
-            <a:off x="393192" y="6035040"/>
-            <a:ext cx="2103120" cy="274320"/>
+            <a:off x="393192" y="6053327"/>
+            <a:ext cx="2103120" cy="292608"/>
           </a:xfrm>
           <a:prstGeom prst="rect">
             <a:avLst/>
@@ -7793,7 +7742,7 @@
           <a:p>
             <a:pPr algn="l"/>
             <a:r>
-              <a:rPr sz="1700" b="1">
+              <a:rPr sz="1800" b="1">
                 <a:solidFill>
                   <a:srgbClr val="142B52"/>
                 </a:solidFill>
@@ -7802,7 +7751,7 @@
               <a:t>16,7%</a:t>
             </a:r>
             <a:r>
-              <a:rPr sz="850" b="0">
+              <a:rPr sz="950" b="0">
                 <a:solidFill>
                   <a:srgbClr val="6B7894"/>
                 </a:solidFill>
@@ -7815,14 +7764,14 @@
       </p:sp>
       <p:sp>
         <p:nvSpPr>
-          <p:cNvPr id="1216" name="Canal detalhe E-MAIL MKT"/>
+          <p:cNvPr id="1215" name="Canal detalhe E-MAIL MKT"/>
           <p:cNvSpPr txBox="1"/>
           <p:nvPr/>
         </p:nvSpPr>
         <p:spPr>
           <a:xfrm>
-            <a:off x="393192" y="6345936"/>
-            <a:ext cx="2103120" cy="310896"/>
+            <a:off x="393192" y="6382512"/>
+            <a:ext cx="2103120" cy="292608"/>
           </a:xfrm>
           <a:prstGeom prst="rect">
             <a:avLst/>
@@ -7837,26 +7786,26 @@
           <a:p>
             <a:pPr algn="l"/>
             <a:r>
-              <a:rPr sz="750" b="0">
+              <a:rPr sz="900" b="0">
                 <a:solidFill>
                   <a:srgbClr val="6B7894"/>
                 </a:solidFill>
                 <a:latin typeface="Manrope"/>
               </a:rPr>
-              <a:t>4.794 enviados · 4.345 entregues · 727 aberturas únicas · 50 cliques</a:t>
-            </a:r>
-          </a:p>
-        </p:txBody>
-      </p:sp>
-      <p:sp>
-        <p:nvSpPr>
-          <p:cNvPr id="1217" name="Canal ZAP VLI"/>
+              <a:t>4.794 enviados · 50 cliques</a:t>
+            </a:r>
+          </a:p>
+        </p:txBody>
+      </p:sp>
+      <p:sp>
+        <p:nvSpPr>
+          <p:cNvPr id="1216" name="Canal ZAP VLI"/>
           <p:cNvSpPr/>
           <p:nvPr/>
         </p:nvSpPr>
         <p:spPr>
           <a:xfrm>
-            <a:off x="2633472" y="5852160"/>
+            <a:off x="2633472" y="5870448"/>
             <a:ext cx="2258568" cy="822960"/>
           </a:xfrm>
           <a:prstGeom prst="roundRect">
@@ -7898,14 +7847,14 @@
       </p:sp>
       <p:sp>
         <p:nvSpPr>
-          <p:cNvPr id="1218" name="Canal rótulo ZAP VLI"/>
+          <p:cNvPr id="1217" name="Canal rótulo ZAP VLI"/>
           <p:cNvSpPr txBox="1"/>
           <p:nvPr/>
         </p:nvSpPr>
         <p:spPr>
           <a:xfrm>
-            <a:off x="2724912" y="5897880"/>
-            <a:ext cx="2103120" cy="128016"/>
+            <a:off x="2724912" y="5916168"/>
+            <a:ext cx="2103120" cy="137160"/>
           </a:xfrm>
           <a:prstGeom prst="rect">
             <a:avLst/>
@@ -7920,7 +7869,7 @@
           <a:p>
             <a:pPr algn="l"/>
             <a:r>
-              <a:rPr sz="750" b="1">
+              <a:rPr sz="850" b="1">
                 <a:solidFill>
                   <a:srgbClr val="43597E"/>
                 </a:solidFill>
@@ -7933,14 +7882,14 @@
       </p:sp>
       <p:sp>
         <p:nvSpPr>
-          <p:cNvPr id="1219" name="Canal KPI ZAP VLI"/>
+          <p:cNvPr id="1218" name="Canal KPI ZAP VLI"/>
           <p:cNvSpPr txBox="1"/>
           <p:nvPr/>
         </p:nvSpPr>
         <p:spPr>
           <a:xfrm>
-            <a:off x="2724912" y="6035040"/>
-            <a:ext cx="2103120" cy="274320"/>
+            <a:off x="2724912" y="6053327"/>
+            <a:ext cx="2103120" cy="292608"/>
           </a:xfrm>
           <a:prstGeom prst="rect">
             <a:avLst/>
@@ -7955,7 +7904,7 @@
           <a:p>
             <a:pPr algn="l"/>
             <a:r>
-              <a:rPr sz="1700" b="1">
+              <a:rPr sz="1800" b="1">
                 <a:solidFill>
                   <a:srgbClr val="142B52"/>
                 </a:solidFill>
@@ -7964,7 +7913,7 @@
               <a:t>56,5%</a:t>
             </a:r>
             <a:r>
-              <a:rPr sz="850" b="0">
+              <a:rPr sz="950" b="0">
                 <a:solidFill>
                   <a:srgbClr val="6B7894"/>
                 </a:solidFill>
@@ -7977,14 +7926,14 @@
       </p:sp>
       <p:sp>
         <p:nvSpPr>
-          <p:cNvPr id="1220" name="Canal detalhe ZAP VLI"/>
+          <p:cNvPr id="1219" name="Canal detalhe ZAP VLI"/>
           <p:cNvSpPr txBox="1"/>
           <p:nvPr/>
         </p:nvSpPr>
         <p:spPr>
           <a:xfrm>
-            <a:off x="2724912" y="6345936"/>
-            <a:ext cx="2103120" cy="310896"/>
+            <a:off x="2724912" y="6382512"/>
+            <a:ext cx="2103120" cy="292608"/>
           </a:xfrm>
           <a:prstGeom prst="rect">
             <a:avLst/>
@@ -7999,26 +7948,26 @@
           <a:p>
             <a:pPr algn="l"/>
             <a:r>
-              <a:rPr sz="750" b="0">
+              <a:rPr sz="900" b="0">
                 <a:solidFill>
                   <a:srgbClr val="6B7894"/>
                 </a:solidFill>
                 <a:latin typeface="Manrope"/>
               </a:rPr>
-              <a:t>3.516 recebidas · 1.985 leituras · 181 interações (9,1%)</a:t>
-            </a:r>
-          </a:p>
-        </p:txBody>
-      </p:sp>
-      <p:sp>
-        <p:nvSpPr>
-          <p:cNvPr id="1221" name="Canal INTRANET VLI@"/>
+              <a:t>3.516 recebidas · 181 interações (9,1%)</a:t>
+            </a:r>
+          </a:p>
+        </p:txBody>
+      </p:sp>
+      <p:sp>
+        <p:nvSpPr>
+          <p:cNvPr id="1220" name="Canal INTRANET VLI@"/>
           <p:cNvSpPr/>
           <p:nvPr/>
         </p:nvSpPr>
         <p:spPr>
           <a:xfrm>
-            <a:off x="4965192" y="5852160"/>
+            <a:off x="4965192" y="5870448"/>
             <a:ext cx="2258568" cy="822960"/>
           </a:xfrm>
           <a:prstGeom prst="roundRect">
@@ -8060,14 +8009,14 @@
       </p:sp>
       <p:sp>
         <p:nvSpPr>
-          <p:cNvPr id="1222" name="Canal rótulo INTRANET VLI@"/>
+          <p:cNvPr id="1221" name="Canal rótulo INTRANET VLI@"/>
           <p:cNvSpPr txBox="1"/>
           <p:nvPr/>
         </p:nvSpPr>
         <p:spPr>
           <a:xfrm>
-            <a:off x="5056631" y="5897880"/>
-            <a:ext cx="2103120" cy="128016"/>
+            <a:off x="5056631" y="5916168"/>
+            <a:ext cx="2103120" cy="137160"/>
           </a:xfrm>
           <a:prstGeom prst="rect">
             <a:avLst/>
@@ -8082,7 +8031,7 @@
           <a:p>
             <a:pPr algn="l"/>
             <a:r>
-              <a:rPr sz="750" b="1">
+              <a:rPr sz="850" b="1">
                 <a:solidFill>
                   <a:srgbClr val="43597E"/>
                 </a:solidFill>
@@ -8095,14 +8044,14 @@
       </p:sp>
       <p:sp>
         <p:nvSpPr>
-          <p:cNvPr id="1223" name="Canal KPI INTRANET VLI@"/>
+          <p:cNvPr id="1222" name="Canal KPI INTRANET VLI@"/>
           <p:cNvSpPr txBox="1"/>
           <p:nvPr/>
         </p:nvSpPr>
         <p:spPr>
           <a:xfrm>
-            <a:off x="5056631" y="6035040"/>
-            <a:ext cx="2103120" cy="274320"/>
+            <a:off x="5056631" y="6053327"/>
+            <a:ext cx="2103120" cy="292608"/>
           </a:xfrm>
           <a:prstGeom prst="rect">
             <a:avLst/>
@@ -8117,7 +8066,7 @@
           <a:p>
             <a:pPr algn="l"/>
             <a:r>
-              <a:rPr sz="1700" b="1">
+              <a:rPr sz="1800" b="1">
                 <a:solidFill>
                   <a:srgbClr val="142B52"/>
                 </a:solidFill>
@@ -8126,7 +8075,7 @@
               <a:t>114</a:t>
             </a:r>
             <a:r>
-              <a:rPr sz="850" b="0">
+              <a:rPr sz="950" b="0">
                 <a:solidFill>
                   <a:srgbClr val="6B7894"/>
                 </a:solidFill>
@@ -8139,14 +8088,14 @@
       </p:sp>
       <p:sp>
         <p:nvSpPr>
-          <p:cNvPr id="1224" name="Canal detalhe INTRANET VLI@"/>
+          <p:cNvPr id="1223" name="Canal detalhe INTRANET VLI@"/>
           <p:cNvSpPr txBox="1"/>
           <p:nvPr/>
         </p:nvSpPr>
         <p:spPr>
           <a:xfrm>
-            <a:off x="5056631" y="6345936"/>
-            <a:ext cx="2103120" cy="310896"/>
+            <a:off x="5056631" y="6382512"/>
+            <a:ext cx="2103120" cy="292608"/>
           </a:xfrm>
           <a:prstGeom prst="rect">
             <a:avLst/>
@@ -8161,26 +8110,26 @@
           <a:p>
             <a:pPr algn="l"/>
             <a:r>
-              <a:rPr sz="750" b="0">
+              <a:rPr sz="900" b="0">
                 <a:solidFill>
                   <a:srgbClr val="6B7894"/>
                 </a:solidFill>
                 <a:latin typeface="Manrope"/>
               </a:rPr>
-              <a:t>Matéria com ações educativas e dicas para o trânsito</a:t>
-            </a:r>
-          </a:p>
-        </p:txBody>
-      </p:sp>
-      <p:sp>
-        <p:nvSpPr>
-          <p:cNvPr id="1225" name="Leitura interna"/>
+              <a:t>matéria educativa sobre trânsito</a:t>
+            </a:r>
+          </a:p>
+        </p:txBody>
+      </p:sp>
+      <p:sp>
+        <p:nvSpPr>
+          <p:cNvPr id="1224" name="Leitura interna"/>
           <p:cNvSpPr/>
           <p:nvPr/>
         </p:nvSpPr>
         <p:spPr>
           <a:xfrm>
-            <a:off x="7296912" y="5852160"/>
+            <a:off x="7296912" y="5870448"/>
             <a:ext cx="4590288" cy="822960"/>
           </a:xfrm>
           <a:prstGeom prst="roundRect">
@@ -8220,13 +8169,13 @@
       </p:sp>
       <p:sp>
         <p:nvSpPr>
-          <p:cNvPr id="1226" name="Leitura interna texto"/>
+          <p:cNvPr id="1225" name="Leitura interna texto"/>
           <p:cNvSpPr txBox="1"/>
           <p:nvPr/>
         </p:nvSpPr>
         <p:spPr>
           <a:xfrm>
-            <a:off x="7406640" y="5897880"/>
+            <a:off x="7406640" y="5916168"/>
             <a:ext cx="4389120" cy="749808"/>
           </a:xfrm>
           <a:prstGeom prst="rect">
@@ -8242,11 +8191,11 @@
           <a:p>
             <a:pPr algn="l">
               <a:spcAft>
-                <a:spcPts val="200"/>
+                <a:spcPts val="300"/>
               </a:spcAft>
             </a:pPr>
             <a:r>
-              <a:rPr sz="800" b="1">
+              <a:rPr sz="1000" b="1">
                 <a:solidFill>
                   <a:srgbClr val="F37919"/>
                 </a:solidFill>
@@ -8255,23 +8204,23 @@
               <a:t>Leitura: </a:t>
             </a:r>
             <a:r>
-              <a:rPr sz="800" b="0">
+              <a:rPr sz="1000" b="0">
                 <a:solidFill>
                   <a:srgbClr val="142B52"/>
                 </a:solidFill>
                 <a:latin typeface="Manrope"/>
               </a:rPr>
-              <a:t>com o mesmo volume de envios da Virada MFA (4.046), a SNT teve 9,1% de interações no ZAP contra 24,6%.</a:t>
+              <a:t>ZAP teve 9,1% de interações, contra 24,6% da Virada MFA (mesmo volume).</a:t>
             </a:r>
           </a:p>
           <a:p>
             <a:pPr algn="l">
               <a:spcAft>
-                <a:spcPts val="200"/>
+                <a:spcPts val="300"/>
               </a:spcAft>
             </a:pPr>
             <a:r>
-              <a:rPr sz="800" b="1">
+              <a:rPr sz="1000" b="1">
                 <a:solidFill>
                   <a:srgbClr val="F37919"/>
                 </a:solidFill>
@@ -8280,26 +8229,26 @@
               <a:t>Oportunidade: </a:t>
             </a:r>
             <a:r>
-              <a:rPr sz="800" b="0">
+              <a:rPr sz="1000" b="0">
                 <a:solidFill>
                   <a:srgbClr val="142B52"/>
                 </a:solidFill>
                 <a:latin typeface="Manrope"/>
               </a:rPr>
-              <a:t>transformar a pauta em jornada contínua ao longo da semana, com histórias reais e depoimentos de empregados.</a:t>
-            </a:r>
-          </a:p>
-        </p:txBody>
-      </p:sp>
-      <p:sp>
-        <p:nvSpPr>
-          <p:cNvPr id="1227" name="Rodapé"/>
+              <a:t>jornada contínua na semana, com depoimentos de empregados.</a:t>
+            </a:r>
+          </a:p>
+        </p:txBody>
+      </p:sp>
+      <p:sp>
+        <p:nvSpPr>
+          <p:cNvPr id="1226" name="Rodapé"/>
           <p:cNvSpPr txBox="1"/>
           <p:nvPr/>
         </p:nvSpPr>
         <p:spPr>
           <a:xfrm>
-            <a:off x="301752" y="6702552"/>
+            <a:off x="301752" y="6720840"/>
             <a:ext cx="11585448" cy="128016"/>
           </a:xfrm>
           <a:prstGeom prst="rect">
@@ -8315,13 +8264,13 @@
           <a:p>
             <a:pPr algn="l"/>
             <a:r>
-              <a:rPr sz="700" b="0">
+              <a:rPr sz="800" b="0">
                 <a:solidFill>
                   <a:srgbClr val="6B7894"/>
                 </a:solidFill>
                 <a:latin typeface="Manrope"/>
               </a:rPr>
-              <a:t>Custo: orçado R$ 60 mil, realizado ~R$ 35 mil (−42%); última campanha: R$ 115 mil (−70%). Alcances de frentes diferentes não são somáveis. Fontes: ANR SNT e Relatório de Comunicação Interna, setembro.</a:t>
+              <a:t>Custo: orçado R$ 60 mil, realizado ~R$ 35 mil (−42%); última campanha R$ 115 mil (−70%). Alcances de frentes diferentes não são somáveis. Fontes: ANR SNT e Relatório de Comunicação Interna.</a:t>
             </a:r>
           </a:p>
         </p:txBody>

</xml_diff>